<commit_message>
Update deck v3: content fixes + paid CRM pricing model
- Pipeline slide now matches the real Ventas pipeline (7 stages).
- Automations: removed Señal/depósito card (→ Handoff a humano); Remarketing
  noted as acting on the Perdido stage.
- Captación: removed the "retorno por fuente" bullet.
- Estética niche: add "spa de uñas y cejas".
- Pricing: omnia CRM is now charged (one-time implementation + monthly),
  not free; cost/margin table expanded; new "Costos de comunicación" slide
  (WhatsApp license, email, AI tokens unlimited-vs-consumption).

Co-Authored-By: Claude Opus 4.8 <noreply@anthropic.com>
Claude-Session: https://claude.ai/code/session_01TgN5d424q32UXmoazQaikt
</commit_message>
<xml_diff>
--- a/presentacion/omnia-sistema-clinicas.pptx
+++ b/presentacion/omnia-sistema-clinicas.pptx
@@ -21,6 +21,7 @@
     <p:sldId id="269" r:id="rId20"/>
     <p:sldId id="270" r:id="rId21"/>
     <p:sldId id="271" r:id="rId22"/>
+    <p:sldId id="272" r:id="rId23"/>
   </p:sldIdLst>
   <p:sldSz cx="12191695" cy="6858000" type="screen4x3"/>
   <p:notesSz cx="6858000" cy="9144000"/>
@@ -3924,7 +3925,7 @@
                 </a:solidFill>
                 <a:latin typeface="Calibri"/>
               </a:rPr>
-              <a:t>•  Faciales, micropigmentación</a:t>
+              <a:t>•  Faciales, micropigmentación, spa de uñas y cejas</a:t>
             </a:r>
           </a:p>
           <a:p>
@@ -4276,7 +4277,7 @@
                 </a:solidFill>
                 <a:latin typeface="Calibri"/>
               </a:rPr>
-              <a:t>10 / 16</a:t>
+              <a:t>10 / 17</a:t>
             </a:r>
           </a:p>
         </p:txBody>
@@ -5219,7 +5220,7 @@
                 </a:solidFill>
                 <a:latin typeface="Calibri"/>
               </a:rPr>
-              <a:t>11 / 16</a:t>
+              <a:t>11 / 17</a:t>
             </a:r>
           </a:p>
         </p:txBody>
@@ -5934,7 +5935,7 @@
                 </a:solidFill>
                 <a:latin typeface="Calibri"/>
               </a:rPr>
-              <a:t>12 / 16</a:t>
+              <a:t>12 / 17</a:t>
             </a:r>
           </a:p>
         </p:txBody>
@@ -6327,7 +6328,7 @@
                 </a:solidFill>
                 <a:latin typeface="Calibri"/>
               </a:rPr>
-              <a:t>•  + Sistema omnia instalado</a:t>
+              <a:t>•  + Sistema omnia (impl. + mensual)</a:t>
             </a:r>
           </a:p>
         </p:txBody>
@@ -6541,7 +6542,7 @@
                 </a:solidFill>
                 <a:latin typeface="Calibri"/>
               </a:rPr>
-              <a:t>•  + Sistema omnia</a:t>
+              <a:t>•  + Sistema omnia (impl. + mensual)</a:t>
             </a:r>
           </a:p>
         </p:txBody>
@@ -6755,7 +6756,7 @@
                 </a:solidFill>
                 <a:latin typeface="Calibri"/>
               </a:rPr>
-              <a:t>•  + Sistema omnia</a:t>
+              <a:t>•  + Sistema omnia (impl. + mensual)</a:t>
             </a:r>
           </a:p>
         </p:txBody>
@@ -6969,7 +6970,7 @@
                 </a:solidFill>
                 <a:latin typeface="Calibri"/>
               </a:rPr>
-              <a:t>•  + Sistema omnia</a:t>
+              <a:t>•  + Sistema omnia (impl. + mensual)</a:t>
             </a:r>
           </a:p>
         </p:txBody>
@@ -6982,8 +6983,8 @@
         </p:nvSpPr>
         <p:spPr>
           <a:xfrm>
-            <a:off x="502920" y="5074920"/>
-            <a:ext cx="11155680" cy="566928"/>
+            <a:off x="502920" y="5029200"/>
+            <a:ext cx="11155680" cy="658368"/>
           </a:xfrm>
           <a:prstGeom prst="roundRect">
             <a:avLst/>
@@ -7026,8 +7027,8 @@
         </p:nvSpPr>
         <p:spPr>
           <a:xfrm>
-            <a:off x="685800" y="5138928"/>
-            <a:ext cx="10789920" cy="457200"/>
+            <a:off x="685800" y="5093208"/>
+            <a:ext cx="10789920" cy="548640"/>
           </a:xfrm>
           <a:prstGeom prst="rect">
             <a:avLst/>
@@ -7042,26 +7043,33 @@
           <a:p>
             <a:pPr algn="l">
               <a:spcAft>
-                <a:spcPts val="400"/>
-              </a:spcAft>
-            </a:pPr>
-            <a:r>
-              <a:rPr sz="1150" b="1">
+                <a:spcPts val="200"/>
+              </a:spcAft>
+            </a:pPr>
+            <a:r>
+              <a:rPr sz="1100" b="1">
                 <a:solidFill>
                   <a:srgbClr val="92400E"/>
                 </a:solidFill>
                 <a:latin typeface="Calibri"/>
               </a:rPr>
-              <a:t>Inversión en anuncios aparte (al medio): mínimo 300 €/campaña.   </a:t>
-            </a:r>
-            <a:r>
-              <a:rPr sz="1150" b="0">
+              <a:t>Sistema omnia = implementación única + mensualidad.  Aparte: inversión en ads (mín. 300 €/camp.) </a:t>
+            </a:r>
+          </a:p>
+          <a:p>
+            <a:pPr algn="l">
+              <a:spcAft>
+                <a:spcPts val="200"/>
+              </a:spcAft>
+            </a:pPr>
+            <a:r>
+              <a:rPr sz="1100" b="0">
                 <a:solidFill>
                   <a:srgbClr val="92400E"/>
                 </a:solidFill>
                 <a:latin typeface="Calibri"/>
               </a:rPr>
-              <a:t>Precio al cliente y setup del sistema: a definir por omnia (ver slide interna).</a:t>
+              <a:t>+ costos de comunicación (WhatsApp, email, IA) según consumo.  Precio final al cliente: a definir (ver slides internas).</a:t>
             </a:r>
           </a:p>
         </p:txBody>
@@ -7183,7 +7191,7 @@
                 </a:solidFill>
                 <a:latin typeface="Calibri"/>
               </a:rPr>
-              <a:t>13 / 16</a:t>
+              <a:t>13 / 17</a:t>
             </a:r>
           </a:p>
         </p:txBody>
@@ -7901,7 +7909,7 @@
                 </a:solidFill>
                 <a:latin typeface="Calibri"/>
               </a:rPr>
-              <a:t>14 / 16</a:t>
+              <a:t>14 / 17</a:t>
             </a:r>
           </a:p>
         </p:txBody>
@@ -8093,8 +8101,8 @@
         </p:nvSpPr>
         <p:spPr>
           <a:xfrm>
-            <a:off x="502920" y="2286000"/>
-            <a:ext cx="2377440" cy="457200"/>
+            <a:off x="502920" y="2240280"/>
+            <a:ext cx="2103120" cy="457200"/>
           </a:xfrm>
           <a:prstGeom prst="rect">
             <a:avLst/>
@@ -8137,8 +8145,8 @@
         </p:nvSpPr>
         <p:spPr>
           <a:xfrm>
-            <a:off x="576072" y="2286000"/>
-            <a:ext cx="2231136" cy="457200"/>
+            <a:off x="566928" y="2240280"/>
+            <a:ext cx="1975103" cy="457200"/>
           </a:xfrm>
           <a:prstGeom prst="rect">
             <a:avLst/>
@@ -8157,7 +8165,7 @@
               </a:spcAft>
             </a:pPr>
             <a:r>
-              <a:rPr sz="1050" b="1">
+              <a:rPr sz="950" b="1">
                 <a:solidFill>
                   <a:srgbClr val="FFFFFF"/>
                 </a:solidFill>
@@ -8176,8 +8184,8 @@
         </p:nvSpPr>
         <p:spPr>
           <a:xfrm>
-            <a:off x="2880360" y="2286000"/>
-            <a:ext cx="2377440" cy="457200"/>
+            <a:off x="2606039" y="2240280"/>
+            <a:ext cx="2011680" cy="457200"/>
           </a:xfrm>
           <a:prstGeom prst="rect">
             <a:avLst/>
@@ -8220,8 +8228,8 @@
         </p:nvSpPr>
         <p:spPr>
           <a:xfrm>
-            <a:off x="2953512" y="2286000"/>
-            <a:ext cx="2231136" cy="457200"/>
+            <a:off x="2670047" y="2240280"/>
+            <a:ext cx="1883664" cy="457200"/>
           </a:xfrm>
           <a:prstGeom prst="rect">
             <a:avLst/>
@@ -8240,7 +8248,7 @@
               </a:spcAft>
             </a:pPr>
             <a:r>
-              <a:rPr sz="1050" b="1">
+              <a:rPr sz="950" b="1">
                 <a:solidFill>
                   <a:srgbClr val="FFFFFF"/>
                 </a:solidFill>
@@ -8259,8 +8267,8 @@
         </p:nvSpPr>
         <p:spPr>
           <a:xfrm>
-            <a:off x="5257800" y="2286000"/>
-            <a:ext cx="2377440" cy="457200"/>
+            <a:off x="4617720" y="2240280"/>
+            <a:ext cx="1920240" cy="457200"/>
           </a:xfrm>
           <a:prstGeom prst="rect">
             <a:avLst/>
@@ -8303,8 +8311,8 @@
         </p:nvSpPr>
         <p:spPr>
           <a:xfrm>
-            <a:off x="5330952" y="2286000"/>
-            <a:ext cx="2231136" cy="457200"/>
+            <a:off x="4681728" y="2240280"/>
+            <a:ext cx="1792224" cy="457200"/>
           </a:xfrm>
           <a:prstGeom prst="rect">
             <a:avLst/>
@@ -8323,13 +8331,13 @@
               </a:spcAft>
             </a:pPr>
             <a:r>
-              <a:rPr sz="1050" b="1">
+              <a:rPr sz="950" b="1">
                 <a:solidFill>
                   <a:srgbClr val="FFFFFF"/>
                 </a:solidFill>
                 <a:latin typeface="Calibri"/>
               </a:rPr>
-              <a:t>Sistema omnia</a:t>
+              <a:t>Sistema omnia /mes</a:t>
             </a:r>
           </a:p>
         </p:txBody>
@@ -8342,8 +8350,8 @@
         </p:nvSpPr>
         <p:spPr>
           <a:xfrm>
-            <a:off x="7635240" y="2286000"/>
-            <a:ext cx="2011680" cy="457200"/>
+            <a:off x="6537960" y="2240280"/>
+            <a:ext cx="1828800" cy="457200"/>
           </a:xfrm>
           <a:prstGeom prst="rect">
             <a:avLst/>
@@ -8386,8 +8394,8 @@
         </p:nvSpPr>
         <p:spPr>
           <a:xfrm>
-            <a:off x="7708392" y="2286000"/>
-            <a:ext cx="1865376" cy="457200"/>
+            <a:off x="6601968" y="2240280"/>
+            <a:ext cx="1700784" cy="457200"/>
           </a:xfrm>
           <a:prstGeom prst="rect">
             <a:avLst/>
@@ -8406,13 +8414,13 @@
               </a:spcAft>
             </a:pPr>
             <a:r>
-              <a:rPr sz="1050" b="1">
+              <a:rPr sz="950" b="1">
                 <a:solidFill>
                   <a:srgbClr val="FFFFFF"/>
                 </a:solidFill>
                 <a:latin typeface="Calibri"/>
               </a:rPr>
-              <a:t>Precio cliente</a:t>
+              <a:t>Comunicación</a:t>
             </a:r>
           </a:p>
         </p:txBody>
@@ -8425,8 +8433,8 @@
         </p:nvSpPr>
         <p:spPr>
           <a:xfrm>
-            <a:off x="9646920" y="2286000"/>
-            <a:ext cx="2011680" cy="457200"/>
+            <a:off x="8366760" y="2240280"/>
+            <a:ext cx="1737360" cy="457200"/>
           </a:xfrm>
           <a:prstGeom prst="rect">
             <a:avLst/>
@@ -8469,8 +8477,8 @@
         </p:nvSpPr>
         <p:spPr>
           <a:xfrm>
-            <a:off x="9720072" y="2286000"/>
-            <a:ext cx="1865376" cy="457200"/>
+            <a:off x="8430768" y="2240280"/>
+            <a:ext cx="1609343" cy="457200"/>
           </a:xfrm>
           <a:prstGeom prst="rect">
             <a:avLst/>
@@ -8489,13 +8497,13 @@
               </a:spcAft>
             </a:pPr>
             <a:r>
-              <a:rPr sz="1050" b="1">
+              <a:rPr sz="950" b="1">
                 <a:solidFill>
                   <a:srgbClr val="FFFFFF"/>
                 </a:solidFill>
                 <a:latin typeface="Calibri"/>
               </a:rPr>
-              <a:t>Margen</a:t>
+              <a:t>Precio cliente</a:t>
             </a:r>
           </a:p>
         </p:txBody>
@@ -8508,8 +8516,91 @@
         </p:nvSpPr>
         <p:spPr>
           <a:xfrm>
-            <a:off x="502920" y="2743200"/>
-            <a:ext cx="2377440" cy="502920"/>
+            <a:off x="10104120" y="2240280"/>
+            <a:ext cx="1554480" cy="457200"/>
+          </a:xfrm>
+          <a:prstGeom prst="rect">
+            <a:avLst/>
+          </a:prstGeom>
+          <a:solidFill>
+            <a:srgbClr val="0B1F3A"/>
+          </a:solidFill>
+          <a:ln>
+            <a:noFill/>
+          </a:ln>
+          <a:effectLst/>
+        </p:spPr>
+        <p:style>
+          <a:lnRef idx="1">
+            <a:schemeClr val="accent1"/>
+          </a:lnRef>
+          <a:fillRef idx="3">
+            <a:schemeClr val="accent1"/>
+          </a:fillRef>
+          <a:effectRef idx="2">
+            <a:schemeClr val="accent1"/>
+          </a:effectRef>
+          <a:fontRef idx="minor">
+            <a:schemeClr val="lt1"/>
+          </a:fontRef>
+        </p:style>
+        <p:txBody>
+          <a:bodyPr rtlCol="0" anchor="ctr"/>
+          <a:lstStyle/>
+          <a:p>
+            <a:pPr algn="ctr"/>
+          </a:p>
+        </p:txBody>
+      </p:sp>
+      <p:sp>
+        <p:nvSpPr>
+          <p:cNvPr id="17" name="TextBox 16"/>
+          <p:cNvSpPr txBox="1"/>
+          <p:nvPr/>
+        </p:nvSpPr>
+        <p:spPr>
+          <a:xfrm>
+            <a:off x="10168128" y="2240280"/>
+            <a:ext cx="1426464" cy="457200"/>
+          </a:xfrm>
+          <a:prstGeom prst="rect">
+            <a:avLst/>
+          </a:prstGeom>
+          <a:noFill/>
+        </p:spPr>
+        <p:txBody>
+          <a:bodyPr wrap="square" anchor="ctr">
+            <a:spAutoFit/>
+          </a:bodyPr>
+          <a:lstStyle/>
+          <a:p>
+            <a:pPr algn="l">
+              <a:spcAft>
+                <a:spcPts val="400"/>
+              </a:spcAft>
+            </a:pPr>
+            <a:r>
+              <a:rPr sz="950" b="1">
+                <a:solidFill>
+                  <a:srgbClr val="FFFFFF"/>
+                </a:solidFill>
+                <a:latin typeface="Calibri"/>
+              </a:rPr>
+              <a:t>Margen</a:t>
+            </a:r>
+          </a:p>
+        </p:txBody>
+      </p:sp>
+      <p:sp>
+        <p:nvSpPr>
+          <p:cNvPr id="18" name="Rectangle 17"/>
+          <p:cNvSpPr/>
+          <p:nvPr/>
+        </p:nvSpPr>
+        <p:spPr>
+          <a:xfrm>
+            <a:off x="502920" y="2697480"/>
+            <a:ext cx="2103120" cy="502920"/>
           </a:xfrm>
           <a:prstGeom prst="rect">
             <a:avLst/>
@@ -8546,14 +8637,14 @@
       </p:sp>
       <p:sp>
         <p:nvSpPr>
-          <p:cNvPr id="17" name="TextBox 16"/>
-          <p:cNvSpPr txBox="1"/>
-          <p:nvPr/>
-        </p:nvSpPr>
-        <p:spPr>
-          <a:xfrm>
-            <a:off x="576072" y="2743200"/>
-            <a:ext cx="2231136" cy="502920"/>
+          <p:cNvPr id="19" name="TextBox 18"/>
+          <p:cNvSpPr txBox="1"/>
+          <p:nvPr/>
+        </p:nvSpPr>
+        <p:spPr>
+          <a:xfrm>
+            <a:off x="566928" y="2697480"/>
+            <a:ext cx="1975103" cy="502920"/>
           </a:xfrm>
           <a:prstGeom prst="rect">
             <a:avLst/>
@@ -8572,7 +8663,7 @@
               </a:spcAft>
             </a:pPr>
             <a:r>
-              <a:rPr sz="1050" b="1">
+              <a:rPr sz="950" b="1">
                 <a:solidFill>
                   <a:srgbClr val="0F172A"/>
                 </a:solidFill>
@@ -8585,14 +8676,14 @@
       </p:sp>
       <p:sp>
         <p:nvSpPr>
-          <p:cNvPr id="18" name="Rectangle 17"/>
+          <p:cNvPr id="20" name="Rectangle 19"/>
           <p:cNvSpPr/>
           <p:nvPr/>
         </p:nvSpPr>
         <p:spPr>
           <a:xfrm>
-            <a:off x="2880360" y="2743200"/>
-            <a:ext cx="2377440" cy="502920"/>
+            <a:off x="2606039" y="2697480"/>
+            <a:ext cx="2011680" cy="502920"/>
           </a:xfrm>
           <a:prstGeom prst="rect">
             <a:avLst/>
@@ -8629,14 +8720,14 @@
       </p:sp>
       <p:sp>
         <p:nvSpPr>
-          <p:cNvPr id="19" name="TextBox 18"/>
-          <p:cNvSpPr txBox="1"/>
-          <p:nvPr/>
-        </p:nvSpPr>
-        <p:spPr>
-          <a:xfrm>
-            <a:off x="2953512" y="2743200"/>
-            <a:ext cx="2231136" cy="502920"/>
+          <p:cNvPr id="21" name="TextBox 20"/>
+          <p:cNvSpPr txBox="1"/>
+          <p:nvPr/>
+        </p:nvSpPr>
+        <p:spPr>
+          <a:xfrm>
+            <a:off x="2670047" y="2697480"/>
+            <a:ext cx="1883664" cy="502920"/>
           </a:xfrm>
           <a:prstGeom prst="rect">
             <a:avLst/>
@@ -8655,7 +8746,7 @@
               </a:spcAft>
             </a:pPr>
             <a:r>
-              <a:rPr sz="1050" b="0">
+              <a:rPr sz="950" b="0">
                 <a:solidFill>
                   <a:srgbClr val="0F172A"/>
                 </a:solidFill>
@@ -8668,14 +8759,14 @@
       </p:sp>
       <p:sp>
         <p:nvSpPr>
-          <p:cNvPr id="20" name="Rectangle 19"/>
+          <p:cNvPr id="22" name="Rectangle 21"/>
           <p:cNvSpPr/>
           <p:nvPr/>
         </p:nvSpPr>
         <p:spPr>
           <a:xfrm>
-            <a:off x="5257800" y="2743200"/>
-            <a:ext cx="2377440" cy="502920"/>
+            <a:off x="4617720" y="2697480"/>
+            <a:ext cx="1920240" cy="502920"/>
           </a:xfrm>
           <a:prstGeom prst="rect">
             <a:avLst/>
@@ -8712,14 +8803,14 @@
       </p:sp>
       <p:sp>
         <p:nvSpPr>
-          <p:cNvPr id="21" name="TextBox 20"/>
-          <p:cNvSpPr txBox="1"/>
-          <p:nvPr/>
-        </p:nvSpPr>
-        <p:spPr>
-          <a:xfrm>
-            <a:off x="5330952" y="2743200"/>
-            <a:ext cx="2231136" cy="502920"/>
+          <p:cNvPr id="23" name="TextBox 22"/>
+          <p:cNvSpPr txBox="1"/>
+          <p:nvPr/>
+        </p:nvSpPr>
+        <p:spPr>
+          <a:xfrm>
+            <a:off x="4681728" y="2697480"/>
+            <a:ext cx="1792224" cy="502920"/>
           </a:xfrm>
           <a:prstGeom prst="rect">
             <a:avLst/>
@@ -8738,27 +8829,27 @@
               </a:spcAft>
             </a:pPr>
             <a:r>
-              <a:rPr sz="1050" b="0">
-                <a:solidFill>
-                  <a:srgbClr val="0F172A"/>
-                </a:solidFill>
-                <a:latin typeface="Calibri"/>
-              </a:rPr>
-              <a:t>setup + mes</a:t>
-            </a:r>
-          </a:p>
-        </p:txBody>
-      </p:sp>
-      <p:sp>
-        <p:nvSpPr>
-          <p:cNvPr id="22" name="Rectangle 21"/>
+              <a:rPr sz="950" b="0">
+                <a:solidFill>
+                  <a:srgbClr val="92400E"/>
+                </a:solidFill>
+                <a:latin typeface="Calibri"/>
+              </a:rPr>
+              <a:t>[definir]</a:t>
+            </a:r>
+          </a:p>
+        </p:txBody>
+      </p:sp>
+      <p:sp>
+        <p:nvSpPr>
+          <p:cNvPr id="24" name="Rectangle 23"/>
           <p:cNvSpPr/>
           <p:nvPr/>
         </p:nvSpPr>
         <p:spPr>
           <a:xfrm>
-            <a:off x="7635240" y="2743200"/>
-            <a:ext cx="2011680" cy="502920"/>
+            <a:off x="6537960" y="2697480"/>
+            <a:ext cx="1828800" cy="502920"/>
           </a:xfrm>
           <a:prstGeom prst="rect">
             <a:avLst/>
@@ -8795,14 +8886,14 @@
       </p:sp>
       <p:sp>
         <p:nvSpPr>
-          <p:cNvPr id="23" name="TextBox 22"/>
-          <p:cNvSpPr txBox="1"/>
-          <p:nvPr/>
-        </p:nvSpPr>
-        <p:spPr>
-          <a:xfrm>
-            <a:off x="7708392" y="2743200"/>
-            <a:ext cx="1865376" cy="502920"/>
+          <p:cNvPr id="25" name="TextBox 24"/>
+          <p:cNvSpPr txBox="1"/>
+          <p:nvPr/>
+        </p:nvSpPr>
+        <p:spPr>
+          <a:xfrm>
+            <a:off x="6601968" y="2697480"/>
+            <a:ext cx="1700784" cy="502920"/>
           </a:xfrm>
           <a:prstGeom prst="rect">
             <a:avLst/>
@@ -8821,27 +8912,27 @@
               </a:spcAft>
             </a:pPr>
             <a:r>
-              <a:rPr sz="1050" b="0">
-                <a:solidFill>
-                  <a:srgbClr val="92400E"/>
-                </a:solidFill>
-                <a:latin typeface="Calibri"/>
-              </a:rPr>
-              <a:t>[definir]</a:t>
-            </a:r>
-          </a:p>
-        </p:txBody>
-      </p:sp>
-      <p:sp>
-        <p:nvSpPr>
-          <p:cNvPr id="24" name="Rectangle 23"/>
+              <a:rPr sz="950" b="0">
+                <a:solidFill>
+                  <a:srgbClr val="0F172A"/>
+                </a:solidFill>
+                <a:latin typeface="Calibri"/>
+              </a:rPr>
+              <a:t>según consumo</a:t>
+            </a:r>
+          </a:p>
+        </p:txBody>
+      </p:sp>
+      <p:sp>
+        <p:nvSpPr>
+          <p:cNvPr id="26" name="Rectangle 25"/>
           <p:cNvSpPr/>
           <p:nvPr/>
         </p:nvSpPr>
         <p:spPr>
           <a:xfrm>
-            <a:off x="9646920" y="2743200"/>
-            <a:ext cx="2011680" cy="502920"/>
+            <a:off x="8366760" y="2697480"/>
+            <a:ext cx="1737360" cy="502920"/>
           </a:xfrm>
           <a:prstGeom prst="rect">
             <a:avLst/>
@@ -8878,14 +8969,14 @@
       </p:sp>
       <p:sp>
         <p:nvSpPr>
-          <p:cNvPr id="25" name="TextBox 24"/>
-          <p:cNvSpPr txBox="1"/>
-          <p:nvPr/>
-        </p:nvSpPr>
-        <p:spPr>
-          <a:xfrm>
-            <a:off x="9720072" y="2743200"/>
-            <a:ext cx="1865376" cy="502920"/>
+          <p:cNvPr id="27" name="TextBox 26"/>
+          <p:cNvSpPr txBox="1"/>
+          <p:nvPr/>
+        </p:nvSpPr>
+        <p:spPr>
+          <a:xfrm>
+            <a:off x="8430768" y="2697480"/>
+            <a:ext cx="1609343" cy="502920"/>
           </a:xfrm>
           <a:prstGeom prst="rect">
             <a:avLst/>
@@ -8904,7 +8995,7 @@
               </a:spcAft>
             </a:pPr>
             <a:r>
-              <a:rPr sz="1050" b="0">
+              <a:rPr sz="950" b="0">
                 <a:solidFill>
                   <a:srgbClr val="92400E"/>
                 </a:solidFill>
@@ -8917,14 +9008,97 @@
       </p:sp>
       <p:sp>
         <p:nvSpPr>
-          <p:cNvPr id="26" name="Rectangle 25"/>
+          <p:cNvPr id="28" name="Rectangle 27"/>
           <p:cNvSpPr/>
           <p:nvPr/>
         </p:nvSpPr>
         <p:spPr>
           <a:xfrm>
-            <a:off x="502920" y="3246120"/>
-            <a:ext cx="2377440" cy="502920"/>
+            <a:off x="10104120" y="2697480"/>
+            <a:ext cx="1554480" cy="502920"/>
+          </a:xfrm>
+          <a:prstGeom prst="rect">
+            <a:avLst/>
+          </a:prstGeom>
+          <a:solidFill>
+            <a:srgbClr val="FFFFFF"/>
+          </a:solidFill>
+          <a:ln>
+            <a:noFill/>
+          </a:ln>
+          <a:effectLst/>
+        </p:spPr>
+        <p:style>
+          <a:lnRef idx="1">
+            <a:schemeClr val="accent1"/>
+          </a:lnRef>
+          <a:fillRef idx="3">
+            <a:schemeClr val="accent1"/>
+          </a:fillRef>
+          <a:effectRef idx="2">
+            <a:schemeClr val="accent1"/>
+          </a:effectRef>
+          <a:fontRef idx="minor">
+            <a:schemeClr val="lt1"/>
+          </a:fontRef>
+        </p:style>
+        <p:txBody>
+          <a:bodyPr rtlCol="0" anchor="ctr"/>
+          <a:lstStyle/>
+          <a:p>
+            <a:pPr algn="ctr"/>
+          </a:p>
+        </p:txBody>
+      </p:sp>
+      <p:sp>
+        <p:nvSpPr>
+          <p:cNvPr id="29" name="TextBox 28"/>
+          <p:cNvSpPr txBox="1"/>
+          <p:nvPr/>
+        </p:nvSpPr>
+        <p:spPr>
+          <a:xfrm>
+            <a:off x="10168128" y="2697480"/>
+            <a:ext cx="1426464" cy="502920"/>
+          </a:xfrm>
+          <a:prstGeom prst="rect">
+            <a:avLst/>
+          </a:prstGeom>
+          <a:noFill/>
+        </p:spPr>
+        <p:txBody>
+          <a:bodyPr wrap="square" anchor="ctr">
+            <a:spAutoFit/>
+          </a:bodyPr>
+          <a:lstStyle/>
+          <a:p>
+            <a:pPr algn="l">
+              <a:spcAft>
+                <a:spcPts val="400"/>
+              </a:spcAft>
+            </a:pPr>
+            <a:r>
+              <a:rPr sz="950" b="0">
+                <a:solidFill>
+                  <a:srgbClr val="92400E"/>
+                </a:solidFill>
+                <a:latin typeface="Calibri"/>
+              </a:rPr>
+              <a:t>[definir]</a:t>
+            </a:r>
+          </a:p>
+        </p:txBody>
+      </p:sp>
+      <p:sp>
+        <p:nvSpPr>
+          <p:cNvPr id="30" name="Rectangle 29"/>
+          <p:cNvSpPr/>
+          <p:nvPr/>
+        </p:nvSpPr>
+        <p:spPr>
+          <a:xfrm>
+            <a:off x="502920" y="3200400"/>
+            <a:ext cx="2103120" cy="502920"/>
           </a:xfrm>
           <a:prstGeom prst="rect">
             <a:avLst/>
@@ -8961,14 +9135,14 @@
       </p:sp>
       <p:sp>
         <p:nvSpPr>
-          <p:cNvPr id="27" name="TextBox 26"/>
-          <p:cNvSpPr txBox="1"/>
-          <p:nvPr/>
-        </p:nvSpPr>
-        <p:spPr>
-          <a:xfrm>
-            <a:off x="576072" y="3246120"/>
-            <a:ext cx="2231136" cy="502920"/>
+          <p:cNvPr id="31" name="TextBox 30"/>
+          <p:cNvSpPr txBox="1"/>
+          <p:nvPr/>
+        </p:nvSpPr>
+        <p:spPr>
+          <a:xfrm>
+            <a:off x="566928" y="3200400"/>
+            <a:ext cx="1975103" cy="502920"/>
           </a:xfrm>
           <a:prstGeom prst="rect">
             <a:avLst/>
@@ -8987,7 +9161,7 @@
               </a:spcAft>
             </a:pPr>
             <a:r>
-              <a:rPr sz="1050" b="1">
+              <a:rPr sz="950" b="1">
                 <a:solidFill>
                   <a:srgbClr val="0F172A"/>
                 </a:solidFill>
@@ -9000,14 +9174,14 @@
       </p:sp>
       <p:sp>
         <p:nvSpPr>
-          <p:cNvPr id="28" name="Rectangle 27"/>
+          <p:cNvPr id="32" name="Rectangle 31"/>
           <p:cNvSpPr/>
           <p:nvPr/>
         </p:nvSpPr>
         <p:spPr>
           <a:xfrm>
-            <a:off x="2880360" y="3246120"/>
-            <a:ext cx="2377440" cy="502920"/>
+            <a:off x="2606039" y="3200400"/>
+            <a:ext cx="2011680" cy="502920"/>
           </a:xfrm>
           <a:prstGeom prst="rect">
             <a:avLst/>
@@ -9044,14 +9218,14 @@
       </p:sp>
       <p:sp>
         <p:nvSpPr>
-          <p:cNvPr id="29" name="TextBox 28"/>
-          <p:cNvSpPr txBox="1"/>
-          <p:nvPr/>
-        </p:nvSpPr>
-        <p:spPr>
-          <a:xfrm>
-            <a:off x="2953512" y="3246120"/>
-            <a:ext cx="2231136" cy="502920"/>
+          <p:cNvPr id="33" name="TextBox 32"/>
+          <p:cNvSpPr txBox="1"/>
+          <p:nvPr/>
+        </p:nvSpPr>
+        <p:spPr>
+          <a:xfrm>
+            <a:off x="2670047" y="3200400"/>
+            <a:ext cx="1883664" cy="502920"/>
           </a:xfrm>
           <a:prstGeom prst="rect">
             <a:avLst/>
@@ -9070,7 +9244,7 @@
               </a:spcAft>
             </a:pPr>
             <a:r>
-              <a:rPr sz="1050" b="0">
+              <a:rPr sz="950" b="0">
                 <a:solidFill>
                   <a:srgbClr val="0F172A"/>
                 </a:solidFill>
@@ -9083,14 +9257,14 @@
       </p:sp>
       <p:sp>
         <p:nvSpPr>
-          <p:cNvPr id="30" name="Rectangle 29"/>
+          <p:cNvPr id="34" name="Rectangle 33"/>
           <p:cNvSpPr/>
           <p:nvPr/>
         </p:nvSpPr>
         <p:spPr>
           <a:xfrm>
-            <a:off x="5257800" y="3246120"/>
-            <a:ext cx="2377440" cy="502920"/>
+            <a:off x="4617720" y="3200400"/>
+            <a:ext cx="1920240" cy="502920"/>
           </a:xfrm>
           <a:prstGeom prst="rect">
             <a:avLst/>
@@ -9127,14 +9301,14 @@
       </p:sp>
       <p:sp>
         <p:nvSpPr>
-          <p:cNvPr id="31" name="TextBox 30"/>
-          <p:cNvSpPr txBox="1"/>
-          <p:nvPr/>
-        </p:nvSpPr>
-        <p:spPr>
-          <a:xfrm>
-            <a:off x="5330952" y="3246120"/>
-            <a:ext cx="2231136" cy="502920"/>
+          <p:cNvPr id="35" name="TextBox 34"/>
+          <p:cNvSpPr txBox="1"/>
+          <p:nvPr/>
+        </p:nvSpPr>
+        <p:spPr>
+          <a:xfrm>
+            <a:off x="4681728" y="3200400"/>
+            <a:ext cx="1792224" cy="502920"/>
           </a:xfrm>
           <a:prstGeom prst="rect">
             <a:avLst/>
@@ -9153,27 +9327,27 @@
               </a:spcAft>
             </a:pPr>
             <a:r>
-              <a:rPr sz="1050" b="0">
-                <a:solidFill>
-                  <a:srgbClr val="0F172A"/>
-                </a:solidFill>
-                <a:latin typeface="Calibri"/>
-              </a:rPr>
-              <a:t>incluido</a:t>
-            </a:r>
-          </a:p>
-        </p:txBody>
-      </p:sp>
-      <p:sp>
-        <p:nvSpPr>
-          <p:cNvPr id="32" name="Rectangle 31"/>
+              <a:rPr sz="950" b="0">
+                <a:solidFill>
+                  <a:srgbClr val="92400E"/>
+                </a:solidFill>
+                <a:latin typeface="Calibri"/>
+              </a:rPr>
+              <a:t>[definir]</a:t>
+            </a:r>
+          </a:p>
+        </p:txBody>
+      </p:sp>
+      <p:sp>
+        <p:nvSpPr>
+          <p:cNvPr id="36" name="Rectangle 35"/>
           <p:cNvSpPr/>
           <p:nvPr/>
         </p:nvSpPr>
         <p:spPr>
           <a:xfrm>
-            <a:off x="7635240" y="3246120"/>
-            <a:ext cx="2011680" cy="502920"/>
+            <a:off x="6537960" y="3200400"/>
+            <a:ext cx="1828800" cy="502920"/>
           </a:xfrm>
           <a:prstGeom prst="rect">
             <a:avLst/>
@@ -9210,14 +9384,14 @@
       </p:sp>
       <p:sp>
         <p:nvSpPr>
-          <p:cNvPr id="33" name="TextBox 32"/>
-          <p:cNvSpPr txBox="1"/>
-          <p:nvPr/>
-        </p:nvSpPr>
-        <p:spPr>
-          <a:xfrm>
-            <a:off x="7708392" y="3246120"/>
-            <a:ext cx="1865376" cy="502920"/>
+          <p:cNvPr id="37" name="TextBox 36"/>
+          <p:cNvSpPr txBox="1"/>
+          <p:nvPr/>
+        </p:nvSpPr>
+        <p:spPr>
+          <a:xfrm>
+            <a:off x="6601968" y="3200400"/>
+            <a:ext cx="1700784" cy="502920"/>
           </a:xfrm>
           <a:prstGeom prst="rect">
             <a:avLst/>
@@ -9236,27 +9410,27 @@
               </a:spcAft>
             </a:pPr>
             <a:r>
-              <a:rPr sz="1050" b="0">
-                <a:solidFill>
-                  <a:srgbClr val="92400E"/>
-                </a:solidFill>
-                <a:latin typeface="Calibri"/>
-              </a:rPr>
-              <a:t>[definir]</a:t>
-            </a:r>
-          </a:p>
-        </p:txBody>
-      </p:sp>
-      <p:sp>
-        <p:nvSpPr>
-          <p:cNvPr id="34" name="Rectangle 33"/>
+              <a:rPr sz="950" b="0">
+                <a:solidFill>
+                  <a:srgbClr val="0F172A"/>
+                </a:solidFill>
+                <a:latin typeface="Calibri"/>
+              </a:rPr>
+              <a:t>según consumo</a:t>
+            </a:r>
+          </a:p>
+        </p:txBody>
+      </p:sp>
+      <p:sp>
+        <p:nvSpPr>
+          <p:cNvPr id="38" name="Rectangle 37"/>
           <p:cNvSpPr/>
           <p:nvPr/>
         </p:nvSpPr>
         <p:spPr>
           <a:xfrm>
-            <a:off x="9646920" y="3246120"/>
-            <a:ext cx="2011680" cy="502920"/>
+            <a:off x="8366760" y="3200400"/>
+            <a:ext cx="1737360" cy="502920"/>
           </a:xfrm>
           <a:prstGeom prst="rect">
             <a:avLst/>
@@ -9293,14 +9467,14 @@
       </p:sp>
       <p:sp>
         <p:nvSpPr>
-          <p:cNvPr id="35" name="TextBox 34"/>
-          <p:cNvSpPr txBox="1"/>
-          <p:nvPr/>
-        </p:nvSpPr>
-        <p:spPr>
-          <a:xfrm>
-            <a:off x="9720072" y="3246120"/>
-            <a:ext cx="1865376" cy="502920"/>
+          <p:cNvPr id="39" name="TextBox 38"/>
+          <p:cNvSpPr txBox="1"/>
+          <p:nvPr/>
+        </p:nvSpPr>
+        <p:spPr>
+          <a:xfrm>
+            <a:off x="8430768" y="3200400"/>
+            <a:ext cx="1609343" cy="502920"/>
           </a:xfrm>
           <a:prstGeom prst="rect">
             <a:avLst/>
@@ -9319,7 +9493,7 @@
               </a:spcAft>
             </a:pPr>
             <a:r>
-              <a:rPr sz="1050" b="0">
+              <a:rPr sz="950" b="0">
                 <a:solidFill>
                   <a:srgbClr val="92400E"/>
                 </a:solidFill>
@@ -9332,14 +9506,97 @@
       </p:sp>
       <p:sp>
         <p:nvSpPr>
-          <p:cNvPr id="36" name="Rectangle 35"/>
+          <p:cNvPr id="40" name="Rectangle 39"/>
           <p:cNvSpPr/>
           <p:nvPr/>
         </p:nvSpPr>
         <p:spPr>
           <a:xfrm>
-            <a:off x="502920" y="3749039"/>
-            <a:ext cx="2377440" cy="502920"/>
+            <a:off x="10104120" y="3200400"/>
+            <a:ext cx="1554480" cy="502920"/>
+          </a:xfrm>
+          <a:prstGeom prst="rect">
+            <a:avLst/>
+          </a:prstGeom>
+          <a:solidFill>
+            <a:srgbClr val="F1F5F9"/>
+          </a:solidFill>
+          <a:ln>
+            <a:noFill/>
+          </a:ln>
+          <a:effectLst/>
+        </p:spPr>
+        <p:style>
+          <a:lnRef idx="1">
+            <a:schemeClr val="accent1"/>
+          </a:lnRef>
+          <a:fillRef idx="3">
+            <a:schemeClr val="accent1"/>
+          </a:fillRef>
+          <a:effectRef idx="2">
+            <a:schemeClr val="accent1"/>
+          </a:effectRef>
+          <a:fontRef idx="minor">
+            <a:schemeClr val="lt1"/>
+          </a:fontRef>
+        </p:style>
+        <p:txBody>
+          <a:bodyPr rtlCol="0" anchor="ctr"/>
+          <a:lstStyle/>
+          <a:p>
+            <a:pPr algn="ctr"/>
+          </a:p>
+        </p:txBody>
+      </p:sp>
+      <p:sp>
+        <p:nvSpPr>
+          <p:cNvPr id="41" name="TextBox 40"/>
+          <p:cNvSpPr txBox="1"/>
+          <p:nvPr/>
+        </p:nvSpPr>
+        <p:spPr>
+          <a:xfrm>
+            <a:off x="10168128" y="3200400"/>
+            <a:ext cx="1426464" cy="502920"/>
+          </a:xfrm>
+          <a:prstGeom prst="rect">
+            <a:avLst/>
+          </a:prstGeom>
+          <a:noFill/>
+        </p:spPr>
+        <p:txBody>
+          <a:bodyPr wrap="square" anchor="ctr">
+            <a:spAutoFit/>
+          </a:bodyPr>
+          <a:lstStyle/>
+          <a:p>
+            <a:pPr algn="l">
+              <a:spcAft>
+                <a:spcPts val="400"/>
+              </a:spcAft>
+            </a:pPr>
+            <a:r>
+              <a:rPr sz="950" b="0">
+                <a:solidFill>
+                  <a:srgbClr val="92400E"/>
+                </a:solidFill>
+                <a:latin typeface="Calibri"/>
+              </a:rPr>
+              <a:t>[definir]</a:t>
+            </a:r>
+          </a:p>
+        </p:txBody>
+      </p:sp>
+      <p:sp>
+        <p:nvSpPr>
+          <p:cNvPr id="42" name="Rectangle 41"/>
+          <p:cNvSpPr/>
+          <p:nvPr/>
+        </p:nvSpPr>
+        <p:spPr>
+          <a:xfrm>
+            <a:off x="502920" y="3703320"/>
+            <a:ext cx="2103120" cy="502920"/>
           </a:xfrm>
           <a:prstGeom prst="rect">
             <a:avLst/>
@@ -9376,14 +9633,14 @@
       </p:sp>
       <p:sp>
         <p:nvSpPr>
-          <p:cNvPr id="37" name="TextBox 36"/>
-          <p:cNvSpPr txBox="1"/>
-          <p:nvPr/>
-        </p:nvSpPr>
-        <p:spPr>
-          <a:xfrm>
-            <a:off x="576072" y="3749039"/>
-            <a:ext cx="2231136" cy="502920"/>
+          <p:cNvPr id="43" name="TextBox 42"/>
+          <p:cNvSpPr txBox="1"/>
+          <p:nvPr/>
+        </p:nvSpPr>
+        <p:spPr>
+          <a:xfrm>
+            <a:off x="566928" y="3703320"/>
+            <a:ext cx="1975103" cy="502920"/>
           </a:xfrm>
           <a:prstGeom prst="rect">
             <a:avLst/>
@@ -9402,7 +9659,7 @@
               </a:spcAft>
             </a:pPr>
             <a:r>
-              <a:rPr sz="1050" b="1">
+              <a:rPr sz="950" b="1">
                 <a:solidFill>
                   <a:srgbClr val="0F172A"/>
                 </a:solidFill>
@@ -9415,14 +9672,14 @@
       </p:sp>
       <p:sp>
         <p:nvSpPr>
-          <p:cNvPr id="38" name="Rectangle 37"/>
+          <p:cNvPr id="44" name="Rectangle 43"/>
           <p:cNvSpPr/>
           <p:nvPr/>
         </p:nvSpPr>
         <p:spPr>
           <a:xfrm>
-            <a:off x="2880360" y="3749039"/>
-            <a:ext cx="2377440" cy="502920"/>
+            <a:off x="2606039" y="3703320"/>
+            <a:ext cx="2011680" cy="502920"/>
           </a:xfrm>
           <a:prstGeom prst="rect">
             <a:avLst/>
@@ -9459,14 +9716,14 @@
       </p:sp>
       <p:sp>
         <p:nvSpPr>
-          <p:cNvPr id="39" name="TextBox 38"/>
-          <p:cNvSpPr txBox="1"/>
-          <p:nvPr/>
-        </p:nvSpPr>
-        <p:spPr>
-          <a:xfrm>
-            <a:off x="2953512" y="3749039"/>
-            <a:ext cx="2231136" cy="502920"/>
+          <p:cNvPr id="45" name="TextBox 44"/>
+          <p:cNvSpPr txBox="1"/>
+          <p:nvPr/>
+        </p:nvSpPr>
+        <p:spPr>
+          <a:xfrm>
+            <a:off x="2670047" y="3703320"/>
+            <a:ext cx="1883664" cy="502920"/>
           </a:xfrm>
           <a:prstGeom prst="rect">
             <a:avLst/>
@@ -9485,7 +9742,7 @@
               </a:spcAft>
             </a:pPr>
             <a:r>
-              <a:rPr sz="1050" b="0">
+              <a:rPr sz="950" b="0">
                 <a:solidFill>
                   <a:srgbClr val="0F172A"/>
                 </a:solidFill>
@@ -9498,14 +9755,14 @@
       </p:sp>
       <p:sp>
         <p:nvSpPr>
-          <p:cNvPr id="40" name="Rectangle 39"/>
+          <p:cNvPr id="46" name="Rectangle 45"/>
           <p:cNvSpPr/>
           <p:nvPr/>
         </p:nvSpPr>
         <p:spPr>
           <a:xfrm>
-            <a:off x="5257800" y="3749039"/>
-            <a:ext cx="2377440" cy="502920"/>
+            <a:off x="4617720" y="3703320"/>
+            <a:ext cx="1920240" cy="502920"/>
           </a:xfrm>
           <a:prstGeom prst="rect">
             <a:avLst/>
@@ -9542,14 +9799,14 @@
       </p:sp>
       <p:sp>
         <p:nvSpPr>
-          <p:cNvPr id="41" name="TextBox 40"/>
-          <p:cNvSpPr txBox="1"/>
-          <p:nvPr/>
-        </p:nvSpPr>
-        <p:spPr>
-          <a:xfrm>
-            <a:off x="5330952" y="3749039"/>
-            <a:ext cx="2231136" cy="502920"/>
+          <p:cNvPr id="47" name="TextBox 46"/>
+          <p:cNvSpPr txBox="1"/>
+          <p:nvPr/>
+        </p:nvSpPr>
+        <p:spPr>
+          <a:xfrm>
+            <a:off x="4681728" y="3703320"/>
+            <a:ext cx="1792224" cy="502920"/>
           </a:xfrm>
           <a:prstGeom prst="rect">
             <a:avLst/>
@@ -9568,27 +9825,27 @@
               </a:spcAft>
             </a:pPr>
             <a:r>
-              <a:rPr sz="1050" b="0">
-                <a:solidFill>
-                  <a:srgbClr val="0F172A"/>
-                </a:solidFill>
-                <a:latin typeface="Calibri"/>
-              </a:rPr>
-              <a:t>incluido</a:t>
-            </a:r>
-          </a:p>
-        </p:txBody>
-      </p:sp>
-      <p:sp>
-        <p:nvSpPr>
-          <p:cNvPr id="42" name="Rectangle 41"/>
+              <a:rPr sz="950" b="0">
+                <a:solidFill>
+                  <a:srgbClr val="92400E"/>
+                </a:solidFill>
+                <a:latin typeface="Calibri"/>
+              </a:rPr>
+              <a:t>[definir]</a:t>
+            </a:r>
+          </a:p>
+        </p:txBody>
+      </p:sp>
+      <p:sp>
+        <p:nvSpPr>
+          <p:cNvPr id="48" name="Rectangle 47"/>
           <p:cNvSpPr/>
           <p:nvPr/>
         </p:nvSpPr>
         <p:spPr>
           <a:xfrm>
-            <a:off x="7635240" y="3749039"/>
-            <a:ext cx="2011680" cy="502920"/>
+            <a:off x="6537960" y="3703320"/>
+            <a:ext cx="1828800" cy="502920"/>
           </a:xfrm>
           <a:prstGeom prst="rect">
             <a:avLst/>
@@ -9625,14 +9882,14 @@
       </p:sp>
       <p:sp>
         <p:nvSpPr>
-          <p:cNvPr id="43" name="TextBox 42"/>
-          <p:cNvSpPr txBox="1"/>
-          <p:nvPr/>
-        </p:nvSpPr>
-        <p:spPr>
-          <a:xfrm>
-            <a:off x="7708392" y="3749039"/>
-            <a:ext cx="1865376" cy="502920"/>
+          <p:cNvPr id="49" name="TextBox 48"/>
+          <p:cNvSpPr txBox="1"/>
+          <p:nvPr/>
+        </p:nvSpPr>
+        <p:spPr>
+          <a:xfrm>
+            <a:off x="6601968" y="3703320"/>
+            <a:ext cx="1700784" cy="502920"/>
           </a:xfrm>
           <a:prstGeom prst="rect">
             <a:avLst/>
@@ -9651,27 +9908,27 @@
               </a:spcAft>
             </a:pPr>
             <a:r>
-              <a:rPr sz="1050" b="0">
-                <a:solidFill>
-                  <a:srgbClr val="92400E"/>
-                </a:solidFill>
-                <a:latin typeface="Calibri"/>
-              </a:rPr>
-              <a:t>[definir]</a:t>
-            </a:r>
-          </a:p>
-        </p:txBody>
-      </p:sp>
-      <p:sp>
-        <p:nvSpPr>
-          <p:cNvPr id="44" name="Rectangle 43"/>
+              <a:rPr sz="950" b="0">
+                <a:solidFill>
+                  <a:srgbClr val="0F172A"/>
+                </a:solidFill>
+                <a:latin typeface="Calibri"/>
+              </a:rPr>
+              <a:t>según consumo</a:t>
+            </a:r>
+          </a:p>
+        </p:txBody>
+      </p:sp>
+      <p:sp>
+        <p:nvSpPr>
+          <p:cNvPr id="50" name="Rectangle 49"/>
           <p:cNvSpPr/>
           <p:nvPr/>
         </p:nvSpPr>
         <p:spPr>
           <a:xfrm>
-            <a:off x="9646920" y="3749039"/>
-            <a:ext cx="2011680" cy="502920"/>
+            <a:off x="8366760" y="3703320"/>
+            <a:ext cx="1737360" cy="502920"/>
           </a:xfrm>
           <a:prstGeom prst="rect">
             <a:avLst/>
@@ -9708,14 +9965,14 @@
       </p:sp>
       <p:sp>
         <p:nvSpPr>
-          <p:cNvPr id="45" name="TextBox 44"/>
-          <p:cNvSpPr txBox="1"/>
-          <p:nvPr/>
-        </p:nvSpPr>
-        <p:spPr>
-          <a:xfrm>
-            <a:off x="9720072" y="3749039"/>
-            <a:ext cx="1865376" cy="502920"/>
+          <p:cNvPr id="51" name="TextBox 50"/>
+          <p:cNvSpPr txBox="1"/>
+          <p:nvPr/>
+        </p:nvSpPr>
+        <p:spPr>
+          <a:xfrm>
+            <a:off x="8430768" y="3703320"/>
+            <a:ext cx="1609343" cy="502920"/>
           </a:xfrm>
           <a:prstGeom prst="rect">
             <a:avLst/>
@@ -9734,7 +9991,7 @@
               </a:spcAft>
             </a:pPr>
             <a:r>
-              <a:rPr sz="1050" b="0">
+              <a:rPr sz="950" b="0">
                 <a:solidFill>
                   <a:srgbClr val="92400E"/>
                 </a:solidFill>
@@ -9747,14 +10004,97 @@
       </p:sp>
       <p:sp>
         <p:nvSpPr>
-          <p:cNvPr id="46" name="Rectangle 45"/>
+          <p:cNvPr id="52" name="Rectangle 51"/>
           <p:cNvSpPr/>
           <p:nvPr/>
         </p:nvSpPr>
         <p:spPr>
           <a:xfrm>
-            <a:off x="502920" y="4251960"/>
-            <a:ext cx="2377440" cy="502920"/>
+            <a:off x="10104120" y="3703320"/>
+            <a:ext cx="1554480" cy="502920"/>
+          </a:xfrm>
+          <a:prstGeom prst="rect">
+            <a:avLst/>
+          </a:prstGeom>
+          <a:solidFill>
+            <a:srgbClr val="FFFFFF"/>
+          </a:solidFill>
+          <a:ln>
+            <a:noFill/>
+          </a:ln>
+          <a:effectLst/>
+        </p:spPr>
+        <p:style>
+          <a:lnRef idx="1">
+            <a:schemeClr val="accent1"/>
+          </a:lnRef>
+          <a:fillRef idx="3">
+            <a:schemeClr val="accent1"/>
+          </a:fillRef>
+          <a:effectRef idx="2">
+            <a:schemeClr val="accent1"/>
+          </a:effectRef>
+          <a:fontRef idx="minor">
+            <a:schemeClr val="lt1"/>
+          </a:fontRef>
+        </p:style>
+        <p:txBody>
+          <a:bodyPr rtlCol="0" anchor="ctr"/>
+          <a:lstStyle/>
+          <a:p>
+            <a:pPr algn="ctr"/>
+          </a:p>
+        </p:txBody>
+      </p:sp>
+      <p:sp>
+        <p:nvSpPr>
+          <p:cNvPr id="53" name="TextBox 52"/>
+          <p:cNvSpPr txBox="1"/>
+          <p:nvPr/>
+        </p:nvSpPr>
+        <p:spPr>
+          <a:xfrm>
+            <a:off x="10168128" y="3703320"/>
+            <a:ext cx="1426464" cy="502920"/>
+          </a:xfrm>
+          <a:prstGeom prst="rect">
+            <a:avLst/>
+          </a:prstGeom>
+          <a:noFill/>
+        </p:spPr>
+        <p:txBody>
+          <a:bodyPr wrap="square" anchor="ctr">
+            <a:spAutoFit/>
+          </a:bodyPr>
+          <a:lstStyle/>
+          <a:p>
+            <a:pPr algn="l">
+              <a:spcAft>
+                <a:spcPts val="400"/>
+              </a:spcAft>
+            </a:pPr>
+            <a:r>
+              <a:rPr sz="950" b="0">
+                <a:solidFill>
+                  <a:srgbClr val="92400E"/>
+                </a:solidFill>
+                <a:latin typeface="Calibri"/>
+              </a:rPr>
+              <a:t>[definir]</a:t>
+            </a:r>
+          </a:p>
+        </p:txBody>
+      </p:sp>
+      <p:sp>
+        <p:nvSpPr>
+          <p:cNvPr id="54" name="Rectangle 53"/>
+          <p:cNvSpPr/>
+          <p:nvPr/>
+        </p:nvSpPr>
+        <p:spPr>
+          <a:xfrm>
+            <a:off x="502920" y="4206240"/>
+            <a:ext cx="2103120" cy="502920"/>
           </a:xfrm>
           <a:prstGeom prst="rect">
             <a:avLst/>
@@ -9791,14 +10131,14 @@
       </p:sp>
       <p:sp>
         <p:nvSpPr>
-          <p:cNvPr id="47" name="TextBox 46"/>
-          <p:cNvSpPr txBox="1"/>
-          <p:nvPr/>
-        </p:nvSpPr>
-        <p:spPr>
-          <a:xfrm>
-            <a:off x="576072" y="4251960"/>
-            <a:ext cx="2231136" cy="502920"/>
+          <p:cNvPr id="55" name="TextBox 54"/>
+          <p:cNvSpPr txBox="1"/>
+          <p:nvPr/>
+        </p:nvSpPr>
+        <p:spPr>
+          <a:xfrm>
+            <a:off x="566928" y="4206240"/>
+            <a:ext cx="1975103" cy="502920"/>
           </a:xfrm>
           <a:prstGeom prst="rect">
             <a:avLst/>
@@ -9817,7 +10157,7 @@
               </a:spcAft>
             </a:pPr>
             <a:r>
-              <a:rPr sz="1050" b="1">
+              <a:rPr sz="950" b="1">
                 <a:solidFill>
                   <a:srgbClr val="0F172A"/>
                 </a:solidFill>
@@ -9830,14 +10170,14 @@
       </p:sp>
       <p:sp>
         <p:nvSpPr>
-          <p:cNvPr id="48" name="Rectangle 47"/>
+          <p:cNvPr id="56" name="Rectangle 55"/>
           <p:cNvSpPr/>
           <p:nvPr/>
         </p:nvSpPr>
         <p:spPr>
           <a:xfrm>
-            <a:off x="2880360" y="4251960"/>
-            <a:ext cx="2377440" cy="502920"/>
+            <a:off x="2606039" y="4206240"/>
+            <a:ext cx="2011680" cy="502920"/>
           </a:xfrm>
           <a:prstGeom prst="rect">
             <a:avLst/>
@@ -9874,14 +10214,14 @@
       </p:sp>
       <p:sp>
         <p:nvSpPr>
-          <p:cNvPr id="49" name="TextBox 48"/>
-          <p:cNvSpPr txBox="1"/>
-          <p:nvPr/>
-        </p:nvSpPr>
-        <p:spPr>
-          <a:xfrm>
-            <a:off x="2953512" y="4251960"/>
-            <a:ext cx="2231136" cy="502920"/>
+          <p:cNvPr id="57" name="TextBox 56"/>
+          <p:cNvSpPr txBox="1"/>
+          <p:nvPr/>
+        </p:nvSpPr>
+        <p:spPr>
+          <a:xfrm>
+            <a:off x="2670047" y="4206240"/>
+            <a:ext cx="1883664" cy="502920"/>
           </a:xfrm>
           <a:prstGeom prst="rect">
             <a:avLst/>
@@ -9900,7 +10240,7 @@
               </a:spcAft>
             </a:pPr>
             <a:r>
-              <a:rPr sz="1050" b="0">
+              <a:rPr sz="950" b="0">
                 <a:solidFill>
                   <a:srgbClr val="0F172A"/>
                 </a:solidFill>
@@ -9913,14 +10253,14 @@
       </p:sp>
       <p:sp>
         <p:nvSpPr>
-          <p:cNvPr id="50" name="Rectangle 49"/>
+          <p:cNvPr id="58" name="Rectangle 57"/>
           <p:cNvSpPr/>
           <p:nvPr/>
         </p:nvSpPr>
         <p:spPr>
           <a:xfrm>
-            <a:off x="5257800" y="4251960"/>
-            <a:ext cx="2377440" cy="502920"/>
+            <a:off x="4617720" y="4206240"/>
+            <a:ext cx="1920240" cy="502920"/>
           </a:xfrm>
           <a:prstGeom prst="rect">
             <a:avLst/>
@@ -9957,14 +10297,14 @@
       </p:sp>
       <p:sp>
         <p:nvSpPr>
-          <p:cNvPr id="51" name="TextBox 50"/>
-          <p:cNvSpPr txBox="1"/>
-          <p:nvPr/>
-        </p:nvSpPr>
-        <p:spPr>
-          <a:xfrm>
-            <a:off x="5330952" y="4251960"/>
-            <a:ext cx="2231136" cy="502920"/>
+          <p:cNvPr id="59" name="TextBox 58"/>
+          <p:cNvSpPr txBox="1"/>
+          <p:nvPr/>
+        </p:nvSpPr>
+        <p:spPr>
+          <a:xfrm>
+            <a:off x="4681728" y="4206240"/>
+            <a:ext cx="1792224" cy="502920"/>
           </a:xfrm>
           <a:prstGeom prst="rect">
             <a:avLst/>
@@ -9983,27 +10323,27 @@
               </a:spcAft>
             </a:pPr>
             <a:r>
-              <a:rPr sz="1050" b="0">
-                <a:solidFill>
-                  <a:srgbClr val="0F172A"/>
-                </a:solidFill>
-                <a:latin typeface="Calibri"/>
-              </a:rPr>
-              <a:t>incluido</a:t>
-            </a:r>
-          </a:p>
-        </p:txBody>
-      </p:sp>
-      <p:sp>
-        <p:nvSpPr>
-          <p:cNvPr id="52" name="Rectangle 51"/>
+              <a:rPr sz="950" b="0">
+                <a:solidFill>
+                  <a:srgbClr val="92400E"/>
+                </a:solidFill>
+                <a:latin typeface="Calibri"/>
+              </a:rPr>
+              <a:t>[definir]</a:t>
+            </a:r>
+          </a:p>
+        </p:txBody>
+      </p:sp>
+      <p:sp>
+        <p:nvSpPr>
+          <p:cNvPr id="60" name="Rectangle 59"/>
           <p:cNvSpPr/>
           <p:nvPr/>
         </p:nvSpPr>
         <p:spPr>
           <a:xfrm>
-            <a:off x="7635240" y="4251960"/>
-            <a:ext cx="2011680" cy="502920"/>
+            <a:off x="6537960" y="4206240"/>
+            <a:ext cx="1828800" cy="502920"/>
           </a:xfrm>
           <a:prstGeom prst="rect">
             <a:avLst/>
@@ -10040,14 +10380,14 @@
       </p:sp>
       <p:sp>
         <p:nvSpPr>
-          <p:cNvPr id="53" name="TextBox 52"/>
-          <p:cNvSpPr txBox="1"/>
-          <p:nvPr/>
-        </p:nvSpPr>
-        <p:spPr>
-          <a:xfrm>
-            <a:off x="7708392" y="4251960"/>
-            <a:ext cx="1865376" cy="502920"/>
+          <p:cNvPr id="61" name="TextBox 60"/>
+          <p:cNvSpPr txBox="1"/>
+          <p:nvPr/>
+        </p:nvSpPr>
+        <p:spPr>
+          <a:xfrm>
+            <a:off x="6601968" y="4206240"/>
+            <a:ext cx="1700784" cy="502920"/>
           </a:xfrm>
           <a:prstGeom prst="rect">
             <a:avLst/>
@@ -10066,27 +10406,27 @@
               </a:spcAft>
             </a:pPr>
             <a:r>
-              <a:rPr sz="1050" b="0">
-                <a:solidFill>
-                  <a:srgbClr val="92400E"/>
-                </a:solidFill>
-                <a:latin typeface="Calibri"/>
-              </a:rPr>
-              <a:t>[definir]</a:t>
-            </a:r>
-          </a:p>
-        </p:txBody>
-      </p:sp>
-      <p:sp>
-        <p:nvSpPr>
-          <p:cNvPr id="54" name="Rectangle 53"/>
+              <a:rPr sz="950" b="0">
+                <a:solidFill>
+                  <a:srgbClr val="0F172A"/>
+                </a:solidFill>
+                <a:latin typeface="Calibri"/>
+              </a:rPr>
+              <a:t>según consumo</a:t>
+            </a:r>
+          </a:p>
+        </p:txBody>
+      </p:sp>
+      <p:sp>
+        <p:nvSpPr>
+          <p:cNvPr id="62" name="Rectangle 61"/>
           <p:cNvSpPr/>
           <p:nvPr/>
         </p:nvSpPr>
         <p:spPr>
           <a:xfrm>
-            <a:off x="9646920" y="4251960"/>
-            <a:ext cx="2011680" cy="502920"/>
+            <a:off x="8366760" y="4206240"/>
+            <a:ext cx="1737360" cy="502920"/>
           </a:xfrm>
           <a:prstGeom prst="rect">
             <a:avLst/>
@@ -10123,14 +10463,14 @@
       </p:sp>
       <p:sp>
         <p:nvSpPr>
-          <p:cNvPr id="55" name="TextBox 54"/>
-          <p:cNvSpPr txBox="1"/>
-          <p:nvPr/>
-        </p:nvSpPr>
-        <p:spPr>
-          <a:xfrm>
-            <a:off x="9720072" y="4251960"/>
-            <a:ext cx="1865376" cy="502920"/>
+          <p:cNvPr id="63" name="TextBox 62"/>
+          <p:cNvSpPr txBox="1"/>
+          <p:nvPr/>
+        </p:nvSpPr>
+        <p:spPr>
+          <a:xfrm>
+            <a:off x="8430768" y="4206240"/>
+            <a:ext cx="1609343" cy="502920"/>
           </a:xfrm>
           <a:prstGeom prst="rect">
             <a:avLst/>
@@ -10149,7 +10489,7 @@
               </a:spcAft>
             </a:pPr>
             <a:r>
-              <a:rPr sz="1050" b="0">
+              <a:rPr sz="950" b="0">
                 <a:solidFill>
                   <a:srgbClr val="92400E"/>
                 </a:solidFill>
@@ -10162,53 +10502,14 @@
       </p:sp>
       <p:sp>
         <p:nvSpPr>
-          <p:cNvPr id="56" name="TextBox 55"/>
-          <p:cNvSpPr txBox="1"/>
-          <p:nvPr/>
-        </p:nvSpPr>
-        <p:spPr>
-          <a:xfrm>
-            <a:off x="502920" y="5029200"/>
-            <a:ext cx="11155680" cy="822960"/>
-          </a:xfrm>
-          <a:prstGeom prst="rect">
-            <a:avLst/>
-          </a:prstGeom>
-          <a:noFill/>
-        </p:spPr>
-        <p:txBody>
-          <a:bodyPr wrap="square" anchor="t">
-            <a:spAutoFit/>
-          </a:bodyPr>
-          <a:lstStyle/>
-          <a:p>
-            <a:pPr algn="l">
-              <a:spcAft>
-                <a:spcPts val="400"/>
-              </a:spcAft>
-            </a:pPr>
-            <a:r>
-              <a:rPr sz="1250" b="1">
-                <a:solidFill>
-                  <a:srgbClr val="92400E"/>
-                </a:solidFill>
-                <a:latin typeface="Calibri"/>
-              </a:rPr>
-              <a:t>Para cerrar la tabla necesito de omnia: precio del SISTEMA (setup + mensual) y si los ads van a costo o con markup.</a:t>
-            </a:r>
-          </a:p>
-        </p:txBody>
-      </p:sp>
-      <p:sp>
-        <p:nvSpPr>
-          <p:cNvPr id="57" name="Rectangle 56"/>
+          <p:cNvPr id="64" name="Rectangle 63"/>
           <p:cNvSpPr/>
           <p:nvPr/>
         </p:nvSpPr>
         <p:spPr>
           <a:xfrm>
-            <a:off x="502920" y="6327648"/>
-            <a:ext cx="11155680" cy="10972"/>
+            <a:off x="10104120" y="4206240"/>
+            <a:ext cx="1554480" cy="502920"/>
           </a:xfrm>
           <a:prstGeom prst="rect">
             <a:avLst/>
@@ -10245,7 +10546,145 @@
       </p:sp>
       <p:sp>
         <p:nvSpPr>
-          <p:cNvPr id="58" name="TextBox 57"/>
+          <p:cNvPr id="65" name="TextBox 64"/>
+          <p:cNvSpPr txBox="1"/>
+          <p:nvPr/>
+        </p:nvSpPr>
+        <p:spPr>
+          <a:xfrm>
+            <a:off x="10168128" y="4206240"/>
+            <a:ext cx="1426464" cy="502920"/>
+          </a:xfrm>
+          <a:prstGeom prst="rect">
+            <a:avLst/>
+          </a:prstGeom>
+          <a:noFill/>
+        </p:spPr>
+        <p:txBody>
+          <a:bodyPr wrap="square" anchor="ctr">
+            <a:spAutoFit/>
+          </a:bodyPr>
+          <a:lstStyle/>
+          <a:p>
+            <a:pPr algn="l">
+              <a:spcAft>
+                <a:spcPts val="400"/>
+              </a:spcAft>
+            </a:pPr>
+            <a:r>
+              <a:rPr sz="950" b="0">
+                <a:solidFill>
+                  <a:srgbClr val="92400E"/>
+                </a:solidFill>
+                <a:latin typeface="Calibri"/>
+              </a:rPr>
+              <a:t>[definir]</a:t>
+            </a:r>
+          </a:p>
+        </p:txBody>
+      </p:sp>
+      <p:sp>
+        <p:nvSpPr>
+          <p:cNvPr id="66" name="TextBox 65"/>
+          <p:cNvSpPr txBox="1"/>
+          <p:nvPr/>
+        </p:nvSpPr>
+        <p:spPr>
+          <a:xfrm>
+            <a:off x="502920" y="4892040"/>
+            <a:ext cx="11155680" cy="1188720"/>
+          </a:xfrm>
+          <a:prstGeom prst="rect">
+            <a:avLst/>
+          </a:prstGeom>
+          <a:noFill/>
+        </p:spPr>
+        <p:txBody>
+          <a:bodyPr wrap="square" anchor="t">
+            <a:spAutoFit/>
+          </a:bodyPr>
+          <a:lstStyle/>
+          <a:p>
+            <a:pPr algn="l">
+              <a:spcAft>
+                <a:spcPts val="400"/>
+              </a:spcAft>
+            </a:pPr>
+            <a:r>
+              <a:rPr sz="1150" b="1">
+                <a:solidFill>
+                  <a:srgbClr val="92400E"/>
+                </a:solidFill>
+                <a:latin typeface="Calibri"/>
+              </a:rPr>
+              <a:t>+ Implementación única del sistema (one-time): [definir].   ·   Comunicación = WhatsApp + email + IA (slide siguiente).</a:t>
+            </a:r>
+          </a:p>
+          <a:p>
+            <a:pPr algn="l">
+              <a:spcAft>
+                <a:spcPts val="400"/>
+              </a:spcAft>
+            </a:pPr>
+            <a:r>
+              <a:rPr sz="1150" b="0">
+                <a:solidFill>
+                  <a:srgbClr val="92400E"/>
+                </a:solidFill>
+                <a:latin typeface="Calibri"/>
+              </a:rPr>
+              <a:t>Falta definir por omnia: precio del SISTEMA (implementación + mensual) y si los ads van a costo o con markup.</a:t>
+            </a:r>
+          </a:p>
+        </p:txBody>
+      </p:sp>
+      <p:sp>
+        <p:nvSpPr>
+          <p:cNvPr id="67" name="Rectangle 66"/>
+          <p:cNvSpPr/>
+          <p:nvPr/>
+        </p:nvSpPr>
+        <p:spPr>
+          <a:xfrm>
+            <a:off x="502920" y="6327648"/>
+            <a:ext cx="11155680" cy="10972"/>
+          </a:xfrm>
+          <a:prstGeom prst="rect">
+            <a:avLst/>
+          </a:prstGeom>
+          <a:solidFill>
+            <a:srgbClr val="F1F5F9"/>
+          </a:solidFill>
+          <a:ln>
+            <a:noFill/>
+          </a:ln>
+          <a:effectLst/>
+        </p:spPr>
+        <p:style>
+          <a:lnRef idx="1">
+            <a:schemeClr val="accent1"/>
+          </a:lnRef>
+          <a:fillRef idx="3">
+            <a:schemeClr val="accent1"/>
+          </a:fillRef>
+          <a:effectRef idx="2">
+            <a:schemeClr val="accent1"/>
+          </a:effectRef>
+          <a:fontRef idx="minor">
+            <a:schemeClr val="lt1"/>
+          </a:fontRef>
+        </p:style>
+        <p:txBody>
+          <a:bodyPr rtlCol="0" anchor="ctr"/>
+          <a:lstStyle/>
+          <a:p>
+            <a:pPr algn="ctr"/>
+          </a:p>
+        </p:txBody>
+      </p:sp>
+      <p:sp>
+        <p:nvSpPr>
+          <p:cNvPr id="68" name="TextBox 67"/>
           <p:cNvSpPr txBox="1"/>
           <p:nvPr/>
         </p:nvSpPr>
@@ -10284,7 +10723,7 @@
       </p:sp>
       <p:sp>
         <p:nvSpPr>
-          <p:cNvPr id="59" name="TextBox 58"/>
+          <p:cNvPr id="69" name="TextBox 68"/>
           <p:cNvSpPr txBox="1"/>
           <p:nvPr/>
         </p:nvSpPr>
@@ -10316,7 +10755,7 @@
                 </a:solidFill>
                 <a:latin typeface="Calibri"/>
               </a:rPr>
-              <a:t>15 / 16</a:t>
+              <a:t>15 / 17</a:t>
             </a:r>
           </a:p>
         </p:txBody>
@@ -10341,6 +10780,972 @@
       <p:grpSpPr/>
       <p:sp>
         <p:nvSpPr>
+          <p:cNvPr id="2" name="Rounded Rectangle 1"/>
+          <p:cNvSpPr/>
+          <p:nvPr/>
+        </p:nvSpPr>
+        <p:spPr>
+          <a:xfrm>
+            <a:off x="502920" y="548640"/>
+            <a:ext cx="292608" cy="292608"/>
+          </a:xfrm>
+          <a:prstGeom prst="roundRect">
+            <a:avLst/>
+          </a:prstGeom>
+          <a:solidFill>
+            <a:srgbClr val="14B8A6"/>
+          </a:solidFill>
+          <a:ln>
+            <a:noFill/>
+          </a:ln>
+          <a:effectLst/>
+        </p:spPr>
+        <p:style>
+          <a:lnRef idx="1">
+            <a:schemeClr val="accent1"/>
+          </a:lnRef>
+          <a:fillRef idx="3">
+            <a:schemeClr val="accent1"/>
+          </a:fillRef>
+          <a:effectRef idx="2">
+            <a:schemeClr val="accent1"/>
+          </a:effectRef>
+          <a:fontRef idx="minor">
+            <a:schemeClr val="lt1"/>
+          </a:fontRef>
+        </p:style>
+        <p:txBody>
+          <a:bodyPr rtlCol="0" anchor="ctr"/>
+          <a:lstStyle/>
+          <a:p>
+            <a:pPr algn="ctr"/>
+          </a:p>
+        </p:txBody>
+      </p:sp>
+      <p:sp>
+        <p:nvSpPr>
+          <p:cNvPr id="3" name="TextBox 2"/>
+          <p:cNvSpPr txBox="1"/>
+          <p:nvPr/>
+        </p:nvSpPr>
+        <p:spPr>
+          <a:xfrm>
+            <a:off x="914400" y="457200"/>
+            <a:ext cx="10058400" cy="457200"/>
+          </a:xfrm>
+          <a:prstGeom prst="rect">
+            <a:avLst/>
+          </a:prstGeom>
+          <a:noFill/>
+        </p:spPr>
+        <p:txBody>
+          <a:bodyPr wrap="square" anchor="t">
+            <a:spAutoFit/>
+          </a:bodyPr>
+          <a:lstStyle/>
+          <a:p>
+            <a:pPr algn="l">
+              <a:spcAft>
+                <a:spcPts val="400"/>
+              </a:spcAft>
+            </a:pPr>
+            <a:r>
+              <a:rPr sz="1100" b="1">
+                <a:solidFill>
+                  <a:srgbClr val="14B8A6"/>
+                </a:solidFill>
+                <a:latin typeface="Calibri"/>
+              </a:rPr>
+              <a:t>COSTOS DE COMUNICACIÓN</a:t>
+            </a:r>
+          </a:p>
+        </p:txBody>
+      </p:sp>
+      <p:sp>
+        <p:nvSpPr>
+          <p:cNvPr id="4" name="TextBox 3"/>
+          <p:cNvSpPr txBox="1"/>
+          <p:nvPr/>
+        </p:nvSpPr>
+        <p:spPr>
+          <a:xfrm>
+            <a:off x="502920" y="868680"/>
+            <a:ext cx="11155680" cy="822960"/>
+          </a:xfrm>
+          <a:prstGeom prst="rect">
+            <a:avLst/>
+          </a:prstGeom>
+          <a:noFill/>
+        </p:spPr>
+        <p:txBody>
+          <a:bodyPr wrap="square" anchor="t">
+            <a:spAutoFit/>
+          </a:bodyPr>
+          <a:lstStyle/>
+          <a:p>
+            <a:pPr algn="l">
+              <a:spcAft>
+                <a:spcPts val="400"/>
+              </a:spcAft>
+            </a:pPr>
+            <a:r>
+              <a:rPr sz="2900" b="1">
+                <a:solidFill>
+                  <a:srgbClr val="0B1F3A"/>
+                </a:solidFill>
+                <a:latin typeface="Calibri"/>
+              </a:rPr>
+              <a:t>Lo que consume el sistema (operativo)</a:t>
+            </a:r>
+          </a:p>
+        </p:txBody>
+      </p:sp>
+      <p:sp>
+        <p:nvSpPr>
+          <p:cNvPr id="5" name="TextBox 4"/>
+          <p:cNvSpPr txBox="1"/>
+          <p:nvPr/>
+        </p:nvSpPr>
+        <p:spPr>
+          <a:xfrm>
+            <a:off x="502920" y="1572768"/>
+            <a:ext cx="11155680" cy="548640"/>
+          </a:xfrm>
+          <a:prstGeom prst="rect">
+            <a:avLst/>
+          </a:prstGeom>
+          <a:noFill/>
+        </p:spPr>
+        <p:txBody>
+          <a:bodyPr wrap="square" anchor="t">
+            <a:spAutoFit/>
+          </a:bodyPr>
+          <a:lstStyle/>
+          <a:p>
+            <a:pPr algn="l">
+              <a:spcAft>
+                <a:spcPts val="400"/>
+              </a:spcAft>
+            </a:pPr>
+            <a:r>
+              <a:rPr sz="1500" b="0">
+                <a:solidFill>
+                  <a:srgbClr val="64748B"/>
+                </a:solidFill>
+                <a:latin typeface="Calibri"/>
+              </a:rPr>
+              <a:t>Uso interno —  aparte de la gestión de ads y de la inversión publicitaria. Definir montos y si se incluyen en la mensualidad o se facturan por uso.</a:t>
+            </a:r>
+          </a:p>
+        </p:txBody>
+      </p:sp>
+      <p:sp>
+        <p:nvSpPr>
+          <p:cNvPr id="6" name="Rounded Rectangle 5"/>
+          <p:cNvSpPr/>
+          <p:nvPr/>
+        </p:nvSpPr>
+        <p:spPr>
+          <a:xfrm>
+            <a:off x="502920" y="2423160"/>
+            <a:ext cx="3535680" cy="2651760"/>
+          </a:xfrm>
+          <a:prstGeom prst="roundRect">
+            <a:avLst/>
+          </a:prstGeom>
+          <a:solidFill>
+            <a:srgbClr val="F1F5F9"/>
+          </a:solidFill>
+          <a:ln>
+            <a:noFill/>
+          </a:ln>
+          <a:effectLst/>
+        </p:spPr>
+        <p:style>
+          <a:lnRef idx="1">
+            <a:schemeClr val="accent1"/>
+          </a:lnRef>
+          <a:fillRef idx="3">
+            <a:schemeClr val="accent1"/>
+          </a:fillRef>
+          <a:effectRef idx="2">
+            <a:schemeClr val="accent1"/>
+          </a:effectRef>
+          <a:fontRef idx="minor">
+            <a:schemeClr val="lt1"/>
+          </a:fontRef>
+        </p:style>
+        <p:txBody>
+          <a:bodyPr rtlCol="0" anchor="ctr"/>
+          <a:lstStyle/>
+          <a:p>
+            <a:pPr algn="ctr"/>
+          </a:p>
+        </p:txBody>
+      </p:sp>
+      <p:sp>
+        <p:nvSpPr>
+          <p:cNvPr id="7" name="Rectangle 6"/>
+          <p:cNvSpPr/>
+          <p:nvPr/>
+        </p:nvSpPr>
+        <p:spPr>
+          <a:xfrm>
+            <a:off x="502920" y="2423160"/>
+            <a:ext cx="3535680" cy="118872"/>
+          </a:xfrm>
+          <a:prstGeom prst="rect">
+            <a:avLst/>
+          </a:prstGeom>
+          <a:solidFill>
+            <a:srgbClr val="2563EB"/>
+          </a:solidFill>
+          <a:ln>
+            <a:noFill/>
+          </a:ln>
+          <a:effectLst/>
+        </p:spPr>
+        <p:style>
+          <a:lnRef idx="1">
+            <a:schemeClr val="accent1"/>
+          </a:lnRef>
+          <a:fillRef idx="3">
+            <a:schemeClr val="accent1"/>
+          </a:fillRef>
+          <a:effectRef idx="2">
+            <a:schemeClr val="accent1"/>
+          </a:effectRef>
+          <a:fontRef idx="minor">
+            <a:schemeClr val="lt1"/>
+          </a:fontRef>
+        </p:style>
+        <p:txBody>
+          <a:bodyPr rtlCol="0" anchor="ctr"/>
+          <a:lstStyle/>
+          <a:p>
+            <a:pPr algn="ctr"/>
+          </a:p>
+        </p:txBody>
+      </p:sp>
+      <p:sp>
+        <p:nvSpPr>
+          <p:cNvPr id="8" name="TextBox 7"/>
+          <p:cNvSpPr txBox="1"/>
+          <p:nvPr/>
+        </p:nvSpPr>
+        <p:spPr>
+          <a:xfrm>
+            <a:off x="685800" y="2697479"/>
+            <a:ext cx="3169920" cy="640080"/>
+          </a:xfrm>
+          <a:prstGeom prst="rect">
+            <a:avLst/>
+          </a:prstGeom>
+          <a:noFill/>
+        </p:spPr>
+        <p:txBody>
+          <a:bodyPr wrap="square" anchor="t">
+            <a:spAutoFit/>
+          </a:bodyPr>
+          <a:lstStyle/>
+          <a:p>
+            <a:pPr algn="l">
+              <a:spcAft>
+                <a:spcPts val="400"/>
+              </a:spcAft>
+            </a:pPr>
+            <a:r>
+              <a:rPr sz="1400" b="1">
+                <a:solidFill>
+                  <a:srgbClr val="0B1F3A"/>
+                </a:solidFill>
+                <a:latin typeface="Calibri"/>
+              </a:rPr>
+              <a:t>Licencia WhatsApp</a:t>
+            </a:r>
+          </a:p>
+        </p:txBody>
+      </p:sp>
+      <p:sp>
+        <p:nvSpPr>
+          <p:cNvPr id="9" name="TextBox 8"/>
+          <p:cNvSpPr txBox="1"/>
+          <p:nvPr/>
+        </p:nvSpPr>
+        <p:spPr>
+          <a:xfrm>
+            <a:off x="685800" y="3337560"/>
+            <a:ext cx="3169920" cy="1600200"/>
+          </a:xfrm>
+          <a:prstGeom prst="rect">
+            <a:avLst/>
+          </a:prstGeom>
+          <a:noFill/>
+        </p:spPr>
+        <p:txBody>
+          <a:bodyPr wrap="square" anchor="t">
+            <a:spAutoFit/>
+          </a:bodyPr>
+          <a:lstStyle/>
+          <a:p>
+            <a:pPr algn="l">
+              <a:spcAft>
+                <a:spcPts val="500"/>
+              </a:spcAft>
+            </a:pPr>
+            <a:r>
+              <a:rPr sz="1100" b="0">
+                <a:solidFill>
+                  <a:srgbClr val="0F172A"/>
+                </a:solidFill>
+                <a:latin typeface="Calibri"/>
+              </a:rPr>
+              <a:t>•  Meta cobra por conversación</a:t>
+            </a:r>
+          </a:p>
+          <a:p>
+            <a:pPr algn="l">
+              <a:spcAft>
+                <a:spcPts val="500"/>
+              </a:spcAft>
+            </a:pPr>
+            <a:r>
+              <a:rPr sz="1100" b="0">
+                <a:solidFill>
+                  <a:srgbClr val="0F172A"/>
+                </a:solidFill>
+                <a:latin typeface="Calibri"/>
+              </a:rPr>
+              <a:t>•  (utility / marketing)</a:t>
+            </a:r>
+          </a:p>
+          <a:p>
+            <a:pPr algn="l">
+              <a:spcAft>
+                <a:spcPts val="500"/>
+              </a:spcAft>
+            </a:pPr>
+            <a:r>
+              <a:rPr sz="1100" b="0">
+                <a:solidFill>
+                  <a:srgbClr val="0F172A"/>
+                </a:solidFill>
+                <a:latin typeface="Calibri"/>
+              </a:rPr>
+              <a:t>•  + posible fee de plataforma</a:t>
+            </a:r>
+          </a:p>
+          <a:p>
+            <a:pPr algn="l">
+              <a:spcAft>
+                <a:spcPts val="500"/>
+              </a:spcAft>
+            </a:pPr>
+            <a:r>
+              <a:rPr sz="1100" b="0">
+                <a:solidFill>
+                  <a:srgbClr val="0F172A"/>
+                </a:solidFill>
+                <a:latin typeface="Calibri"/>
+              </a:rPr>
+              <a:t>•  Monto: [definir]</a:t>
+            </a:r>
+          </a:p>
+        </p:txBody>
+      </p:sp>
+      <p:sp>
+        <p:nvSpPr>
+          <p:cNvPr id="10" name="Rounded Rectangle 9"/>
+          <p:cNvSpPr/>
+          <p:nvPr/>
+        </p:nvSpPr>
+        <p:spPr>
+          <a:xfrm>
+            <a:off x="4312920" y="2423160"/>
+            <a:ext cx="3535680" cy="2651760"/>
+          </a:xfrm>
+          <a:prstGeom prst="roundRect">
+            <a:avLst/>
+          </a:prstGeom>
+          <a:solidFill>
+            <a:srgbClr val="F1F5F9"/>
+          </a:solidFill>
+          <a:ln>
+            <a:noFill/>
+          </a:ln>
+          <a:effectLst/>
+        </p:spPr>
+        <p:style>
+          <a:lnRef idx="1">
+            <a:schemeClr val="accent1"/>
+          </a:lnRef>
+          <a:fillRef idx="3">
+            <a:schemeClr val="accent1"/>
+          </a:fillRef>
+          <a:effectRef idx="2">
+            <a:schemeClr val="accent1"/>
+          </a:effectRef>
+          <a:fontRef idx="minor">
+            <a:schemeClr val="lt1"/>
+          </a:fontRef>
+        </p:style>
+        <p:txBody>
+          <a:bodyPr rtlCol="0" anchor="ctr"/>
+          <a:lstStyle/>
+          <a:p>
+            <a:pPr algn="ctr"/>
+          </a:p>
+        </p:txBody>
+      </p:sp>
+      <p:sp>
+        <p:nvSpPr>
+          <p:cNvPr id="11" name="Rectangle 10"/>
+          <p:cNvSpPr/>
+          <p:nvPr/>
+        </p:nvSpPr>
+        <p:spPr>
+          <a:xfrm>
+            <a:off x="4312920" y="2423160"/>
+            <a:ext cx="3535680" cy="118872"/>
+          </a:xfrm>
+          <a:prstGeom prst="rect">
+            <a:avLst/>
+          </a:prstGeom>
+          <a:solidFill>
+            <a:srgbClr val="2563EB"/>
+          </a:solidFill>
+          <a:ln>
+            <a:noFill/>
+          </a:ln>
+          <a:effectLst/>
+        </p:spPr>
+        <p:style>
+          <a:lnRef idx="1">
+            <a:schemeClr val="accent1"/>
+          </a:lnRef>
+          <a:fillRef idx="3">
+            <a:schemeClr val="accent1"/>
+          </a:fillRef>
+          <a:effectRef idx="2">
+            <a:schemeClr val="accent1"/>
+          </a:effectRef>
+          <a:fontRef idx="minor">
+            <a:schemeClr val="lt1"/>
+          </a:fontRef>
+        </p:style>
+        <p:txBody>
+          <a:bodyPr rtlCol="0" anchor="ctr"/>
+          <a:lstStyle/>
+          <a:p>
+            <a:pPr algn="ctr"/>
+          </a:p>
+        </p:txBody>
+      </p:sp>
+      <p:sp>
+        <p:nvSpPr>
+          <p:cNvPr id="12" name="TextBox 11"/>
+          <p:cNvSpPr txBox="1"/>
+          <p:nvPr/>
+        </p:nvSpPr>
+        <p:spPr>
+          <a:xfrm>
+            <a:off x="4495800" y="2697479"/>
+            <a:ext cx="3169920" cy="640080"/>
+          </a:xfrm>
+          <a:prstGeom prst="rect">
+            <a:avLst/>
+          </a:prstGeom>
+          <a:noFill/>
+        </p:spPr>
+        <p:txBody>
+          <a:bodyPr wrap="square" anchor="t">
+            <a:spAutoFit/>
+          </a:bodyPr>
+          <a:lstStyle/>
+          <a:p>
+            <a:pPr algn="l">
+              <a:spcAft>
+                <a:spcPts val="400"/>
+              </a:spcAft>
+            </a:pPr>
+            <a:r>
+              <a:rPr sz="1400" b="1">
+                <a:solidFill>
+                  <a:srgbClr val="0B1F3A"/>
+                </a:solidFill>
+                <a:latin typeface="Calibri"/>
+              </a:rPr>
+              <a:t>Correos electrónicos</a:t>
+            </a:r>
+          </a:p>
+        </p:txBody>
+      </p:sp>
+      <p:sp>
+        <p:nvSpPr>
+          <p:cNvPr id="13" name="TextBox 12"/>
+          <p:cNvSpPr txBox="1"/>
+          <p:nvPr/>
+        </p:nvSpPr>
+        <p:spPr>
+          <a:xfrm>
+            <a:off x="4495800" y="3337560"/>
+            <a:ext cx="3169920" cy="1600200"/>
+          </a:xfrm>
+          <a:prstGeom prst="rect">
+            <a:avLst/>
+          </a:prstGeom>
+          <a:noFill/>
+        </p:spPr>
+        <p:txBody>
+          <a:bodyPr wrap="square" anchor="t">
+            <a:spAutoFit/>
+          </a:bodyPr>
+          <a:lstStyle/>
+          <a:p>
+            <a:pPr algn="l">
+              <a:spcAft>
+                <a:spcPts val="500"/>
+              </a:spcAft>
+            </a:pPr>
+            <a:r>
+              <a:rPr sz="1100" b="0">
+                <a:solidFill>
+                  <a:srgbClr val="0F172A"/>
+                </a:solidFill>
+                <a:latin typeface="Calibri"/>
+              </a:rPr>
+              <a:t>•  Costo por envío / volumen</a:t>
+            </a:r>
+          </a:p>
+          <a:p>
+            <a:pPr algn="l">
+              <a:spcAft>
+                <a:spcPts val="500"/>
+              </a:spcAft>
+            </a:pPr>
+            <a:r>
+              <a:rPr sz="1100" b="0">
+                <a:solidFill>
+                  <a:srgbClr val="0F172A"/>
+                </a:solidFill>
+                <a:latin typeface="Calibri"/>
+              </a:rPr>
+              <a:t>•  Boletines + automatizaciones</a:t>
+            </a:r>
+          </a:p>
+          <a:p>
+            <a:pPr algn="l">
+              <a:spcAft>
+                <a:spcPts val="500"/>
+              </a:spcAft>
+            </a:pPr>
+            <a:r>
+              <a:rPr sz="1100" b="0">
+                <a:solidFill>
+                  <a:srgbClr val="0F172A"/>
+                </a:solidFill>
+                <a:latin typeface="Calibri"/>
+              </a:rPr>
+              <a:t>•  Monto: [definir]</a:t>
+            </a:r>
+          </a:p>
+        </p:txBody>
+      </p:sp>
+      <p:sp>
+        <p:nvSpPr>
+          <p:cNvPr id="14" name="Rounded Rectangle 13"/>
+          <p:cNvSpPr/>
+          <p:nvPr/>
+        </p:nvSpPr>
+        <p:spPr>
+          <a:xfrm>
+            <a:off x="8122920" y="2423160"/>
+            <a:ext cx="3535680" cy="2651760"/>
+          </a:xfrm>
+          <a:prstGeom prst="roundRect">
+            <a:avLst/>
+          </a:prstGeom>
+          <a:solidFill>
+            <a:srgbClr val="F1F5F9"/>
+          </a:solidFill>
+          <a:ln>
+            <a:noFill/>
+          </a:ln>
+          <a:effectLst/>
+        </p:spPr>
+        <p:style>
+          <a:lnRef idx="1">
+            <a:schemeClr val="accent1"/>
+          </a:lnRef>
+          <a:fillRef idx="3">
+            <a:schemeClr val="accent1"/>
+          </a:fillRef>
+          <a:effectRef idx="2">
+            <a:schemeClr val="accent1"/>
+          </a:effectRef>
+          <a:fontRef idx="minor">
+            <a:schemeClr val="lt1"/>
+          </a:fontRef>
+        </p:style>
+        <p:txBody>
+          <a:bodyPr rtlCol="0" anchor="ctr"/>
+          <a:lstStyle/>
+          <a:p>
+            <a:pPr algn="ctr"/>
+          </a:p>
+        </p:txBody>
+      </p:sp>
+      <p:sp>
+        <p:nvSpPr>
+          <p:cNvPr id="15" name="Rectangle 14"/>
+          <p:cNvSpPr/>
+          <p:nvPr/>
+        </p:nvSpPr>
+        <p:spPr>
+          <a:xfrm>
+            <a:off x="8122920" y="2423160"/>
+            <a:ext cx="3535680" cy="118872"/>
+          </a:xfrm>
+          <a:prstGeom prst="rect">
+            <a:avLst/>
+          </a:prstGeom>
+          <a:solidFill>
+            <a:srgbClr val="2563EB"/>
+          </a:solidFill>
+          <a:ln>
+            <a:noFill/>
+          </a:ln>
+          <a:effectLst/>
+        </p:spPr>
+        <p:style>
+          <a:lnRef idx="1">
+            <a:schemeClr val="accent1"/>
+          </a:lnRef>
+          <a:fillRef idx="3">
+            <a:schemeClr val="accent1"/>
+          </a:fillRef>
+          <a:effectRef idx="2">
+            <a:schemeClr val="accent1"/>
+          </a:effectRef>
+          <a:fontRef idx="minor">
+            <a:schemeClr val="lt1"/>
+          </a:fontRef>
+        </p:style>
+        <p:txBody>
+          <a:bodyPr rtlCol="0" anchor="ctr"/>
+          <a:lstStyle/>
+          <a:p>
+            <a:pPr algn="ctr"/>
+          </a:p>
+        </p:txBody>
+      </p:sp>
+      <p:sp>
+        <p:nvSpPr>
+          <p:cNvPr id="16" name="TextBox 15"/>
+          <p:cNvSpPr txBox="1"/>
+          <p:nvPr/>
+        </p:nvSpPr>
+        <p:spPr>
+          <a:xfrm>
+            <a:off x="8305800" y="2697479"/>
+            <a:ext cx="3169920" cy="640080"/>
+          </a:xfrm>
+          <a:prstGeom prst="rect">
+            <a:avLst/>
+          </a:prstGeom>
+          <a:noFill/>
+        </p:spPr>
+        <p:txBody>
+          <a:bodyPr wrap="square" anchor="t">
+            <a:spAutoFit/>
+          </a:bodyPr>
+          <a:lstStyle/>
+          <a:p>
+            <a:pPr algn="l">
+              <a:spcAft>
+                <a:spcPts val="400"/>
+              </a:spcAft>
+            </a:pPr>
+            <a:r>
+              <a:rPr sz="1400" b="1">
+                <a:solidFill>
+                  <a:srgbClr val="0B1F3A"/>
+                </a:solidFill>
+                <a:latin typeface="Calibri"/>
+              </a:rPr>
+              <a:t>Tokens de IA (Sofía)</a:t>
+            </a:r>
+          </a:p>
+        </p:txBody>
+      </p:sp>
+      <p:sp>
+        <p:nvSpPr>
+          <p:cNvPr id="17" name="TextBox 16"/>
+          <p:cNvSpPr txBox="1"/>
+          <p:nvPr/>
+        </p:nvSpPr>
+        <p:spPr>
+          <a:xfrm>
+            <a:off x="8305800" y="3337560"/>
+            <a:ext cx="3169920" cy="1600200"/>
+          </a:xfrm>
+          <a:prstGeom prst="rect">
+            <a:avLst/>
+          </a:prstGeom>
+          <a:noFill/>
+        </p:spPr>
+        <p:txBody>
+          <a:bodyPr wrap="square" anchor="t">
+            <a:spAutoFit/>
+          </a:bodyPr>
+          <a:lstStyle/>
+          <a:p>
+            <a:pPr algn="l">
+              <a:spcAft>
+                <a:spcPts val="500"/>
+              </a:spcAft>
+            </a:pPr>
+            <a:r>
+              <a:rPr sz="1100" b="0">
+                <a:solidFill>
+                  <a:srgbClr val="0F172A"/>
+                </a:solidFill>
+                <a:latin typeface="Calibri"/>
+              </a:rPr>
+              <a:t>•  DECIDIR el modelo:</a:t>
+            </a:r>
+          </a:p>
+          <a:p>
+            <a:pPr algn="l">
+              <a:spcAft>
+                <a:spcPts val="500"/>
+              </a:spcAft>
+            </a:pPr>
+            <a:r>
+              <a:rPr sz="1100" b="0">
+                <a:solidFill>
+                  <a:srgbClr val="0F172A"/>
+                </a:solidFill>
+                <a:latin typeface="Calibri"/>
+              </a:rPr>
+              <a:t>•  ☐ Ilimitada (cuota fija)</a:t>
+            </a:r>
+          </a:p>
+          <a:p>
+            <a:pPr algn="l">
+              <a:spcAft>
+                <a:spcPts val="500"/>
+              </a:spcAft>
+            </a:pPr>
+            <a:r>
+              <a:rPr sz="1100" b="0">
+                <a:solidFill>
+                  <a:srgbClr val="0F172A"/>
+                </a:solidFill>
+                <a:latin typeface="Calibri"/>
+              </a:rPr>
+              <a:t>•  ☐ Por consumo (por mensaje)</a:t>
+            </a:r>
+          </a:p>
+          <a:p>
+            <a:pPr algn="l">
+              <a:spcAft>
+                <a:spcPts val="500"/>
+              </a:spcAft>
+            </a:pPr>
+            <a:r>
+              <a:rPr sz="1100" b="0">
+                <a:solidFill>
+                  <a:srgbClr val="0F172A"/>
+                </a:solidFill>
+                <a:latin typeface="Calibri"/>
+              </a:rPr>
+              <a:t>•  Monto: [definir]</a:t>
+            </a:r>
+          </a:p>
+        </p:txBody>
+      </p:sp>
+      <p:sp>
+        <p:nvSpPr>
+          <p:cNvPr id="18" name="TextBox 17"/>
+          <p:cNvSpPr txBox="1"/>
+          <p:nvPr/>
+        </p:nvSpPr>
+        <p:spPr>
+          <a:xfrm>
+            <a:off x="502920" y="5257800"/>
+            <a:ext cx="11155680" cy="640080"/>
+          </a:xfrm>
+          <a:prstGeom prst="rect">
+            <a:avLst/>
+          </a:prstGeom>
+          <a:noFill/>
+        </p:spPr>
+        <p:txBody>
+          <a:bodyPr wrap="square" anchor="t">
+            <a:spAutoFit/>
+          </a:bodyPr>
+          <a:lstStyle/>
+          <a:p>
+            <a:pPr algn="l">
+              <a:spcAft>
+                <a:spcPts val="400"/>
+              </a:spcAft>
+            </a:pPr>
+            <a:r>
+              <a:rPr sz="1200" b="1">
+                <a:solidFill>
+                  <a:srgbClr val="92400E"/>
+                </a:solidFill>
+                <a:latin typeface="Calibri"/>
+              </a:rPr>
+              <a:t>Recomendado: incluir un 'fee de comunicación' fijo en la mensualidad y avisar que el consumo alto se factura aparte.</a:t>
+            </a:r>
+          </a:p>
+        </p:txBody>
+      </p:sp>
+      <p:sp>
+        <p:nvSpPr>
+          <p:cNvPr id="19" name="Rectangle 18"/>
+          <p:cNvSpPr/>
+          <p:nvPr/>
+        </p:nvSpPr>
+        <p:spPr>
+          <a:xfrm>
+            <a:off x="502920" y="6327648"/>
+            <a:ext cx="11155680" cy="10972"/>
+          </a:xfrm>
+          <a:prstGeom prst="rect">
+            <a:avLst/>
+          </a:prstGeom>
+          <a:solidFill>
+            <a:srgbClr val="F1F5F9"/>
+          </a:solidFill>
+          <a:ln>
+            <a:noFill/>
+          </a:ln>
+          <a:effectLst/>
+        </p:spPr>
+        <p:style>
+          <a:lnRef idx="1">
+            <a:schemeClr val="accent1"/>
+          </a:lnRef>
+          <a:fillRef idx="3">
+            <a:schemeClr val="accent1"/>
+          </a:fillRef>
+          <a:effectRef idx="2">
+            <a:schemeClr val="accent1"/>
+          </a:effectRef>
+          <a:fontRef idx="minor">
+            <a:schemeClr val="lt1"/>
+          </a:fontRef>
+        </p:style>
+        <p:txBody>
+          <a:bodyPr rtlCol="0" anchor="ctr"/>
+          <a:lstStyle/>
+          <a:p>
+            <a:pPr algn="ctr"/>
+          </a:p>
+        </p:txBody>
+      </p:sp>
+      <p:sp>
+        <p:nvSpPr>
+          <p:cNvPr id="20" name="TextBox 19"/>
+          <p:cNvSpPr txBox="1"/>
+          <p:nvPr/>
+        </p:nvSpPr>
+        <p:spPr>
+          <a:xfrm>
+            <a:off x="502920" y="6364224"/>
+            <a:ext cx="8229600" cy="365760"/>
+          </a:xfrm>
+          <a:prstGeom prst="rect">
+            <a:avLst/>
+          </a:prstGeom>
+          <a:noFill/>
+        </p:spPr>
+        <p:txBody>
+          <a:bodyPr wrap="square" anchor="t">
+            <a:spAutoFit/>
+          </a:bodyPr>
+          <a:lstStyle/>
+          <a:p>
+            <a:pPr algn="l">
+              <a:spcAft>
+                <a:spcPts val="400"/>
+              </a:spcAft>
+            </a:pPr>
+            <a:r>
+              <a:rPr sz="900" b="1">
+                <a:solidFill>
+                  <a:srgbClr val="92400E"/>
+                </a:solidFill>
+                <a:latin typeface="Calibri"/>
+              </a:rPr>
+              <a:t>omnia  ·  USO INTERNO · Costos de comunicación</a:t>
+            </a:r>
+          </a:p>
+        </p:txBody>
+      </p:sp>
+      <p:sp>
+        <p:nvSpPr>
+          <p:cNvPr id="21" name="TextBox 20"/>
+          <p:cNvSpPr txBox="1"/>
+          <p:nvPr/>
+        </p:nvSpPr>
+        <p:spPr>
+          <a:xfrm>
+            <a:off x="10058400" y="6364224"/>
+            <a:ext cx="1627632" cy="365760"/>
+          </a:xfrm>
+          <a:prstGeom prst="rect">
+            <a:avLst/>
+          </a:prstGeom>
+          <a:noFill/>
+        </p:spPr>
+        <p:txBody>
+          <a:bodyPr wrap="square" anchor="t">
+            <a:spAutoFit/>
+          </a:bodyPr>
+          <a:lstStyle/>
+          <a:p>
+            <a:pPr algn="r">
+              <a:spcAft>
+                <a:spcPts val="400"/>
+              </a:spcAft>
+            </a:pPr>
+            <a:r>
+              <a:rPr sz="900" b="0">
+                <a:solidFill>
+                  <a:srgbClr val="64748B"/>
+                </a:solidFill>
+                <a:latin typeface="Calibri"/>
+              </a:rPr>
+              <a:t>16 / 17</a:t>
+            </a:r>
+          </a:p>
+        </p:txBody>
+      </p:sp>
+    </p:spTree>
+  </p:cSld>
+  <p:clrMapOvr>
+    <a:masterClrMapping/>
+  </p:clrMapOvr>
+</p:sld>
+</file>
+
+<file path=ppt/slides/slide17.xml><?xml version="1.0" encoding="utf-8"?>
+<p:sld xmlns:a="http://schemas.openxmlformats.org/drawingml/2006/main" xmlns:p="http://schemas.openxmlformats.org/presentationml/2006/main" xmlns:r="http://schemas.openxmlformats.org/officeDocument/2006/relationships">
+  <p:cSld>
+    <p:spTree>
+      <p:nvGrpSpPr>
+        <p:cNvPr id="1" name=""/>
+        <p:cNvGrpSpPr/>
+        <p:nvPr/>
+      </p:nvGrpSpPr>
+      <p:grpSpPr/>
+      <p:sp>
+        <p:nvSpPr>
           <p:cNvPr id="2" name="Rectangle 1"/>
           <p:cNvSpPr/>
           <p:nvPr/>
@@ -11719,7 +13124,7 @@
                 </a:solidFill>
                 <a:latin typeface="Calibri"/>
               </a:rPr>
-              <a:t>02 / 16</a:t>
+              <a:t>02 / 17</a:t>
             </a:r>
           </a:p>
         </p:txBody>
@@ -12623,7 +14028,7 @@
                 </a:solidFill>
                 <a:latin typeface="Calibri"/>
               </a:rPr>
-              <a:t>03 / 16</a:t>
+              <a:t>03 / 17</a:t>
             </a:r>
           </a:p>
         </p:txBody>
@@ -13752,7 +15157,7 @@
                 </a:solidFill>
                 <a:latin typeface="Calibri"/>
               </a:rPr>
-              <a:t>04 / 16</a:t>
+              <a:t>04 / 17</a:t>
             </a:r>
           </a:p>
         </p:txBody>
@@ -14647,7 +16052,7 @@
                 </a:solidFill>
                 <a:latin typeface="Calibri"/>
               </a:rPr>
-              <a:t>05 / 16</a:t>
+              <a:t>05 / 17</a:t>
             </a:r>
           </a:p>
         </p:txBody>
@@ -15170,22 +16575,6 @@
               <a:t>•  Sabés qué campaña trae pacientes</a:t>
             </a:r>
           </a:p>
-          <a:p>
-            <a:pPr algn="l">
-              <a:spcAft>
-                <a:spcPts val="500"/>
-              </a:spcAft>
-            </a:pPr>
-            <a:r>
-              <a:rPr sz="1100" b="0">
-                <a:solidFill>
-                  <a:srgbClr val="0F172A"/>
-                </a:solidFill>
-                <a:latin typeface="Calibri"/>
-              </a:rPr>
-              <a:t>•  Mides retorno por fuente</a:t>
-            </a:r>
-          </a:p>
         </p:txBody>
       </p:sp>
       <p:sp>
@@ -15503,7 +16892,7 @@
                 </a:solidFill>
                 <a:latin typeface="Calibri"/>
               </a:rPr>
-              <a:t>06 / 16</a:t>
+              <a:t>06 / 17</a:t>
             </a:r>
           </a:p>
         </p:txBody>
@@ -15903,7 +17292,7 @@
                 </a:solidFill>
                 <a:latin typeface="Calibri"/>
               </a:rPr>
-              <a:t>En conversación</a:t>
+              <a:t>En conversación humana</a:t>
             </a:r>
           </a:p>
           <a:p>
@@ -16041,7 +17430,7 @@
                 </a:solidFill>
                 <a:latin typeface="Calibri"/>
               </a:rPr>
-              <a:t>Pre-reserva</a:t>
+              <a:t>Pre-reserva / Cita Reservada</a:t>
             </a:r>
           </a:p>
           <a:p>
@@ -16179,7 +17568,7 @@
                 </a:solidFill>
                 <a:latin typeface="Calibri"/>
               </a:rPr>
-              <a:t>Cita Reservada</a:t>
+              <a:t>Cita Confirmada</a:t>
             </a:r>
           </a:p>
           <a:p>
@@ -16317,7 +17706,7 @@
                 </a:solidFill>
                 <a:latin typeface="Calibri"/>
               </a:rPr>
-              <a:t>Cita Confirmada</a:t>
+              <a:t>No Asistió</a:t>
             </a:r>
           </a:p>
           <a:p>
@@ -16455,7 +17844,7 @@
                 </a:solidFill>
                 <a:latin typeface="Calibri"/>
               </a:rPr>
-              <a:t>Servicio</a:t>
+              <a:t>Servicio Realizado (Ganado)</a:t>
             </a:r>
           </a:p>
           <a:p>
@@ -16593,7 +17982,7 @@
                 </a:solidFill>
                 <a:latin typeface="Calibri"/>
               </a:rPr>
-              <a:t>No reservó</a:t>
+              <a:t>Perdido</a:t>
             </a:r>
           </a:p>
           <a:p>
@@ -16770,7 +18159,7 @@
                 </a:solidFill>
                 <a:latin typeface="Calibri"/>
               </a:rPr>
-              <a:t>07 / 16</a:t>
+              <a:t>07 / 17</a:t>
             </a:r>
           </a:p>
         </p:txBody>
@@ -17661,6 +19050,22 @@
                 </a:solidFill>
                 <a:latin typeface="Calibri"/>
               </a:rPr>
+              <a:t>•  Actúa en la etapa Perdido</a:t>
+            </a:r>
+          </a:p>
+          <a:p>
+            <a:pPr algn="l">
+              <a:spcAft>
+                <a:spcPts val="500"/>
+              </a:spcAft>
+            </a:pPr>
+            <a:r>
+              <a:rPr sz="1100" b="0">
+                <a:solidFill>
+                  <a:srgbClr val="0F172A"/>
+                </a:solidFill>
+                <a:latin typeface="Calibri"/>
+              </a:rPr>
               <a:t>•  Recupera al que no agendó</a:t>
             </a:r>
           </a:p>
@@ -17804,7 +19209,7 @@
                 </a:solidFill>
                 <a:latin typeface="Calibri"/>
               </a:rPr>
-              <a:t>Señal / depósito</a:t>
+              <a:t>Handoff a humano</a:t>
             </a:r>
           </a:p>
         </p:txBody>
@@ -17843,7 +19248,7 @@
                 </a:solidFill>
                 <a:latin typeface="Calibri"/>
               </a:rPr>
-              <a:t>•  Valida el pago</a:t>
+              <a:t>•  Deriva a una persona</a:t>
             </a:r>
           </a:p>
           <a:p>
@@ -17859,7 +19264,7 @@
                 </a:solidFill>
                 <a:latin typeface="Calibri"/>
               </a:rPr>
-              <a:t>•  Confirma la cita</a:t>
+              <a:t>•  Pausa el bot y avisa al equipo</a:t>
             </a:r>
           </a:p>
         </p:txBody>
@@ -18163,7 +19568,7 @@
                 </a:solidFill>
                 <a:latin typeface="Calibri"/>
               </a:rPr>
-              <a:t>08 / 16</a:t>
+              <a:t>08 / 17</a:t>
             </a:r>
           </a:p>
         </p:txBody>
@@ -18821,7 +20226,7 @@
                 </a:solidFill>
                 <a:latin typeface="Calibri"/>
               </a:rPr>
-              <a:t>09 / 16</a:t>
+              <a:t>09 / 17</a:t>
             </a:r>
           </a:p>
         </p:txBody>

</xml_diff>

<commit_message>
Deck v4: omnia branding, español de España, productized pricing
- Apply omnia brand: gradient cover/closing (indigo→pink), purple/blue/pink
  accents; "omnia" lowercase, "ómibu" with accent.
- Convert all copy to peninsular Spanish (remove voseo).
- Pricing reworked as a MASSIVE/MVP product (not per-client custom):
  activation 290€ + system 197€/mes; plans Z/S/P/T = 547/827/1.072 €/mes
  (ads markup ~40% over ómibu cost); cotizador's $5,683 used as value anchor.
- Cost/margin table filled with proposed numbers.

Co-Authored-By: Claude Opus 4.8 <noreply@anthropic.com>
Claude-Session: https://claude.ai/code/session_01TgN5d424q32UXmoazQaikt
</commit_message>
<xml_diff>
--- a/presentacion/omnia-sistema-clinicas.pptx
+++ b/presentacion/omnia-sistema-clinicas.pptx
@@ -3118,9 +3118,17 @@
           <a:prstGeom prst="rect">
             <a:avLst/>
           </a:prstGeom>
-          <a:solidFill>
-            <a:srgbClr val="0B1F3A"/>
-          </a:solidFill>
+          <a:gradFill rotWithShape="1">
+            <a:gsLst>
+              <a:gs pos="0">
+                <a:srgbClr val="4F46E5"/>
+              </a:gs>
+              <a:gs pos="100000">
+                <a:srgbClr val="EC4899"/>
+              </a:gs>
+            </a:gsLst>
+            <a:lin scaled="0" ang="19500000"/>
+          </a:gradFill>
           <a:ln>
             <a:noFill/>
           </a:ln>
@@ -3150,51 +3158,7 @@
       </p:sp>
       <p:sp>
         <p:nvSpPr>
-          <p:cNvPr id="3" name="Rectangle 2"/>
-          <p:cNvSpPr/>
-          <p:nvPr/>
-        </p:nvSpPr>
-        <p:spPr>
-          <a:xfrm>
-            <a:off x="0" y="0"/>
-            <a:ext cx="228600" cy="6858000"/>
-          </a:xfrm>
-          <a:prstGeom prst="rect">
-            <a:avLst/>
-          </a:prstGeom>
-          <a:solidFill>
-            <a:srgbClr val="14B8A6"/>
-          </a:solidFill>
-          <a:ln>
-            <a:noFill/>
-          </a:ln>
-          <a:effectLst/>
-        </p:spPr>
-        <p:style>
-          <a:lnRef idx="1">
-            <a:schemeClr val="accent1"/>
-          </a:lnRef>
-          <a:fillRef idx="3">
-            <a:schemeClr val="accent1"/>
-          </a:fillRef>
-          <a:effectRef idx="2">
-            <a:schemeClr val="accent1"/>
-          </a:effectRef>
-          <a:fontRef idx="minor">
-            <a:schemeClr val="lt1"/>
-          </a:fontRef>
-        </p:style>
-        <p:txBody>
-          <a:bodyPr rtlCol="0" anchor="ctr"/>
-          <a:lstStyle/>
-          <a:p>
-            <a:pPr algn="ctr"/>
-          </a:p>
-        </p:txBody>
-      </p:sp>
-      <p:sp>
-        <p:nvSpPr>
-          <p:cNvPr id="4" name="TextBox 3"/>
+          <p:cNvPr id="3" name="TextBox 2"/>
           <p:cNvSpPr txBox="1"/>
           <p:nvPr/>
         </p:nvSpPr>
@@ -3222,7 +3186,7 @@
             <a:r>
               <a:rPr sz="1300" b="1">
                 <a:solidFill>
-                  <a:srgbClr val="14B8A6"/>
+                  <a:srgbClr val="FFFFFF"/>
                 </a:solidFill>
                 <a:latin typeface="Calibri"/>
               </a:rPr>
@@ -3233,7 +3197,7 @@
       </p:sp>
       <p:sp>
         <p:nvSpPr>
-          <p:cNvPr id="5" name="TextBox 4"/>
+          <p:cNvPr id="4" name="TextBox 3"/>
           <p:cNvSpPr txBox="1"/>
           <p:nvPr/>
         </p:nvSpPr>
@@ -3272,7 +3236,7 @@
       </p:sp>
       <p:sp>
         <p:nvSpPr>
-          <p:cNvPr id="6" name="TextBox 5"/>
+          <p:cNvPr id="5" name="TextBox 4"/>
           <p:cNvSpPr txBox="1"/>
           <p:nvPr/>
         </p:nvSpPr>
@@ -3311,7 +3275,7 @@
       </p:sp>
       <p:sp>
         <p:nvSpPr>
-          <p:cNvPr id="7" name="TextBox 6"/>
+          <p:cNvPr id="6" name="TextBox 5"/>
           <p:cNvSpPr txBox="1"/>
           <p:nvPr/>
         </p:nvSpPr>
@@ -3339,7 +3303,7 @@
             <a:r>
               <a:rPr sz="1500" b="0">
                 <a:solidFill>
-                  <a:srgbClr val="14B8A6"/>
+                  <a:srgbClr val="FFFFFF"/>
                 </a:solidFill>
                 <a:latin typeface="Calibri"/>
               </a:rPr>
@@ -3350,7 +3314,7 @@
       </p:sp>
       <p:sp>
         <p:nvSpPr>
-          <p:cNvPr id="8" name="TextBox 7"/>
+          <p:cNvPr id="7" name="TextBox 6"/>
           <p:cNvSpPr txBox="1"/>
           <p:nvPr/>
         </p:nvSpPr>
@@ -3420,7 +3384,7 @@
             <a:avLst/>
           </a:prstGeom>
           <a:solidFill>
-            <a:srgbClr val="14B8A6"/>
+            <a:srgbClr val="9A3CE0"/>
           </a:solidFill>
           <a:ln>
             <a:noFill/>
@@ -3479,7 +3443,7 @@
             <a:r>
               <a:rPr sz="1100" b="1">
                 <a:solidFill>
-                  <a:srgbClr val="14B8A6"/>
+                  <a:srgbClr val="9A3CE0"/>
                 </a:solidFill>
                 <a:latin typeface="Calibri"/>
               </a:rPr>
@@ -3518,7 +3482,7 @@
             <a:r>
               <a:rPr sz="2900" b="1">
                 <a:solidFill>
-                  <a:srgbClr val="0B1F3A"/>
+                  <a:srgbClr val="14102B"/>
                 </a:solidFill>
                 <a:latin typeface="Calibri"/>
               </a:rPr>
@@ -3581,7 +3545,7 @@
             <a:avLst/>
           </a:prstGeom>
           <a:solidFill>
-            <a:srgbClr val="F1F5F9"/>
+            <a:srgbClr val="F3F1FB"/>
           </a:solidFill>
           <a:ln>
             <a:noFill/>
@@ -3625,7 +3589,7 @@
             <a:avLst/>
           </a:prstGeom>
           <a:solidFill>
-            <a:srgbClr val="2563EB"/>
+            <a:srgbClr val="4F46E5"/>
           </a:solidFill>
           <a:ln>
             <a:noFill/>
@@ -3684,7 +3648,7 @@
             <a:r>
               <a:rPr sz="1400" b="1">
                 <a:solidFill>
-                  <a:srgbClr val="0B1F3A"/>
+                  <a:srgbClr val="14102B"/>
                 </a:solidFill>
                 <a:latin typeface="Calibri"/>
               </a:rPr>
@@ -3779,7 +3743,7 @@
             <a:avLst/>
           </a:prstGeom>
           <a:solidFill>
-            <a:srgbClr val="F1F5F9"/>
+            <a:srgbClr val="F3F1FB"/>
           </a:solidFill>
           <a:ln>
             <a:noFill/>
@@ -3823,7 +3787,7 @@
             <a:avLst/>
           </a:prstGeom>
           <a:solidFill>
-            <a:srgbClr val="14B8A6"/>
+            <a:srgbClr val="9A3CE0"/>
           </a:solidFill>
           <a:ln>
             <a:noFill/>
@@ -3882,7 +3846,7 @@
             <a:r>
               <a:rPr sz="1400" b="1">
                 <a:solidFill>
-                  <a:srgbClr val="0B1F3A"/>
+                  <a:srgbClr val="14102B"/>
                 </a:solidFill>
                 <a:latin typeface="Calibri"/>
               </a:rPr>
@@ -3977,7 +3941,7 @@
             <a:avLst/>
           </a:prstGeom>
           <a:solidFill>
-            <a:srgbClr val="F1F5F9"/>
+            <a:srgbClr val="F3F1FB"/>
           </a:solidFill>
           <a:ln>
             <a:noFill/>
@@ -4021,7 +3985,7 @@
             <a:avLst/>
           </a:prstGeom>
           <a:solidFill>
-            <a:srgbClr val="2563EB"/>
+            <a:srgbClr val="4F46E5"/>
           </a:solidFill>
           <a:ln>
             <a:noFill/>
@@ -4080,7 +4044,7 @@
             <a:r>
               <a:rPr sz="1400" b="1">
                 <a:solidFill>
-                  <a:srgbClr val="0B1F3A"/>
+                  <a:srgbClr val="14102B"/>
                 </a:solidFill>
                 <a:latin typeface="Calibri"/>
               </a:rPr>
@@ -4175,7 +4139,7 @@
             <a:avLst/>
           </a:prstGeom>
           <a:solidFill>
-            <a:srgbClr val="F1F5F9"/>
+            <a:srgbClr val="F3F1FB"/>
           </a:solidFill>
           <a:ln>
             <a:noFill/>
@@ -4315,7 +4279,7 @@
             <a:avLst/>
           </a:prstGeom>
           <a:solidFill>
-            <a:srgbClr val="14B8A6"/>
+            <a:srgbClr val="9A3CE0"/>
           </a:solidFill>
           <a:ln>
             <a:noFill/>
@@ -4374,7 +4338,7 @@
             <a:r>
               <a:rPr sz="1100" b="1">
                 <a:solidFill>
-                  <a:srgbClr val="14B8A6"/>
+                  <a:srgbClr val="9A3CE0"/>
                 </a:solidFill>
                 <a:latin typeface="Calibri"/>
               </a:rPr>
@@ -4413,7 +4377,7 @@
             <a:r>
               <a:rPr sz="2900" b="1">
                 <a:solidFill>
-                  <a:srgbClr val="0B1F3A"/>
+                  <a:srgbClr val="14102B"/>
                 </a:solidFill>
                 <a:latin typeface="Calibri"/>
               </a:rPr>
@@ -4476,7 +4440,7 @@
             <a:avLst/>
           </a:prstGeom>
           <a:solidFill>
-            <a:srgbClr val="F1F5F9"/>
+            <a:srgbClr val="F3F1FB"/>
           </a:solidFill>
           <a:ln>
             <a:noFill/>
@@ -4520,7 +4484,7 @@
             <a:avLst/>
           </a:prstGeom>
           <a:solidFill>
-            <a:srgbClr val="14B8A6"/>
+            <a:srgbClr val="9A3CE0"/>
           </a:solidFill>
           <a:ln>
             <a:noFill/>
@@ -4579,7 +4543,7 @@
             <a:r>
               <a:rPr sz="1400" b="1">
                 <a:solidFill>
-                  <a:srgbClr val="0B1F3A"/>
+                  <a:srgbClr val="14102B"/>
                 </a:solidFill>
                 <a:latin typeface="Calibri"/>
               </a:rPr>
@@ -4690,7 +4654,7 @@
             <a:avLst/>
           </a:prstGeom>
           <a:solidFill>
-            <a:srgbClr val="F1F5F9"/>
+            <a:srgbClr val="F3F1FB"/>
           </a:solidFill>
           <a:ln>
             <a:noFill/>
@@ -4734,7 +4698,7 @@
             <a:avLst/>
           </a:prstGeom>
           <a:solidFill>
-            <a:srgbClr val="2563EB"/>
+            <a:srgbClr val="4F46E5"/>
           </a:solidFill>
           <a:ln>
             <a:noFill/>
@@ -4793,7 +4757,7 @@
             <a:r>
               <a:rPr sz="1400" b="1">
                 <a:solidFill>
-                  <a:srgbClr val="0B1F3A"/>
+                  <a:srgbClr val="14102B"/>
                 </a:solidFill>
                 <a:latin typeface="Calibri"/>
               </a:rPr>
@@ -4904,7 +4868,7 @@
             <a:avLst/>
           </a:prstGeom>
           <a:solidFill>
-            <a:srgbClr val="F1F5F9"/>
+            <a:srgbClr val="F3F1FB"/>
           </a:solidFill>
           <a:ln>
             <a:noFill/>
@@ -4948,7 +4912,7 @@
             <a:avLst/>
           </a:prstGeom>
           <a:solidFill>
-            <a:srgbClr val="14B8A6"/>
+            <a:srgbClr val="9A3CE0"/>
           </a:solidFill>
           <a:ln>
             <a:noFill/>
@@ -5007,7 +4971,7 @@
             <a:r>
               <a:rPr sz="1400" b="1">
                 <a:solidFill>
-                  <a:srgbClr val="0B1F3A"/>
+                  <a:srgbClr val="14102B"/>
                 </a:solidFill>
                 <a:latin typeface="Calibri"/>
               </a:rPr>
@@ -5118,7 +5082,7 @@
             <a:avLst/>
           </a:prstGeom>
           <a:solidFill>
-            <a:srgbClr val="F1F5F9"/>
+            <a:srgbClr val="F3F1FB"/>
           </a:solidFill>
           <a:ln>
             <a:noFill/>
@@ -5258,7 +5222,7 @@
             <a:avLst/>
           </a:prstGeom>
           <a:solidFill>
-            <a:srgbClr val="14B8A6"/>
+            <a:srgbClr val="9A3CE0"/>
           </a:solidFill>
           <a:ln>
             <a:noFill/>
@@ -5317,7 +5281,7 @@
             <a:r>
               <a:rPr sz="1100" b="1">
                 <a:solidFill>
-                  <a:srgbClr val="14B8A6"/>
+                  <a:srgbClr val="9A3CE0"/>
                 </a:solidFill>
                 <a:latin typeface="Calibri"/>
               </a:rPr>
@@ -5356,7 +5320,7 @@
             <a:r>
               <a:rPr sz="2900" b="1">
                 <a:solidFill>
-                  <a:srgbClr val="0B1F3A"/>
+                  <a:srgbClr val="14102B"/>
                 </a:solidFill>
                 <a:latin typeface="Calibri"/>
               </a:rPr>
@@ -5419,7 +5383,7 @@
             <a:avLst/>
           </a:prstGeom>
           <a:solidFill>
-            <a:srgbClr val="F1F5F9"/>
+            <a:srgbClr val="F3F1FB"/>
           </a:solidFill>
           <a:ln>
             <a:noFill/>
@@ -5626,7 +5590,7 @@
             <a:avLst/>
           </a:prstGeom>
           <a:solidFill>
-            <a:srgbClr val="F1F5F9"/>
+            <a:srgbClr val="F3F1FB"/>
           </a:solidFill>
           <a:ln>
             <a:noFill/>
@@ -5670,7 +5634,7 @@
             <a:avLst/>
           </a:prstGeom>
           <a:solidFill>
-            <a:srgbClr val="14B8A6"/>
+            <a:srgbClr val="9A3CE0"/>
           </a:solidFill>
           <a:ln>
             <a:noFill/>
@@ -5729,7 +5693,7 @@
             <a:r>
               <a:rPr sz="1500" b="1">
                 <a:solidFill>
-                  <a:srgbClr val="14B8A6"/>
+                  <a:srgbClr val="9A3CE0"/>
                 </a:solidFill>
                 <a:latin typeface="Calibri"/>
               </a:rPr>
@@ -5833,7 +5797,7 @@
             <a:avLst/>
           </a:prstGeom>
           <a:solidFill>
-            <a:srgbClr val="F1F5F9"/>
+            <a:srgbClr val="F3F1FB"/>
           </a:solidFill>
           <a:ln>
             <a:noFill/>
@@ -5973,7 +5937,7 @@
             <a:avLst/>
           </a:prstGeom>
           <a:solidFill>
-            <a:srgbClr val="14B8A6"/>
+            <a:srgbClr val="9A3CE0"/>
           </a:solidFill>
           <a:ln>
             <a:noFill/>
@@ -6032,7 +5996,7 @@
             <a:r>
               <a:rPr sz="1100" b="1">
                 <a:solidFill>
-                  <a:srgbClr val="14B8A6"/>
+                  <a:srgbClr val="9A3CE0"/>
                 </a:solidFill>
                 <a:latin typeface="Calibri"/>
               </a:rPr>
@@ -6071,7 +6035,7 @@
             <a:r>
               <a:rPr sz="2900" b="1">
                 <a:solidFill>
-                  <a:srgbClr val="0B1F3A"/>
+                  <a:srgbClr val="14102B"/>
                 </a:solidFill>
                 <a:latin typeface="Calibri"/>
               </a:rPr>
@@ -6128,13 +6092,13 @@
         <p:spPr>
           <a:xfrm>
             <a:off x="502920" y="2286000"/>
-            <a:ext cx="2583179" cy="2606040"/>
+            <a:ext cx="2583179" cy="2468880"/>
           </a:xfrm>
           <a:prstGeom prst="roundRect">
             <a:avLst/>
           </a:prstGeom>
           <a:solidFill>
-            <a:srgbClr val="F1F5F9"/>
+            <a:srgbClr val="F3F1FB"/>
           </a:solidFill>
           <a:ln>
             <a:noFill/>
@@ -6178,7 +6142,7 @@
             <a:avLst/>
           </a:prstGeom>
           <a:solidFill>
-            <a:srgbClr val="2563EB"/>
+            <a:srgbClr val="4F46E5"/>
           </a:solidFill>
           <a:ln>
             <a:noFill/>
@@ -6237,7 +6201,7 @@
             <a:r>
               <a:rPr sz="1400" b="1">
                 <a:solidFill>
-                  <a:srgbClr val="0B1F3A"/>
+                  <a:srgbClr val="14102B"/>
                 </a:solidFill>
                 <a:latin typeface="Calibri"/>
               </a:rPr>
@@ -6255,7 +6219,7 @@
         <p:spPr>
           <a:xfrm>
             <a:off x="685800" y="3200400"/>
-            <a:ext cx="2217420" cy="1554480"/>
+            <a:ext cx="2217420" cy="1417320"/>
           </a:xfrm>
           <a:prstGeom prst="rect">
             <a:avLst/>
@@ -6280,7 +6244,7 @@
                 </a:solidFill>
                 <a:latin typeface="Calibri"/>
               </a:rPr>
-              <a:t>•  Ads: 250 €/mes</a:t>
+              <a:t>•  547 €/mes</a:t>
             </a:r>
           </a:p>
           <a:p>
@@ -6296,7 +6260,7 @@
                 </a:solidFill>
                 <a:latin typeface="Calibri"/>
               </a:rPr>
-              <a:t>•  1 canal (Google o Meta)</a:t>
+              <a:t>•  Ads 1 canal (Google o Meta)</a:t>
             </a:r>
           </a:p>
           <a:p>
@@ -6312,23 +6276,23 @@
                 </a:solidFill>
                 <a:latin typeface="Calibri"/>
               </a:rPr>
+              <a:t>•  Sistema omnia incluido</a:t>
+            </a:r>
+          </a:p>
+          <a:p>
+            <a:pPr algn="l">
+              <a:spcAft>
+                <a:spcPts val="500"/>
+              </a:spcAft>
+            </a:pPr>
+            <a:r>
+              <a:rPr sz="1100" b="0">
+                <a:solidFill>
+                  <a:srgbClr val="0F172A"/>
+                </a:solidFill>
+                <a:latin typeface="Calibri"/>
+              </a:rPr>
               <a:t>•  Campañas de leads</a:t>
-            </a:r>
-          </a:p>
-          <a:p>
-            <a:pPr algn="l">
-              <a:spcAft>
-                <a:spcPts val="500"/>
-              </a:spcAft>
-            </a:pPr>
-            <a:r>
-              <a:rPr sz="1100" b="0">
-                <a:solidFill>
-                  <a:srgbClr val="0F172A"/>
-                </a:solidFill>
-                <a:latin typeface="Calibri"/>
-              </a:rPr>
-              <a:t>•  + Sistema omnia (impl. + mensual)</a:t>
             </a:r>
           </a:p>
         </p:txBody>
@@ -6342,13 +6306,13 @@
         <p:spPr>
           <a:xfrm>
             <a:off x="3360420" y="2286000"/>
-            <a:ext cx="2583179" cy="2606040"/>
+            <a:ext cx="2583179" cy="2468880"/>
           </a:xfrm>
           <a:prstGeom prst="roundRect">
             <a:avLst/>
           </a:prstGeom>
           <a:solidFill>
-            <a:srgbClr val="F1F5F9"/>
+            <a:srgbClr val="F3F1FB"/>
           </a:solidFill>
           <a:ln>
             <a:noFill/>
@@ -6392,7 +6356,7 @@
             <a:avLst/>
           </a:prstGeom>
           <a:solidFill>
-            <a:srgbClr val="14B8A6"/>
+            <a:srgbClr val="9A3CE0"/>
           </a:solidFill>
           <a:ln>
             <a:noFill/>
@@ -6451,7 +6415,7 @@
             <a:r>
               <a:rPr sz="1400" b="1">
                 <a:solidFill>
-                  <a:srgbClr val="0B1F3A"/>
+                  <a:srgbClr val="14102B"/>
                 </a:solidFill>
                 <a:latin typeface="Calibri"/>
               </a:rPr>
@@ -6469,7 +6433,7 @@
         <p:spPr>
           <a:xfrm>
             <a:off x="3543300" y="3200400"/>
-            <a:ext cx="2217420" cy="1554480"/>
+            <a:ext cx="2217420" cy="1417320"/>
           </a:xfrm>
           <a:prstGeom prst="rect">
             <a:avLst/>
@@ -6494,7 +6458,7 @@
                 </a:solidFill>
                 <a:latin typeface="Calibri"/>
               </a:rPr>
-              <a:t>•  Ads: 450 €/mes</a:t>
+              <a:t>•  827 €/mes</a:t>
             </a:r>
           </a:p>
           <a:p>
@@ -6510,7 +6474,7 @@
                 </a:solidFill>
                 <a:latin typeface="Calibri"/>
               </a:rPr>
-              <a:t>•  Más campañas / 2 canales</a:t>
+              <a:t>•  Ads 2 canales + analítica</a:t>
             </a:r>
           </a:p>
           <a:p>
@@ -6526,7 +6490,7 @@
                 </a:solidFill>
                 <a:latin typeface="Calibri"/>
               </a:rPr>
-              <a:t>•  + Analítica de leads</a:t>
+              <a:t>•  Sistema omnia incluido</a:t>
             </a:r>
           </a:p>
           <a:p>
@@ -6542,7 +6506,7 @@
                 </a:solidFill>
                 <a:latin typeface="Calibri"/>
               </a:rPr>
-              <a:t>•  + Sistema omnia (impl. + mensual)</a:t>
+              <a:t>•  Más campañas</a:t>
             </a:r>
           </a:p>
         </p:txBody>
@@ -6556,13 +6520,13 @@
         <p:spPr>
           <a:xfrm>
             <a:off x="6217919" y="2286000"/>
-            <a:ext cx="2583179" cy="2606040"/>
+            <a:ext cx="2583179" cy="2468880"/>
           </a:xfrm>
           <a:prstGeom prst="roundRect">
             <a:avLst/>
           </a:prstGeom>
           <a:solidFill>
-            <a:srgbClr val="F1F5F9"/>
+            <a:srgbClr val="F3F1FB"/>
           </a:solidFill>
           <a:ln>
             <a:noFill/>
@@ -6606,7 +6570,7 @@
             <a:avLst/>
           </a:prstGeom>
           <a:solidFill>
-            <a:srgbClr val="2563EB"/>
+            <a:srgbClr val="4F46E5"/>
           </a:solidFill>
           <a:ln>
             <a:noFill/>
@@ -6665,7 +6629,7 @@
             <a:r>
               <a:rPr sz="1400" b="1">
                 <a:solidFill>
-                  <a:srgbClr val="0B1F3A"/>
+                  <a:srgbClr val="14102B"/>
                 </a:solidFill>
                 <a:latin typeface="Calibri"/>
               </a:rPr>
@@ -6683,7 +6647,7 @@
         <p:spPr>
           <a:xfrm>
             <a:off x="6400799" y="3200400"/>
-            <a:ext cx="2217420" cy="1554480"/>
+            <a:ext cx="2217420" cy="1417320"/>
           </a:xfrm>
           <a:prstGeom prst="rect">
             <a:avLst/>
@@ -6708,7 +6672,7 @@
                 </a:solidFill>
                 <a:latin typeface="Calibri"/>
               </a:rPr>
-              <a:t>•  Ads: 625 €/mes</a:t>
+              <a:t>•  1.072 €/mes</a:t>
             </a:r>
           </a:p>
           <a:p>
@@ -6724,7 +6688,7 @@
                 </a:solidFill>
                 <a:latin typeface="Calibri"/>
               </a:rPr>
-              <a:t>•  Gestión avanzada</a:t>
+              <a:t>•  Gestión avanzada + redistribución</a:t>
             </a:r>
           </a:p>
           <a:p>
@@ -6740,7 +6704,7 @@
                 </a:solidFill>
                 <a:latin typeface="Calibri"/>
               </a:rPr>
-              <a:t>•  + Redistribución de presupuesto</a:t>
+              <a:t>•  Sistema omnia incluido</a:t>
             </a:r>
           </a:p>
           <a:p>
@@ -6756,7 +6720,7 @@
                 </a:solidFill>
                 <a:latin typeface="Calibri"/>
               </a:rPr>
-              <a:t>•  + Sistema omnia (impl. + mensual)</a:t>
+              <a:t>•  Reporting</a:t>
             </a:r>
           </a:p>
         </p:txBody>
@@ -6770,13 +6734,13 @@
         <p:spPr>
           <a:xfrm>
             <a:off x="9075419" y="2286000"/>
-            <a:ext cx="2583179" cy="2606040"/>
+            <a:ext cx="2583179" cy="2468880"/>
           </a:xfrm>
           <a:prstGeom prst="roundRect">
             <a:avLst/>
           </a:prstGeom>
           <a:solidFill>
-            <a:srgbClr val="F1F5F9"/>
+            <a:srgbClr val="F3F1FB"/>
           </a:solidFill>
           <a:ln>
             <a:noFill/>
@@ -6820,7 +6784,7 @@
             <a:avLst/>
           </a:prstGeom>
           <a:solidFill>
-            <a:srgbClr val="14B8A6"/>
+            <a:srgbClr val="9A3CE0"/>
           </a:solidFill>
           <a:ln>
             <a:noFill/>
@@ -6879,7 +6843,7 @@
             <a:r>
               <a:rPr sz="1400" b="1">
                 <a:solidFill>
-                  <a:srgbClr val="0B1F3A"/>
+                  <a:srgbClr val="14102B"/>
                 </a:solidFill>
                 <a:latin typeface="Calibri"/>
               </a:rPr>
@@ -6897,7 +6861,7 @@
         <p:spPr>
           <a:xfrm>
             <a:off x="9258299" y="3200400"/>
-            <a:ext cx="2217420" cy="1554480"/>
+            <a:ext cx="2217420" cy="1417320"/>
           </a:xfrm>
           <a:prstGeom prst="rect">
             <a:avLst/>
@@ -6922,7 +6886,7 @@
                 </a:solidFill>
                 <a:latin typeface="Calibri"/>
               </a:rPr>
-              <a:t>•  Ads: a medida</a:t>
+              <a:t>•  a medida</a:t>
             </a:r>
           </a:p>
           <a:p>
@@ -6954,7 +6918,7 @@
                 </a:solidFill>
                 <a:latin typeface="Calibri"/>
               </a:rPr>
-              <a:t>•  + Reporting a medida</a:t>
+              <a:t>•  Sistema omnia incluido</a:t>
             </a:r>
           </a:p>
           <a:p>
@@ -6970,7 +6934,7 @@
                 </a:solidFill>
                 <a:latin typeface="Calibri"/>
               </a:rPr>
-              <a:t>•  + Sistema omnia (impl. + mensual)</a:t>
+              <a:t>•  A medida</a:t>
             </a:r>
           </a:p>
         </p:txBody>
@@ -6983,8 +6947,8 @@
         </p:nvSpPr>
         <p:spPr>
           <a:xfrm>
-            <a:off x="502920" y="5029200"/>
-            <a:ext cx="11155680" cy="658368"/>
+            <a:off x="502920" y="4892040"/>
+            <a:ext cx="11155680" cy="777240"/>
           </a:xfrm>
           <a:prstGeom prst="roundRect">
             <a:avLst/>
@@ -7027,8 +6991,8 @@
         </p:nvSpPr>
         <p:spPr>
           <a:xfrm>
-            <a:off x="685800" y="5093208"/>
-            <a:ext cx="10789920" cy="548640"/>
+            <a:off x="685800" y="4956048"/>
+            <a:ext cx="10789920" cy="685800"/>
           </a:xfrm>
           <a:prstGeom prst="rect">
             <a:avLst/>
@@ -7047,13 +7011,13 @@
               </a:spcAft>
             </a:pPr>
             <a:r>
-              <a:rPr sz="1100" b="1">
+              <a:rPr sz="1050" b="1">
                 <a:solidFill>
                   <a:srgbClr val="92400E"/>
                 </a:solidFill>
                 <a:latin typeface="Calibri"/>
               </a:rPr>
-              <a:t>Sistema omnia = implementación única + mensualidad.  Aparte: inversión en ads (mín. 300 €/camp.) </a:t>
+              <a:t>Activación única 290 € · sistema 197 €/mes (ya incluido en el plan).  A medida costaría 5.683 $ (cotizador): con omnia, productizado.</a:t>
             </a:r>
           </a:p>
           <a:p>
@@ -7063,13 +7027,13 @@
               </a:spcAft>
             </a:pPr>
             <a:r>
-              <a:rPr sz="1100" b="0">
+              <a:rPr sz="1050" b="0">
                 <a:solidFill>
                   <a:srgbClr val="92400E"/>
                 </a:solidFill>
                 <a:latin typeface="Calibri"/>
               </a:rPr>
-              <a:t>+ costos de comunicación (WhatsApp, email, IA) según consumo.  Precio final al cliente: a definir (ver slides internas).</a:t>
+              <a:t>Aparte: inversión publicitaria (desde 300 €/camp.) + comunicación (WhatsApp/email/IA) según consumo.  Precios propuestos (+IVA), a validar.</a:t>
             </a:r>
           </a:p>
         </p:txBody>
@@ -7089,7 +7053,7 @@
             <a:avLst/>
           </a:prstGeom>
           <a:solidFill>
-            <a:srgbClr val="F1F5F9"/>
+            <a:srgbClr val="F3F1FB"/>
           </a:solidFill>
           <a:ln>
             <a:noFill/>
@@ -7229,7 +7193,7 @@
             <a:avLst/>
           </a:prstGeom>
           <a:solidFill>
-            <a:srgbClr val="14B8A6"/>
+            <a:srgbClr val="9A3CE0"/>
           </a:solidFill>
           <a:ln>
             <a:noFill/>
@@ -7288,7 +7252,7 @@
             <a:r>
               <a:rPr sz="1100" b="1">
                 <a:solidFill>
-                  <a:srgbClr val="14B8A6"/>
+                  <a:srgbClr val="9A3CE0"/>
                 </a:solidFill>
                 <a:latin typeface="Calibri"/>
               </a:rPr>
@@ -7327,7 +7291,7 @@
             <a:r>
               <a:rPr sz="2900" b="1">
                 <a:solidFill>
-                  <a:srgbClr val="0B1F3A"/>
+                  <a:srgbClr val="14102B"/>
                 </a:solidFill>
                 <a:latin typeface="Calibri"/>
               </a:rPr>
@@ -7390,7 +7354,7 @@
             <a:avLst/>
           </a:prstGeom>
           <a:solidFill>
-            <a:srgbClr val="F1F5F9"/>
+            <a:srgbClr val="F3F1FB"/>
           </a:solidFill>
           <a:ln>
             <a:noFill/>
@@ -7449,7 +7413,7 @@
             <a:r>
               <a:rPr sz="1250" b="1">
                 <a:solidFill>
-                  <a:srgbClr val="0B1F3A"/>
+                  <a:srgbClr val="14102B"/>
                 </a:solidFill>
                 <a:latin typeface="Calibri"/>
               </a:rPr>
@@ -7505,7 +7469,7 @@
             <a:r>
               <a:rPr sz="1800" b="1">
                 <a:solidFill>
-                  <a:srgbClr val="14B8A6"/>
+                  <a:srgbClr val="9A3CE0"/>
                 </a:solidFill>
                 <a:latin typeface="Calibri"/>
               </a:rPr>
@@ -7529,7 +7493,7 @@
             <a:avLst/>
           </a:prstGeom>
           <a:solidFill>
-            <a:srgbClr val="F1F5F9"/>
+            <a:srgbClr val="F3F1FB"/>
           </a:solidFill>
           <a:ln>
             <a:noFill/>
@@ -7588,7 +7552,7 @@
             <a:r>
               <a:rPr sz="1250" b="1">
                 <a:solidFill>
-                  <a:srgbClr val="0B1F3A"/>
+                  <a:srgbClr val="14102B"/>
                 </a:solidFill>
                 <a:latin typeface="Calibri"/>
               </a:rPr>
@@ -7644,7 +7608,7 @@
             <a:r>
               <a:rPr sz="1800" b="1">
                 <a:solidFill>
-                  <a:srgbClr val="14B8A6"/>
+                  <a:srgbClr val="9A3CE0"/>
                 </a:solidFill>
                 <a:latin typeface="Calibri"/>
               </a:rPr>
@@ -7668,7 +7632,7 @@
             <a:avLst/>
           </a:prstGeom>
           <a:solidFill>
-            <a:srgbClr val="F1F5F9"/>
+            <a:srgbClr val="F3F1FB"/>
           </a:solidFill>
           <a:ln>
             <a:noFill/>
@@ -7727,7 +7691,7 @@
             <a:r>
               <a:rPr sz="1250" b="1">
                 <a:solidFill>
-                  <a:srgbClr val="0B1F3A"/>
+                  <a:srgbClr val="14102B"/>
                 </a:solidFill>
                 <a:latin typeface="Calibri"/>
               </a:rPr>
@@ -7807,7 +7771,7 @@
             <a:avLst/>
           </a:prstGeom>
           <a:solidFill>
-            <a:srgbClr val="F1F5F9"/>
+            <a:srgbClr val="F3F1FB"/>
           </a:solidFill>
           <a:ln>
             <a:noFill/>
@@ -7947,7 +7911,7 @@
             <a:avLst/>
           </a:prstGeom>
           <a:solidFill>
-            <a:srgbClr val="14B8A6"/>
+            <a:srgbClr val="9A3CE0"/>
           </a:solidFill>
           <a:ln>
             <a:noFill/>
@@ -8006,7 +7970,7 @@
             <a:r>
               <a:rPr sz="1100" b="1">
                 <a:solidFill>
-                  <a:srgbClr val="14B8A6"/>
+                  <a:srgbClr val="9A3CE0"/>
                 </a:solidFill>
                 <a:latin typeface="Calibri"/>
               </a:rPr>
@@ -8045,11 +8009,11 @@
             <a:r>
               <a:rPr sz="2900" b="1">
                 <a:solidFill>
-                  <a:srgbClr val="0B1F3A"/>
-                </a:solidFill>
-                <a:latin typeface="Calibri"/>
-              </a:rPr>
-              <a:t>Estructura por nivel (a completar)</a:t>
+                  <a:srgbClr val="14102B"/>
+                </a:solidFill>
+                <a:latin typeface="Calibri"/>
+              </a:rPr>
+              <a:t>Estructura por nivel (propuesta)</a:t>
             </a:r>
           </a:p>
         </p:txBody>
@@ -8088,7 +8052,7 @@
                 </a:solidFill>
                 <a:latin typeface="Calibri"/>
               </a:rPr>
-              <a:t>Uso interno —  costos ómibu reales; precio al cliente y margen los define omnia.</a:t>
+              <a:t>Uso interno —  costos ómibu reales + precios producto propuestos. Validar.</a:t>
             </a:r>
           </a:p>
         </p:txBody>
@@ -8102,13 +8066,13 @@
         <p:spPr>
           <a:xfrm>
             <a:off x="502920" y="2240280"/>
-            <a:ext cx="2103120" cy="457200"/>
+            <a:ext cx="1783080" cy="457200"/>
           </a:xfrm>
           <a:prstGeom prst="rect">
             <a:avLst/>
           </a:prstGeom>
           <a:solidFill>
-            <a:srgbClr val="0B1F3A"/>
+            <a:srgbClr val="14102B"/>
           </a:solidFill>
           <a:ln>
             <a:noFill/>
@@ -8145,8 +8109,8 @@
         </p:nvSpPr>
         <p:spPr>
           <a:xfrm>
-            <a:off x="566928" y="2240280"/>
-            <a:ext cx="1975103" cy="457200"/>
+            <a:off x="557784" y="2240280"/>
+            <a:ext cx="1673352" cy="457200"/>
           </a:xfrm>
           <a:prstGeom prst="rect">
             <a:avLst/>
@@ -8165,7 +8129,7 @@
               </a:spcAft>
             </a:pPr>
             <a:r>
-              <a:rPr sz="950" b="1">
+              <a:rPr sz="900" b="1">
                 <a:solidFill>
                   <a:srgbClr val="FFFFFF"/>
                 </a:solidFill>
@@ -8184,14 +8148,14 @@
         </p:nvSpPr>
         <p:spPr>
           <a:xfrm>
-            <a:off x="2606039" y="2240280"/>
-            <a:ext cx="2011680" cy="457200"/>
+            <a:off x="2286000" y="2240280"/>
+            <a:ext cx="1874519" cy="457200"/>
           </a:xfrm>
           <a:prstGeom prst="rect">
             <a:avLst/>
           </a:prstGeom>
           <a:solidFill>
-            <a:srgbClr val="0B1F3A"/>
+            <a:srgbClr val="14102B"/>
           </a:solidFill>
           <a:ln>
             <a:noFill/>
@@ -8228,8 +8192,8 @@
         </p:nvSpPr>
         <p:spPr>
           <a:xfrm>
-            <a:off x="2670047" y="2240280"/>
-            <a:ext cx="1883664" cy="457200"/>
+            <a:off x="2340864" y="2240280"/>
+            <a:ext cx="1764791" cy="457200"/>
           </a:xfrm>
           <a:prstGeom prst="rect">
             <a:avLst/>
@@ -8248,13 +8212,13 @@
               </a:spcAft>
             </a:pPr>
             <a:r>
-              <a:rPr sz="950" b="1">
+              <a:rPr sz="900" b="1">
                 <a:solidFill>
                   <a:srgbClr val="FFFFFF"/>
                 </a:solidFill>
                 <a:latin typeface="Calibri"/>
               </a:rPr>
-              <a:t>Ads (costo ómibu)</a:t>
+              <a:t>Costo ads (ómibu)</a:t>
             </a:r>
           </a:p>
         </p:txBody>
@@ -8267,14 +8231,14 @@
         </p:nvSpPr>
         <p:spPr>
           <a:xfrm>
-            <a:off x="4617720" y="2240280"/>
-            <a:ext cx="1920240" cy="457200"/>
+            <a:off x="4160520" y="2240280"/>
+            <a:ext cx="1691640" cy="457200"/>
           </a:xfrm>
           <a:prstGeom prst="rect">
             <a:avLst/>
           </a:prstGeom>
           <a:solidFill>
-            <a:srgbClr val="0B1F3A"/>
+            <a:srgbClr val="14102B"/>
           </a:solidFill>
           <a:ln>
             <a:noFill/>
@@ -8311,8 +8275,8 @@
         </p:nvSpPr>
         <p:spPr>
           <a:xfrm>
-            <a:off x="4681728" y="2240280"/>
-            <a:ext cx="1792224" cy="457200"/>
+            <a:off x="4215383" y="2240280"/>
+            <a:ext cx="1581912" cy="457200"/>
           </a:xfrm>
           <a:prstGeom prst="rect">
             <a:avLst/>
@@ -8331,13 +8295,13 @@
               </a:spcAft>
             </a:pPr>
             <a:r>
-              <a:rPr sz="950" b="1">
+              <a:rPr sz="900" b="1">
                 <a:solidFill>
                   <a:srgbClr val="FFFFFF"/>
                 </a:solidFill>
                 <a:latin typeface="Calibri"/>
               </a:rPr>
-              <a:t>Sistema omnia /mes</a:t>
+              <a:t>Precio ads</a:t>
             </a:r>
           </a:p>
         </p:txBody>
@@ -8350,14 +8314,14 @@
         </p:nvSpPr>
         <p:spPr>
           <a:xfrm>
-            <a:off x="6537960" y="2240280"/>
-            <a:ext cx="1828800" cy="457200"/>
+            <a:off x="5852160" y="2240280"/>
+            <a:ext cx="1691640" cy="457200"/>
           </a:xfrm>
           <a:prstGeom prst="rect">
             <a:avLst/>
           </a:prstGeom>
           <a:solidFill>
-            <a:srgbClr val="0B1F3A"/>
+            <a:srgbClr val="14102B"/>
           </a:solidFill>
           <a:ln>
             <a:noFill/>
@@ -8394,8 +8358,8 @@
         </p:nvSpPr>
         <p:spPr>
           <a:xfrm>
-            <a:off x="6601968" y="2240280"/>
-            <a:ext cx="1700784" cy="457200"/>
+            <a:off x="5907024" y="2240280"/>
+            <a:ext cx="1581912" cy="457200"/>
           </a:xfrm>
           <a:prstGeom prst="rect">
             <a:avLst/>
@@ -8414,13 +8378,13 @@
               </a:spcAft>
             </a:pPr>
             <a:r>
-              <a:rPr sz="950" b="1">
+              <a:rPr sz="900" b="1">
                 <a:solidFill>
                   <a:srgbClr val="FFFFFF"/>
                 </a:solidFill>
                 <a:latin typeface="Calibri"/>
               </a:rPr>
-              <a:t>Comunicación</a:t>
+              <a:t>Sistema /mes</a:t>
             </a:r>
           </a:p>
         </p:txBody>
@@ -8433,14 +8397,14 @@
         </p:nvSpPr>
         <p:spPr>
           <a:xfrm>
-            <a:off x="8366760" y="2240280"/>
-            <a:ext cx="1737360" cy="457200"/>
+            <a:off x="7543800" y="2240280"/>
+            <a:ext cx="2057400" cy="457200"/>
           </a:xfrm>
           <a:prstGeom prst="rect">
             <a:avLst/>
           </a:prstGeom>
           <a:solidFill>
-            <a:srgbClr val="0B1F3A"/>
+            <a:srgbClr val="14102B"/>
           </a:solidFill>
           <a:ln>
             <a:noFill/>
@@ -8477,8 +8441,8 @@
         </p:nvSpPr>
         <p:spPr>
           <a:xfrm>
-            <a:off x="8430768" y="2240280"/>
-            <a:ext cx="1609343" cy="457200"/>
+            <a:off x="7598664" y="2240280"/>
+            <a:ext cx="1947672" cy="457200"/>
           </a:xfrm>
           <a:prstGeom prst="rect">
             <a:avLst/>
@@ -8497,13 +8461,13 @@
               </a:spcAft>
             </a:pPr>
             <a:r>
-              <a:rPr sz="950" b="1">
+              <a:rPr sz="900" b="1">
                 <a:solidFill>
                   <a:srgbClr val="FFFFFF"/>
                 </a:solidFill>
                 <a:latin typeface="Calibri"/>
               </a:rPr>
-              <a:t>Precio cliente</a:t>
+              <a:t>Total cliente /mes</a:t>
             </a:r>
           </a:p>
         </p:txBody>
@@ -8516,14 +8480,14 @@
         </p:nvSpPr>
         <p:spPr>
           <a:xfrm>
-            <a:off x="10104120" y="2240280"/>
-            <a:ext cx="1554480" cy="457200"/>
+            <a:off x="9601200" y="2240280"/>
+            <a:ext cx="2011680" cy="457200"/>
           </a:xfrm>
           <a:prstGeom prst="rect">
             <a:avLst/>
           </a:prstGeom>
           <a:solidFill>
-            <a:srgbClr val="0B1F3A"/>
+            <a:srgbClr val="14102B"/>
           </a:solidFill>
           <a:ln>
             <a:noFill/>
@@ -8560,8 +8524,8 @@
         </p:nvSpPr>
         <p:spPr>
           <a:xfrm>
-            <a:off x="10168128" y="2240280"/>
-            <a:ext cx="1426464" cy="457200"/>
+            <a:off x="9656064" y="2240280"/>
+            <a:ext cx="1901952" cy="457200"/>
           </a:xfrm>
           <a:prstGeom prst="rect">
             <a:avLst/>
@@ -8580,13 +8544,13 @@
               </a:spcAft>
             </a:pPr>
             <a:r>
-              <a:rPr sz="950" b="1">
+              <a:rPr sz="900" b="1">
                 <a:solidFill>
                   <a:srgbClr val="FFFFFF"/>
                 </a:solidFill>
                 <a:latin typeface="Calibri"/>
               </a:rPr>
-              <a:t>Margen</a:t>
+              <a:t>Margen ads</a:t>
             </a:r>
           </a:p>
         </p:txBody>
@@ -8600,7 +8564,7 @@
         <p:spPr>
           <a:xfrm>
             <a:off x="502920" y="2697480"/>
-            <a:ext cx="2103120" cy="502920"/>
+            <a:ext cx="1783080" cy="457200"/>
           </a:xfrm>
           <a:prstGeom prst="rect">
             <a:avLst/>
@@ -8643,8 +8607,8 @@
         </p:nvSpPr>
         <p:spPr>
           <a:xfrm>
-            <a:off x="566928" y="2697480"/>
-            <a:ext cx="1975103" cy="502920"/>
+            <a:off x="557784" y="2697480"/>
+            <a:ext cx="1673352" cy="457200"/>
           </a:xfrm>
           <a:prstGeom prst="rect">
             <a:avLst/>
@@ -8663,7 +8627,7 @@
               </a:spcAft>
             </a:pPr>
             <a:r>
-              <a:rPr sz="950" b="1">
+              <a:rPr sz="900" b="1">
                 <a:solidFill>
                   <a:srgbClr val="0F172A"/>
                 </a:solidFill>
@@ -8682,8 +8646,8 @@
         </p:nvSpPr>
         <p:spPr>
           <a:xfrm>
-            <a:off x="2606039" y="2697480"/>
-            <a:ext cx="2011680" cy="502920"/>
+            <a:off x="2286000" y="2697480"/>
+            <a:ext cx="1874519" cy="457200"/>
           </a:xfrm>
           <a:prstGeom prst="rect">
             <a:avLst/>
@@ -8726,8 +8690,8 @@
         </p:nvSpPr>
         <p:spPr>
           <a:xfrm>
-            <a:off x="2670047" y="2697480"/>
-            <a:ext cx="1883664" cy="502920"/>
+            <a:off x="2340864" y="2697480"/>
+            <a:ext cx="1764791" cy="457200"/>
           </a:xfrm>
           <a:prstGeom prst="rect">
             <a:avLst/>
@@ -8746,13 +8710,13 @@
               </a:spcAft>
             </a:pPr>
             <a:r>
-              <a:rPr sz="950" b="0">
+              <a:rPr sz="900" b="0">
                 <a:solidFill>
                   <a:srgbClr val="0F172A"/>
                 </a:solidFill>
                 <a:latin typeface="Calibri"/>
               </a:rPr>
-              <a:t>250 €/mes</a:t>
+              <a:t>250 €</a:t>
             </a:r>
           </a:p>
         </p:txBody>
@@ -8765,8 +8729,8 @@
         </p:nvSpPr>
         <p:spPr>
           <a:xfrm>
-            <a:off x="4617720" y="2697480"/>
-            <a:ext cx="1920240" cy="502920"/>
+            <a:off x="4160520" y="2697480"/>
+            <a:ext cx="1691640" cy="457200"/>
           </a:xfrm>
           <a:prstGeom prst="rect">
             <a:avLst/>
@@ -8809,8 +8773,8 @@
         </p:nvSpPr>
         <p:spPr>
           <a:xfrm>
-            <a:off x="4681728" y="2697480"/>
-            <a:ext cx="1792224" cy="502920"/>
+            <a:off x="4215383" y="2697480"/>
+            <a:ext cx="1581912" cy="457200"/>
           </a:xfrm>
           <a:prstGeom prst="rect">
             <a:avLst/>
@@ -8829,13 +8793,13 @@
               </a:spcAft>
             </a:pPr>
             <a:r>
-              <a:rPr sz="950" b="0">
-                <a:solidFill>
-                  <a:srgbClr val="92400E"/>
-                </a:solidFill>
-                <a:latin typeface="Calibri"/>
-              </a:rPr>
-              <a:t>[definir]</a:t>
+              <a:rPr sz="900" b="0">
+                <a:solidFill>
+                  <a:srgbClr val="0F172A"/>
+                </a:solidFill>
+                <a:latin typeface="Calibri"/>
+              </a:rPr>
+              <a:t>350 €/mes</a:t>
             </a:r>
           </a:p>
         </p:txBody>
@@ -8848,8 +8812,8 @@
         </p:nvSpPr>
         <p:spPr>
           <a:xfrm>
-            <a:off x="6537960" y="2697480"/>
-            <a:ext cx="1828800" cy="502920"/>
+            <a:off x="5852160" y="2697480"/>
+            <a:ext cx="1691640" cy="457200"/>
           </a:xfrm>
           <a:prstGeom prst="rect">
             <a:avLst/>
@@ -8892,8 +8856,8 @@
         </p:nvSpPr>
         <p:spPr>
           <a:xfrm>
-            <a:off x="6601968" y="2697480"/>
-            <a:ext cx="1700784" cy="502920"/>
+            <a:off x="5907024" y="2697480"/>
+            <a:ext cx="1581912" cy="457200"/>
           </a:xfrm>
           <a:prstGeom prst="rect">
             <a:avLst/>
@@ -8912,13 +8876,13 @@
               </a:spcAft>
             </a:pPr>
             <a:r>
-              <a:rPr sz="950" b="0">
+              <a:rPr sz="900" b="0">
                 <a:solidFill>
                   <a:srgbClr val="0F172A"/>
                 </a:solidFill>
                 <a:latin typeface="Calibri"/>
               </a:rPr>
-              <a:t>según consumo</a:t>
+              <a:t>197 €/mes</a:t>
             </a:r>
           </a:p>
         </p:txBody>
@@ -8931,8 +8895,8 @@
         </p:nvSpPr>
         <p:spPr>
           <a:xfrm>
-            <a:off x="8366760" y="2697480"/>
-            <a:ext cx="1737360" cy="502920"/>
+            <a:off x="7543800" y="2697480"/>
+            <a:ext cx="2057400" cy="457200"/>
           </a:xfrm>
           <a:prstGeom prst="rect">
             <a:avLst/>
@@ -8975,8 +8939,8 @@
         </p:nvSpPr>
         <p:spPr>
           <a:xfrm>
-            <a:off x="8430768" y="2697480"/>
-            <a:ext cx="1609343" cy="502920"/>
+            <a:off x="7598664" y="2697480"/>
+            <a:ext cx="1947672" cy="457200"/>
           </a:xfrm>
           <a:prstGeom prst="rect">
             <a:avLst/>
@@ -8995,13 +8959,13 @@
               </a:spcAft>
             </a:pPr>
             <a:r>
-              <a:rPr sz="950" b="0">
-                <a:solidFill>
-                  <a:srgbClr val="92400E"/>
-                </a:solidFill>
-                <a:latin typeface="Calibri"/>
-              </a:rPr>
-              <a:t>[definir]</a:t>
+              <a:rPr sz="900" b="0">
+                <a:solidFill>
+                  <a:srgbClr val="0F172A"/>
+                </a:solidFill>
+                <a:latin typeface="Calibri"/>
+              </a:rPr>
+              <a:t>547 €/mes</a:t>
             </a:r>
           </a:p>
         </p:txBody>
@@ -9014,8 +8978,8 @@
         </p:nvSpPr>
         <p:spPr>
           <a:xfrm>
-            <a:off x="10104120" y="2697480"/>
-            <a:ext cx="1554480" cy="502920"/>
+            <a:off x="9601200" y="2697480"/>
+            <a:ext cx="2011680" cy="457200"/>
           </a:xfrm>
           <a:prstGeom prst="rect">
             <a:avLst/>
@@ -9058,8 +9022,8 @@
         </p:nvSpPr>
         <p:spPr>
           <a:xfrm>
-            <a:off x="10168128" y="2697480"/>
-            <a:ext cx="1426464" cy="502920"/>
+            <a:off x="9656064" y="2697480"/>
+            <a:ext cx="1901952" cy="457200"/>
           </a:xfrm>
           <a:prstGeom prst="rect">
             <a:avLst/>
@@ -9078,13 +9042,13 @@
               </a:spcAft>
             </a:pPr>
             <a:r>
-              <a:rPr sz="950" b="0">
-                <a:solidFill>
-                  <a:srgbClr val="92400E"/>
-                </a:solidFill>
-                <a:latin typeface="Calibri"/>
-              </a:rPr>
-              <a:t>[definir]</a:t>
+              <a:rPr sz="900" b="0">
+                <a:solidFill>
+                  <a:srgbClr val="0F172A"/>
+                </a:solidFill>
+                <a:latin typeface="Calibri"/>
+              </a:rPr>
+              <a:t>100 €</a:t>
             </a:r>
           </a:p>
         </p:txBody>
@@ -9097,14 +9061,14 @@
         </p:nvSpPr>
         <p:spPr>
           <a:xfrm>
-            <a:off x="502920" y="3200400"/>
-            <a:ext cx="2103120" cy="502920"/>
+            <a:off x="502920" y="3154680"/>
+            <a:ext cx="1783080" cy="457200"/>
           </a:xfrm>
           <a:prstGeom prst="rect">
             <a:avLst/>
           </a:prstGeom>
           <a:solidFill>
-            <a:srgbClr val="F1F5F9"/>
+            <a:srgbClr val="F3F1FB"/>
           </a:solidFill>
           <a:ln>
             <a:noFill/>
@@ -9141,8 +9105,8 @@
         </p:nvSpPr>
         <p:spPr>
           <a:xfrm>
-            <a:off x="566928" y="3200400"/>
-            <a:ext cx="1975103" cy="502920"/>
+            <a:off x="557784" y="3154680"/>
+            <a:ext cx="1673352" cy="457200"/>
           </a:xfrm>
           <a:prstGeom prst="rect">
             <a:avLst/>
@@ -9161,7 +9125,7 @@
               </a:spcAft>
             </a:pPr>
             <a:r>
-              <a:rPr sz="950" b="1">
+              <a:rPr sz="900" b="1">
                 <a:solidFill>
                   <a:srgbClr val="0F172A"/>
                 </a:solidFill>
@@ -9180,14 +9144,14 @@
         </p:nvSpPr>
         <p:spPr>
           <a:xfrm>
-            <a:off x="2606039" y="3200400"/>
-            <a:ext cx="2011680" cy="502920"/>
+            <a:off x="2286000" y="3154680"/>
+            <a:ext cx="1874519" cy="457200"/>
           </a:xfrm>
           <a:prstGeom prst="rect">
             <a:avLst/>
           </a:prstGeom>
           <a:solidFill>
-            <a:srgbClr val="F1F5F9"/>
+            <a:srgbClr val="F3F1FB"/>
           </a:solidFill>
           <a:ln>
             <a:noFill/>
@@ -9224,8 +9188,8 @@
         </p:nvSpPr>
         <p:spPr>
           <a:xfrm>
-            <a:off x="2670047" y="3200400"/>
-            <a:ext cx="1883664" cy="502920"/>
+            <a:off x="2340864" y="3154680"/>
+            <a:ext cx="1764791" cy="457200"/>
           </a:xfrm>
           <a:prstGeom prst="rect">
             <a:avLst/>
@@ -9244,13 +9208,13 @@
               </a:spcAft>
             </a:pPr>
             <a:r>
-              <a:rPr sz="950" b="0">
+              <a:rPr sz="900" b="0">
                 <a:solidFill>
                   <a:srgbClr val="0F172A"/>
                 </a:solidFill>
                 <a:latin typeface="Calibri"/>
               </a:rPr>
-              <a:t>450 €/mes</a:t>
+              <a:t>450 €</a:t>
             </a:r>
           </a:p>
         </p:txBody>
@@ -9263,14 +9227,14 @@
         </p:nvSpPr>
         <p:spPr>
           <a:xfrm>
-            <a:off x="4617720" y="3200400"/>
-            <a:ext cx="1920240" cy="502920"/>
+            <a:off x="4160520" y="3154680"/>
+            <a:ext cx="1691640" cy="457200"/>
           </a:xfrm>
           <a:prstGeom prst="rect">
             <a:avLst/>
           </a:prstGeom>
           <a:solidFill>
-            <a:srgbClr val="F1F5F9"/>
+            <a:srgbClr val="F3F1FB"/>
           </a:solidFill>
           <a:ln>
             <a:noFill/>
@@ -9307,8 +9271,8 @@
         </p:nvSpPr>
         <p:spPr>
           <a:xfrm>
-            <a:off x="4681728" y="3200400"/>
-            <a:ext cx="1792224" cy="502920"/>
+            <a:off x="4215383" y="3154680"/>
+            <a:ext cx="1581912" cy="457200"/>
           </a:xfrm>
           <a:prstGeom prst="rect">
             <a:avLst/>
@@ -9327,13 +9291,13 @@
               </a:spcAft>
             </a:pPr>
             <a:r>
-              <a:rPr sz="950" b="0">
-                <a:solidFill>
-                  <a:srgbClr val="92400E"/>
-                </a:solidFill>
-                <a:latin typeface="Calibri"/>
-              </a:rPr>
-              <a:t>[definir]</a:t>
+              <a:rPr sz="900" b="0">
+                <a:solidFill>
+                  <a:srgbClr val="0F172A"/>
+                </a:solidFill>
+                <a:latin typeface="Calibri"/>
+              </a:rPr>
+              <a:t>630 €/mes</a:t>
             </a:r>
           </a:p>
         </p:txBody>
@@ -9346,14 +9310,14 @@
         </p:nvSpPr>
         <p:spPr>
           <a:xfrm>
-            <a:off x="6537960" y="3200400"/>
-            <a:ext cx="1828800" cy="502920"/>
+            <a:off x="5852160" y="3154680"/>
+            <a:ext cx="1691640" cy="457200"/>
           </a:xfrm>
           <a:prstGeom prst="rect">
             <a:avLst/>
           </a:prstGeom>
           <a:solidFill>
-            <a:srgbClr val="F1F5F9"/>
+            <a:srgbClr val="F3F1FB"/>
           </a:solidFill>
           <a:ln>
             <a:noFill/>
@@ -9390,8 +9354,8 @@
         </p:nvSpPr>
         <p:spPr>
           <a:xfrm>
-            <a:off x="6601968" y="3200400"/>
-            <a:ext cx="1700784" cy="502920"/>
+            <a:off x="5907024" y="3154680"/>
+            <a:ext cx="1581912" cy="457200"/>
           </a:xfrm>
           <a:prstGeom prst="rect">
             <a:avLst/>
@@ -9410,13 +9374,13 @@
               </a:spcAft>
             </a:pPr>
             <a:r>
-              <a:rPr sz="950" b="0">
+              <a:rPr sz="900" b="0">
                 <a:solidFill>
                   <a:srgbClr val="0F172A"/>
                 </a:solidFill>
                 <a:latin typeface="Calibri"/>
               </a:rPr>
-              <a:t>según consumo</a:t>
+              <a:t>197 €/mes</a:t>
             </a:r>
           </a:p>
         </p:txBody>
@@ -9429,14 +9393,14 @@
         </p:nvSpPr>
         <p:spPr>
           <a:xfrm>
-            <a:off x="8366760" y="3200400"/>
-            <a:ext cx="1737360" cy="502920"/>
+            <a:off x="7543800" y="3154680"/>
+            <a:ext cx="2057400" cy="457200"/>
           </a:xfrm>
           <a:prstGeom prst="rect">
             <a:avLst/>
           </a:prstGeom>
           <a:solidFill>
-            <a:srgbClr val="F1F5F9"/>
+            <a:srgbClr val="F3F1FB"/>
           </a:solidFill>
           <a:ln>
             <a:noFill/>
@@ -9473,8 +9437,8 @@
         </p:nvSpPr>
         <p:spPr>
           <a:xfrm>
-            <a:off x="8430768" y="3200400"/>
-            <a:ext cx="1609343" cy="502920"/>
+            <a:off x="7598664" y="3154680"/>
+            <a:ext cx="1947672" cy="457200"/>
           </a:xfrm>
           <a:prstGeom prst="rect">
             <a:avLst/>
@@ -9493,13 +9457,13 @@
               </a:spcAft>
             </a:pPr>
             <a:r>
-              <a:rPr sz="950" b="0">
-                <a:solidFill>
-                  <a:srgbClr val="92400E"/>
-                </a:solidFill>
-                <a:latin typeface="Calibri"/>
-              </a:rPr>
-              <a:t>[definir]</a:t>
+              <a:rPr sz="900" b="0">
+                <a:solidFill>
+                  <a:srgbClr val="0F172A"/>
+                </a:solidFill>
+                <a:latin typeface="Calibri"/>
+              </a:rPr>
+              <a:t>827 €/mes</a:t>
             </a:r>
           </a:p>
         </p:txBody>
@@ -9512,14 +9476,14 @@
         </p:nvSpPr>
         <p:spPr>
           <a:xfrm>
-            <a:off x="10104120" y="3200400"/>
-            <a:ext cx="1554480" cy="502920"/>
+            <a:off x="9601200" y="3154680"/>
+            <a:ext cx="2011680" cy="457200"/>
           </a:xfrm>
           <a:prstGeom prst="rect">
             <a:avLst/>
           </a:prstGeom>
           <a:solidFill>
-            <a:srgbClr val="F1F5F9"/>
+            <a:srgbClr val="F3F1FB"/>
           </a:solidFill>
           <a:ln>
             <a:noFill/>
@@ -9556,8 +9520,8 @@
         </p:nvSpPr>
         <p:spPr>
           <a:xfrm>
-            <a:off x="10168128" y="3200400"/>
-            <a:ext cx="1426464" cy="502920"/>
+            <a:off x="9656064" y="3154680"/>
+            <a:ext cx="1901952" cy="457200"/>
           </a:xfrm>
           <a:prstGeom prst="rect">
             <a:avLst/>
@@ -9576,13 +9540,13 @@
               </a:spcAft>
             </a:pPr>
             <a:r>
-              <a:rPr sz="950" b="0">
-                <a:solidFill>
-                  <a:srgbClr val="92400E"/>
-                </a:solidFill>
-                <a:latin typeface="Calibri"/>
-              </a:rPr>
-              <a:t>[definir]</a:t>
+              <a:rPr sz="900" b="0">
+                <a:solidFill>
+                  <a:srgbClr val="0F172A"/>
+                </a:solidFill>
+                <a:latin typeface="Calibri"/>
+              </a:rPr>
+              <a:t>180 €</a:t>
             </a:r>
           </a:p>
         </p:txBody>
@@ -9595,8 +9559,8 @@
         </p:nvSpPr>
         <p:spPr>
           <a:xfrm>
-            <a:off x="502920" y="3703320"/>
-            <a:ext cx="2103120" cy="502920"/>
+            <a:off x="502920" y="3611880"/>
+            <a:ext cx="1783080" cy="457200"/>
           </a:xfrm>
           <a:prstGeom prst="rect">
             <a:avLst/>
@@ -9639,8 +9603,8 @@
         </p:nvSpPr>
         <p:spPr>
           <a:xfrm>
-            <a:off x="566928" y="3703320"/>
-            <a:ext cx="1975103" cy="502920"/>
+            <a:off x="557784" y="3611880"/>
+            <a:ext cx="1673352" cy="457200"/>
           </a:xfrm>
           <a:prstGeom prst="rect">
             <a:avLst/>
@@ -9659,7 +9623,7 @@
               </a:spcAft>
             </a:pPr>
             <a:r>
-              <a:rPr sz="950" b="1">
+              <a:rPr sz="900" b="1">
                 <a:solidFill>
                   <a:srgbClr val="0F172A"/>
                 </a:solidFill>
@@ -9678,8 +9642,8 @@
         </p:nvSpPr>
         <p:spPr>
           <a:xfrm>
-            <a:off x="2606039" y="3703320"/>
-            <a:ext cx="2011680" cy="502920"/>
+            <a:off x="2286000" y="3611880"/>
+            <a:ext cx="1874519" cy="457200"/>
           </a:xfrm>
           <a:prstGeom prst="rect">
             <a:avLst/>
@@ -9722,8 +9686,8 @@
         </p:nvSpPr>
         <p:spPr>
           <a:xfrm>
-            <a:off x="2670047" y="3703320"/>
-            <a:ext cx="1883664" cy="502920"/>
+            <a:off x="2340864" y="3611880"/>
+            <a:ext cx="1764791" cy="457200"/>
           </a:xfrm>
           <a:prstGeom prst="rect">
             <a:avLst/>
@@ -9742,13 +9706,13 @@
               </a:spcAft>
             </a:pPr>
             <a:r>
-              <a:rPr sz="950" b="0">
+              <a:rPr sz="900" b="0">
                 <a:solidFill>
                   <a:srgbClr val="0F172A"/>
                 </a:solidFill>
                 <a:latin typeface="Calibri"/>
               </a:rPr>
-              <a:t>625 €/mes</a:t>
+              <a:t>625 €</a:t>
             </a:r>
           </a:p>
         </p:txBody>
@@ -9761,8 +9725,8 @@
         </p:nvSpPr>
         <p:spPr>
           <a:xfrm>
-            <a:off x="4617720" y="3703320"/>
-            <a:ext cx="1920240" cy="502920"/>
+            <a:off x="4160520" y="3611880"/>
+            <a:ext cx="1691640" cy="457200"/>
           </a:xfrm>
           <a:prstGeom prst="rect">
             <a:avLst/>
@@ -9805,8 +9769,8 @@
         </p:nvSpPr>
         <p:spPr>
           <a:xfrm>
-            <a:off x="4681728" y="3703320"/>
-            <a:ext cx="1792224" cy="502920"/>
+            <a:off x="4215383" y="3611880"/>
+            <a:ext cx="1581912" cy="457200"/>
           </a:xfrm>
           <a:prstGeom prst="rect">
             <a:avLst/>
@@ -9825,13 +9789,13 @@
               </a:spcAft>
             </a:pPr>
             <a:r>
-              <a:rPr sz="950" b="0">
-                <a:solidFill>
-                  <a:srgbClr val="92400E"/>
-                </a:solidFill>
-                <a:latin typeface="Calibri"/>
-              </a:rPr>
-              <a:t>[definir]</a:t>
+              <a:rPr sz="900" b="0">
+                <a:solidFill>
+                  <a:srgbClr val="0F172A"/>
+                </a:solidFill>
+                <a:latin typeface="Calibri"/>
+              </a:rPr>
+              <a:t>875 €/mes</a:t>
             </a:r>
           </a:p>
         </p:txBody>
@@ -9844,8 +9808,8 @@
         </p:nvSpPr>
         <p:spPr>
           <a:xfrm>
-            <a:off x="6537960" y="3703320"/>
-            <a:ext cx="1828800" cy="502920"/>
+            <a:off x="5852160" y="3611880"/>
+            <a:ext cx="1691640" cy="457200"/>
           </a:xfrm>
           <a:prstGeom prst="rect">
             <a:avLst/>
@@ -9888,8 +9852,8 @@
         </p:nvSpPr>
         <p:spPr>
           <a:xfrm>
-            <a:off x="6601968" y="3703320"/>
-            <a:ext cx="1700784" cy="502920"/>
+            <a:off x="5907024" y="3611880"/>
+            <a:ext cx="1581912" cy="457200"/>
           </a:xfrm>
           <a:prstGeom prst="rect">
             <a:avLst/>
@@ -9908,13 +9872,13 @@
               </a:spcAft>
             </a:pPr>
             <a:r>
-              <a:rPr sz="950" b="0">
+              <a:rPr sz="900" b="0">
                 <a:solidFill>
                   <a:srgbClr val="0F172A"/>
                 </a:solidFill>
                 <a:latin typeface="Calibri"/>
               </a:rPr>
-              <a:t>según consumo</a:t>
+              <a:t>197 €/mes</a:t>
             </a:r>
           </a:p>
         </p:txBody>
@@ -9927,8 +9891,8 @@
         </p:nvSpPr>
         <p:spPr>
           <a:xfrm>
-            <a:off x="8366760" y="3703320"/>
-            <a:ext cx="1737360" cy="502920"/>
+            <a:off x="7543800" y="3611880"/>
+            <a:ext cx="2057400" cy="457200"/>
           </a:xfrm>
           <a:prstGeom prst="rect">
             <a:avLst/>
@@ -9971,8 +9935,8 @@
         </p:nvSpPr>
         <p:spPr>
           <a:xfrm>
-            <a:off x="8430768" y="3703320"/>
-            <a:ext cx="1609343" cy="502920"/>
+            <a:off x="7598664" y="3611880"/>
+            <a:ext cx="1947672" cy="457200"/>
           </a:xfrm>
           <a:prstGeom prst="rect">
             <a:avLst/>
@@ -9991,13 +9955,13 @@
               </a:spcAft>
             </a:pPr>
             <a:r>
-              <a:rPr sz="950" b="0">
-                <a:solidFill>
-                  <a:srgbClr val="92400E"/>
-                </a:solidFill>
-                <a:latin typeface="Calibri"/>
-              </a:rPr>
-              <a:t>[definir]</a:t>
+              <a:rPr sz="900" b="0">
+                <a:solidFill>
+                  <a:srgbClr val="0F172A"/>
+                </a:solidFill>
+                <a:latin typeface="Calibri"/>
+              </a:rPr>
+              <a:t>1.072 €/mes</a:t>
             </a:r>
           </a:p>
         </p:txBody>
@@ -10010,8 +9974,8 @@
         </p:nvSpPr>
         <p:spPr>
           <a:xfrm>
-            <a:off x="10104120" y="3703320"/>
-            <a:ext cx="1554480" cy="502920"/>
+            <a:off x="9601200" y="3611880"/>
+            <a:ext cx="2011680" cy="457200"/>
           </a:xfrm>
           <a:prstGeom prst="rect">
             <a:avLst/>
@@ -10054,8 +10018,8 @@
         </p:nvSpPr>
         <p:spPr>
           <a:xfrm>
-            <a:off x="10168128" y="3703320"/>
-            <a:ext cx="1426464" cy="502920"/>
+            <a:off x="9656064" y="3611880"/>
+            <a:ext cx="1901952" cy="457200"/>
           </a:xfrm>
           <a:prstGeom prst="rect">
             <a:avLst/>
@@ -10074,13 +10038,13 @@
               </a:spcAft>
             </a:pPr>
             <a:r>
-              <a:rPr sz="950" b="0">
-                <a:solidFill>
-                  <a:srgbClr val="92400E"/>
-                </a:solidFill>
-                <a:latin typeface="Calibri"/>
-              </a:rPr>
-              <a:t>[definir]</a:t>
+              <a:rPr sz="900" b="0">
+                <a:solidFill>
+                  <a:srgbClr val="0F172A"/>
+                </a:solidFill>
+                <a:latin typeface="Calibri"/>
+              </a:rPr>
+              <a:t>250 €</a:t>
             </a:r>
           </a:p>
         </p:txBody>
@@ -10093,14 +10057,14 @@
         </p:nvSpPr>
         <p:spPr>
           <a:xfrm>
-            <a:off x="502920" y="4206240"/>
-            <a:ext cx="2103120" cy="502920"/>
+            <a:off x="502920" y="4069080"/>
+            <a:ext cx="1783080" cy="457200"/>
           </a:xfrm>
           <a:prstGeom prst="rect">
             <a:avLst/>
           </a:prstGeom>
           <a:solidFill>
-            <a:srgbClr val="F1F5F9"/>
+            <a:srgbClr val="F3F1FB"/>
           </a:solidFill>
           <a:ln>
             <a:noFill/>
@@ -10137,8 +10101,8 @@
         </p:nvSpPr>
         <p:spPr>
           <a:xfrm>
-            <a:off x="566928" y="4206240"/>
-            <a:ext cx="1975103" cy="502920"/>
+            <a:off x="557784" y="4069080"/>
+            <a:ext cx="1673352" cy="457200"/>
           </a:xfrm>
           <a:prstGeom prst="rect">
             <a:avLst/>
@@ -10157,7 +10121,7 @@
               </a:spcAft>
             </a:pPr>
             <a:r>
-              <a:rPr sz="950" b="1">
+              <a:rPr sz="900" b="1">
                 <a:solidFill>
                   <a:srgbClr val="0F172A"/>
                 </a:solidFill>
@@ -10176,14 +10140,14 @@
         </p:nvSpPr>
         <p:spPr>
           <a:xfrm>
-            <a:off x="2606039" y="4206240"/>
-            <a:ext cx="2011680" cy="502920"/>
+            <a:off x="2286000" y="4069080"/>
+            <a:ext cx="1874519" cy="457200"/>
           </a:xfrm>
           <a:prstGeom prst="rect">
             <a:avLst/>
           </a:prstGeom>
           <a:solidFill>
-            <a:srgbClr val="F1F5F9"/>
+            <a:srgbClr val="F3F1FB"/>
           </a:solidFill>
           <a:ln>
             <a:noFill/>
@@ -10220,8 +10184,8 @@
         </p:nvSpPr>
         <p:spPr>
           <a:xfrm>
-            <a:off x="2670047" y="4206240"/>
-            <a:ext cx="1883664" cy="502920"/>
+            <a:off x="2340864" y="4069080"/>
+            <a:ext cx="1764791" cy="457200"/>
           </a:xfrm>
           <a:prstGeom prst="rect">
             <a:avLst/>
@@ -10240,7 +10204,7 @@
               </a:spcAft>
             </a:pPr>
             <a:r>
-              <a:rPr sz="950" b="0">
+              <a:rPr sz="900" b="0">
                 <a:solidFill>
                   <a:srgbClr val="0F172A"/>
                 </a:solidFill>
@@ -10259,14 +10223,14 @@
         </p:nvSpPr>
         <p:spPr>
           <a:xfrm>
-            <a:off x="4617720" y="4206240"/>
-            <a:ext cx="1920240" cy="502920"/>
+            <a:off x="4160520" y="4069080"/>
+            <a:ext cx="1691640" cy="457200"/>
           </a:xfrm>
           <a:prstGeom prst="rect">
             <a:avLst/>
           </a:prstGeom>
           <a:solidFill>
-            <a:srgbClr val="F1F5F9"/>
+            <a:srgbClr val="F3F1FB"/>
           </a:solidFill>
           <a:ln>
             <a:noFill/>
@@ -10303,8 +10267,8 @@
         </p:nvSpPr>
         <p:spPr>
           <a:xfrm>
-            <a:off x="4681728" y="4206240"/>
-            <a:ext cx="1792224" cy="502920"/>
+            <a:off x="4215383" y="4069080"/>
+            <a:ext cx="1581912" cy="457200"/>
           </a:xfrm>
           <a:prstGeom prst="rect">
             <a:avLst/>
@@ -10323,13 +10287,13 @@
               </a:spcAft>
             </a:pPr>
             <a:r>
-              <a:rPr sz="950" b="0">
-                <a:solidFill>
-                  <a:srgbClr val="92400E"/>
-                </a:solidFill>
-                <a:latin typeface="Calibri"/>
-              </a:rPr>
-              <a:t>[definir]</a:t>
+              <a:rPr sz="900" b="0">
+                <a:solidFill>
+                  <a:srgbClr val="0F172A"/>
+                </a:solidFill>
+                <a:latin typeface="Calibri"/>
+              </a:rPr>
+              <a:t>a medida</a:t>
             </a:r>
           </a:p>
         </p:txBody>
@@ -10342,14 +10306,14 @@
         </p:nvSpPr>
         <p:spPr>
           <a:xfrm>
-            <a:off x="6537960" y="4206240"/>
-            <a:ext cx="1828800" cy="502920"/>
+            <a:off x="5852160" y="4069080"/>
+            <a:ext cx="1691640" cy="457200"/>
           </a:xfrm>
           <a:prstGeom prst="rect">
             <a:avLst/>
           </a:prstGeom>
           <a:solidFill>
-            <a:srgbClr val="F1F5F9"/>
+            <a:srgbClr val="F3F1FB"/>
           </a:solidFill>
           <a:ln>
             <a:noFill/>
@@ -10386,8 +10350,8 @@
         </p:nvSpPr>
         <p:spPr>
           <a:xfrm>
-            <a:off x="6601968" y="4206240"/>
-            <a:ext cx="1700784" cy="502920"/>
+            <a:off x="5907024" y="4069080"/>
+            <a:ext cx="1581912" cy="457200"/>
           </a:xfrm>
           <a:prstGeom prst="rect">
             <a:avLst/>
@@ -10406,13 +10370,13 @@
               </a:spcAft>
             </a:pPr>
             <a:r>
-              <a:rPr sz="950" b="0">
+              <a:rPr sz="900" b="0">
                 <a:solidFill>
                   <a:srgbClr val="0F172A"/>
                 </a:solidFill>
                 <a:latin typeface="Calibri"/>
               </a:rPr>
-              <a:t>según consumo</a:t>
+              <a:t>197 €/mes</a:t>
             </a:r>
           </a:p>
         </p:txBody>
@@ -10425,14 +10389,14 @@
         </p:nvSpPr>
         <p:spPr>
           <a:xfrm>
-            <a:off x="8366760" y="4206240"/>
-            <a:ext cx="1737360" cy="502920"/>
+            <a:off x="7543800" y="4069080"/>
+            <a:ext cx="2057400" cy="457200"/>
           </a:xfrm>
           <a:prstGeom prst="rect">
             <a:avLst/>
           </a:prstGeom>
           <a:solidFill>
-            <a:srgbClr val="F1F5F9"/>
+            <a:srgbClr val="F3F1FB"/>
           </a:solidFill>
           <a:ln>
             <a:noFill/>
@@ -10469,8 +10433,8 @@
         </p:nvSpPr>
         <p:spPr>
           <a:xfrm>
-            <a:off x="8430768" y="4206240"/>
-            <a:ext cx="1609343" cy="502920"/>
+            <a:off x="7598664" y="4069080"/>
+            <a:ext cx="1947672" cy="457200"/>
           </a:xfrm>
           <a:prstGeom prst="rect">
             <a:avLst/>
@@ -10489,13 +10453,13 @@
               </a:spcAft>
             </a:pPr>
             <a:r>
-              <a:rPr sz="950" b="0">
-                <a:solidFill>
-                  <a:srgbClr val="92400E"/>
-                </a:solidFill>
-                <a:latin typeface="Calibri"/>
-              </a:rPr>
-              <a:t>[definir]</a:t>
+              <a:rPr sz="900" b="0">
+                <a:solidFill>
+                  <a:srgbClr val="0F172A"/>
+                </a:solidFill>
+                <a:latin typeface="Calibri"/>
+              </a:rPr>
+              <a:t>a medida</a:t>
             </a:r>
           </a:p>
         </p:txBody>
@@ -10508,14 +10472,14 @@
         </p:nvSpPr>
         <p:spPr>
           <a:xfrm>
-            <a:off x="10104120" y="4206240"/>
-            <a:ext cx="1554480" cy="502920"/>
+            <a:off x="9601200" y="4069080"/>
+            <a:ext cx="2011680" cy="457200"/>
           </a:xfrm>
           <a:prstGeom prst="rect">
             <a:avLst/>
           </a:prstGeom>
           <a:solidFill>
-            <a:srgbClr val="F1F5F9"/>
+            <a:srgbClr val="F3F1FB"/>
           </a:solidFill>
           <a:ln>
             <a:noFill/>
@@ -10552,8 +10516,8 @@
         </p:nvSpPr>
         <p:spPr>
           <a:xfrm>
-            <a:off x="10168128" y="4206240"/>
-            <a:ext cx="1426464" cy="502920"/>
+            <a:off x="9656064" y="4069080"/>
+            <a:ext cx="1901952" cy="457200"/>
           </a:xfrm>
           <a:prstGeom prst="rect">
             <a:avLst/>
@@ -10572,68 +10536,68 @@
               </a:spcAft>
             </a:pPr>
             <a:r>
-              <a:rPr sz="950" b="0">
+              <a:rPr sz="900" b="0">
+                <a:solidFill>
+                  <a:srgbClr val="0F172A"/>
+                </a:solidFill>
+                <a:latin typeface="Calibri"/>
+              </a:rPr>
+              <a:t>—</a:t>
+            </a:r>
+          </a:p>
+        </p:txBody>
+      </p:sp>
+      <p:sp>
+        <p:nvSpPr>
+          <p:cNvPr id="66" name="TextBox 65"/>
+          <p:cNvSpPr txBox="1"/>
+          <p:nvPr/>
+        </p:nvSpPr>
+        <p:spPr>
+          <a:xfrm>
+            <a:off x="502920" y="4526280"/>
+            <a:ext cx="11155680" cy="1371600"/>
+          </a:xfrm>
+          <a:prstGeom prst="rect">
+            <a:avLst/>
+          </a:prstGeom>
+          <a:noFill/>
+        </p:spPr>
+        <p:txBody>
+          <a:bodyPr wrap="square" anchor="t">
+            <a:spAutoFit/>
+          </a:bodyPr>
+          <a:lstStyle/>
+          <a:p>
+            <a:pPr algn="l">
+              <a:spcAft>
+                <a:spcPts val="300"/>
+              </a:spcAft>
+            </a:pPr>
+            <a:r>
+              <a:rPr sz="1050" b="1">
                 <a:solidFill>
                   <a:srgbClr val="92400E"/>
                 </a:solidFill>
                 <a:latin typeface="Calibri"/>
               </a:rPr>
-              <a:t>[definir]</a:t>
-            </a:r>
-          </a:p>
-        </p:txBody>
-      </p:sp>
-      <p:sp>
-        <p:nvSpPr>
-          <p:cNvPr id="66" name="TextBox 65"/>
-          <p:cNvSpPr txBox="1"/>
-          <p:nvPr/>
-        </p:nvSpPr>
-        <p:spPr>
-          <a:xfrm>
-            <a:off x="502920" y="4892040"/>
-            <a:ext cx="11155680" cy="1188720"/>
-          </a:xfrm>
-          <a:prstGeom prst="rect">
-            <a:avLst/>
-          </a:prstGeom>
-          <a:noFill/>
-        </p:spPr>
-        <p:txBody>
-          <a:bodyPr wrap="square" anchor="t">
-            <a:spAutoFit/>
-          </a:bodyPr>
-          <a:lstStyle/>
-          <a:p>
-            <a:pPr algn="l">
-              <a:spcAft>
-                <a:spcPts val="400"/>
-              </a:spcAft>
-            </a:pPr>
-            <a:r>
-              <a:rPr sz="1150" b="1">
+              <a:t>Activación única: 290 € (margen alto: el snapshot es templatizado).   ·   Sistema 197 €/mes = plataforma + IA + soporte.</a:t>
+            </a:r>
+          </a:p>
+          <a:p>
+            <a:pPr algn="l">
+              <a:spcAft>
+                <a:spcPts val="300"/>
+              </a:spcAft>
+            </a:pPr>
+            <a:r>
+              <a:rPr sz="1050" b="0">
                 <a:solidFill>
                   <a:srgbClr val="92400E"/>
                 </a:solidFill>
                 <a:latin typeface="Calibri"/>
               </a:rPr>
-              <a:t>+ Implementación única del sistema (one-time): [definir].   ·   Comunicación = WhatsApp + email + IA (slide siguiente).</a:t>
-            </a:r>
-          </a:p>
-          <a:p>
-            <a:pPr algn="l">
-              <a:spcAft>
-                <a:spcPts val="400"/>
-              </a:spcAft>
-            </a:pPr>
-            <a:r>
-              <a:rPr sz="1150" b="0">
-                <a:solidFill>
-                  <a:srgbClr val="92400E"/>
-                </a:solidFill>
-                <a:latin typeface="Calibri"/>
-              </a:rPr>
-              <a:t>Falta definir por omnia: precio del SISTEMA (implementación + mensual) y si los ads van a costo o con markup.</a:t>
+              <a:t>Ancla de valor: a medida = 5.683 $ (cotizador).   ·   Comunicación (WhatsApp/email/IA) según consumo.   ·   PROPUESTA — validar y unificar moneda.</a:t>
             </a:r>
           </a:p>
         </p:txBody>
@@ -10653,7 +10617,7 @@
             <a:avLst/>
           </a:prstGeom>
           <a:solidFill>
-            <a:srgbClr val="F1F5F9"/>
+            <a:srgbClr val="F3F1FB"/>
           </a:solidFill>
           <a:ln>
             <a:noFill/>
@@ -10793,7 +10757,7 @@
             <a:avLst/>
           </a:prstGeom>
           <a:solidFill>
-            <a:srgbClr val="14B8A6"/>
+            <a:srgbClr val="9A3CE0"/>
           </a:solidFill>
           <a:ln>
             <a:noFill/>
@@ -10852,7 +10816,7 @@
             <a:r>
               <a:rPr sz="1100" b="1">
                 <a:solidFill>
-                  <a:srgbClr val="14B8A6"/>
+                  <a:srgbClr val="9A3CE0"/>
                 </a:solidFill>
                 <a:latin typeface="Calibri"/>
               </a:rPr>
@@ -10891,7 +10855,7 @@
             <a:r>
               <a:rPr sz="2900" b="1">
                 <a:solidFill>
-                  <a:srgbClr val="0B1F3A"/>
+                  <a:srgbClr val="14102B"/>
                 </a:solidFill>
                 <a:latin typeface="Calibri"/>
               </a:rPr>
@@ -10954,7 +10918,7 @@
             <a:avLst/>
           </a:prstGeom>
           <a:solidFill>
-            <a:srgbClr val="F1F5F9"/>
+            <a:srgbClr val="F3F1FB"/>
           </a:solidFill>
           <a:ln>
             <a:noFill/>
@@ -10998,7 +10962,7 @@
             <a:avLst/>
           </a:prstGeom>
           <a:solidFill>
-            <a:srgbClr val="2563EB"/>
+            <a:srgbClr val="4F46E5"/>
           </a:solidFill>
           <a:ln>
             <a:noFill/>
@@ -11057,7 +11021,7 @@
             <a:r>
               <a:rPr sz="1400" b="1">
                 <a:solidFill>
-                  <a:srgbClr val="0B1F3A"/>
+                  <a:srgbClr val="14102B"/>
                 </a:solidFill>
                 <a:latin typeface="Calibri"/>
               </a:rPr>
@@ -11168,7 +11132,7 @@
             <a:avLst/>
           </a:prstGeom>
           <a:solidFill>
-            <a:srgbClr val="F1F5F9"/>
+            <a:srgbClr val="F3F1FB"/>
           </a:solidFill>
           <a:ln>
             <a:noFill/>
@@ -11212,7 +11176,7 @@
             <a:avLst/>
           </a:prstGeom>
           <a:solidFill>
-            <a:srgbClr val="2563EB"/>
+            <a:srgbClr val="4F46E5"/>
           </a:solidFill>
           <a:ln>
             <a:noFill/>
@@ -11271,7 +11235,7 @@
             <a:r>
               <a:rPr sz="1400" b="1">
                 <a:solidFill>
-                  <a:srgbClr val="0B1F3A"/>
+                  <a:srgbClr val="14102B"/>
                 </a:solidFill>
                 <a:latin typeface="Calibri"/>
               </a:rPr>
@@ -11366,7 +11330,7 @@
             <a:avLst/>
           </a:prstGeom>
           <a:solidFill>
-            <a:srgbClr val="F1F5F9"/>
+            <a:srgbClr val="F3F1FB"/>
           </a:solidFill>
           <a:ln>
             <a:noFill/>
@@ -11410,7 +11374,7 @@
             <a:avLst/>
           </a:prstGeom>
           <a:solidFill>
-            <a:srgbClr val="2563EB"/>
+            <a:srgbClr val="4F46E5"/>
           </a:solidFill>
           <a:ln>
             <a:noFill/>
@@ -11469,7 +11433,7 @@
             <a:r>
               <a:rPr sz="1400" b="1">
                 <a:solidFill>
-                  <a:srgbClr val="0B1F3A"/>
+                  <a:srgbClr val="14102B"/>
                 </a:solidFill>
                 <a:latin typeface="Calibri"/>
               </a:rPr>
@@ -11619,7 +11583,7 @@
             <a:avLst/>
           </a:prstGeom>
           <a:solidFill>
-            <a:srgbClr val="F1F5F9"/>
+            <a:srgbClr val="F3F1FB"/>
           </a:solidFill>
           <a:ln>
             <a:noFill/>
@@ -11758,9 +11722,17 @@
           <a:prstGeom prst="rect">
             <a:avLst/>
           </a:prstGeom>
-          <a:solidFill>
-            <a:srgbClr val="0B1F3A"/>
-          </a:solidFill>
+          <a:gradFill rotWithShape="1">
+            <a:gsLst>
+              <a:gs pos="0">
+                <a:srgbClr val="4F46E5"/>
+              </a:gs>
+              <a:gs pos="100000">
+                <a:srgbClr val="EC4899"/>
+              </a:gs>
+            </a:gsLst>
+            <a:lin scaled="0" ang="19500000"/>
+          </a:gradFill>
           <a:ln>
             <a:noFill/>
           </a:ln>
@@ -11790,51 +11762,7 @@
       </p:sp>
       <p:sp>
         <p:nvSpPr>
-          <p:cNvPr id="3" name="Rectangle 2"/>
-          <p:cNvSpPr/>
-          <p:nvPr/>
-        </p:nvSpPr>
-        <p:spPr>
-          <a:xfrm>
-            <a:off x="0" y="0"/>
-            <a:ext cx="228600" cy="6858000"/>
-          </a:xfrm>
-          <a:prstGeom prst="rect">
-            <a:avLst/>
-          </a:prstGeom>
-          <a:solidFill>
-            <a:srgbClr val="14B8A6"/>
-          </a:solidFill>
-          <a:ln>
-            <a:noFill/>
-          </a:ln>
-          <a:effectLst/>
-        </p:spPr>
-        <p:style>
-          <a:lnRef idx="1">
-            <a:schemeClr val="accent1"/>
-          </a:lnRef>
-          <a:fillRef idx="3">
-            <a:schemeClr val="accent1"/>
-          </a:fillRef>
-          <a:effectRef idx="2">
-            <a:schemeClr val="accent1"/>
-          </a:effectRef>
-          <a:fontRef idx="minor">
-            <a:schemeClr val="lt1"/>
-          </a:fontRef>
-        </p:style>
-        <p:txBody>
-          <a:bodyPr rtlCol="0" anchor="ctr"/>
-          <a:lstStyle/>
-          <a:p>
-            <a:pPr algn="ctr"/>
-          </a:p>
-        </p:txBody>
-      </p:sp>
-      <p:sp>
-        <p:nvSpPr>
-          <p:cNvPr id="4" name="TextBox 3"/>
+          <p:cNvPr id="3" name="TextBox 2"/>
           <p:cNvSpPr txBox="1"/>
           <p:nvPr/>
         </p:nvSpPr>
@@ -11862,7 +11790,7 @@
             <a:r>
               <a:rPr sz="1300" b="1">
                 <a:solidFill>
-                  <a:srgbClr val="14B8A6"/>
+                  <a:srgbClr val="FFFFFF"/>
                 </a:solidFill>
                 <a:latin typeface="Calibri"/>
               </a:rPr>
@@ -11873,7 +11801,7 @@
       </p:sp>
       <p:sp>
         <p:nvSpPr>
-          <p:cNvPr id="5" name="TextBox 4"/>
+          <p:cNvPr id="4" name="TextBox 3"/>
           <p:cNvSpPr txBox="1"/>
           <p:nvPr/>
         </p:nvSpPr>
@@ -11928,7 +11856,7 @@
       </p:sp>
       <p:sp>
         <p:nvSpPr>
-          <p:cNvPr id="6" name="TextBox 5"/>
+          <p:cNvPr id="5" name="TextBox 4"/>
           <p:cNvSpPr txBox="1"/>
           <p:nvPr/>
         </p:nvSpPr>
@@ -11976,7 +11904,7 @@
                 </a:solidFill>
                 <a:latin typeface="Calibri"/>
               </a:rPr>
-              <a:t>✓  En español, adaptable a odontología, estética y medicina</a:t>
+              <a:t>✓  En español de España, para odontología, estética y medicina</a:t>
             </a:r>
           </a:p>
           <a:p>
@@ -11992,14 +11920,14 @@
                 </a:solidFill>
                 <a:latin typeface="Calibri"/>
               </a:rPr>
-              <a:t>✓  Templatizado: nuevo cliente en horas</a:t>
-            </a:r>
-          </a:p>
-        </p:txBody>
-      </p:sp>
-      <p:sp>
-        <p:nvSpPr>
-          <p:cNvPr id="7" name="TextBox 6"/>
+              <a:t>✓  Templatizado y masivo: nuevo cliente en horas</a:t>
+            </a:r>
+          </a:p>
+        </p:txBody>
+      </p:sp>
+      <p:sp>
+        <p:nvSpPr>
+          <p:cNvPr id="6" name="TextBox 5"/>
           <p:cNvSpPr txBox="1"/>
           <p:nvPr/>
         </p:nvSpPr>
@@ -12027,11 +11955,11 @@
             <a:r>
               <a:rPr sz="1400" b="1">
                 <a:solidFill>
-                  <a:srgbClr val="14B8A6"/>
-                </a:solidFill>
-                <a:latin typeface="Calibri"/>
-              </a:rPr>
-              <a:t>omnia  ·  [web / contacto]</a:t>
+                  <a:srgbClr val="FFFFFF"/>
+                </a:solidFill>
+                <a:latin typeface="Calibri"/>
+              </a:rPr>
+              <a:t>omnia  ·  omniainbusiness.com</a:t>
             </a:r>
           </a:p>
         </p:txBody>
@@ -12069,7 +11997,7 @@
             <a:avLst/>
           </a:prstGeom>
           <a:solidFill>
-            <a:srgbClr val="14B8A6"/>
+            <a:srgbClr val="9A3CE0"/>
           </a:solidFill>
           <a:ln>
             <a:noFill/>
@@ -12128,7 +12056,7 @@
             <a:r>
               <a:rPr sz="1100" b="1">
                 <a:solidFill>
-                  <a:srgbClr val="14B8A6"/>
+                  <a:srgbClr val="9A3CE0"/>
                 </a:solidFill>
                 <a:latin typeface="Calibri"/>
               </a:rPr>
@@ -12167,7 +12095,7 @@
             <a:r>
               <a:rPr sz="2900" b="1">
                 <a:solidFill>
-                  <a:srgbClr val="0B1F3A"/>
+                  <a:srgbClr val="14102B"/>
                 </a:solidFill>
                 <a:latin typeface="Calibri"/>
               </a:rPr>
@@ -12230,7 +12158,7 @@
             <a:avLst/>
           </a:prstGeom>
           <a:solidFill>
-            <a:srgbClr val="F1F5F9"/>
+            <a:srgbClr val="F3F1FB"/>
           </a:solidFill>
           <a:ln>
             <a:noFill/>
@@ -12274,7 +12202,7 @@
             <a:avLst/>
           </a:prstGeom>
           <a:solidFill>
-            <a:srgbClr val="2563EB"/>
+            <a:srgbClr val="4F46E5"/>
           </a:solidFill>
           <a:ln>
             <a:noFill/>
@@ -12333,7 +12261,7 @@
             <a:r>
               <a:rPr sz="1400" b="1">
                 <a:solidFill>
-                  <a:srgbClr val="0B1F3A"/>
+                  <a:srgbClr val="14102B"/>
                 </a:solidFill>
                 <a:latin typeface="Calibri"/>
               </a:rPr>
@@ -12428,7 +12356,7 @@
             <a:avLst/>
           </a:prstGeom>
           <a:solidFill>
-            <a:srgbClr val="F1F5F9"/>
+            <a:srgbClr val="F3F1FB"/>
           </a:solidFill>
           <a:ln>
             <a:noFill/>
@@ -12472,7 +12400,7 @@
             <a:avLst/>
           </a:prstGeom>
           <a:solidFill>
-            <a:srgbClr val="2563EB"/>
+            <a:srgbClr val="4F46E5"/>
           </a:solidFill>
           <a:ln>
             <a:noFill/>
@@ -12531,7 +12459,7 @@
             <a:r>
               <a:rPr sz="1400" b="1">
                 <a:solidFill>
-                  <a:srgbClr val="0B1F3A"/>
+                  <a:srgbClr val="14102B"/>
                 </a:solidFill>
                 <a:latin typeface="Calibri"/>
               </a:rPr>
@@ -12626,7 +12554,7 @@
             <a:avLst/>
           </a:prstGeom>
           <a:solidFill>
-            <a:srgbClr val="F1F5F9"/>
+            <a:srgbClr val="F3F1FB"/>
           </a:solidFill>
           <a:ln>
             <a:noFill/>
@@ -12670,7 +12598,7 @@
             <a:avLst/>
           </a:prstGeom>
           <a:solidFill>
-            <a:srgbClr val="2563EB"/>
+            <a:srgbClr val="4F46E5"/>
           </a:solidFill>
           <a:ln>
             <a:noFill/>
@@ -12729,7 +12657,7 @@
             <a:r>
               <a:rPr sz="1400" b="1">
                 <a:solidFill>
-                  <a:srgbClr val="0B1F3A"/>
+                  <a:srgbClr val="14102B"/>
                 </a:solidFill>
                 <a:latin typeface="Calibri"/>
               </a:rPr>
@@ -12824,7 +12752,7 @@
             <a:avLst/>
           </a:prstGeom>
           <a:solidFill>
-            <a:srgbClr val="F1F5F9"/>
+            <a:srgbClr val="F3F1FB"/>
           </a:solidFill>
           <a:ln>
             <a:noFill/>
@@ -12868,7 +12796,7 @@
             <a:avLst/>
           </a:prstGeom>
           <a:solidFill>
-            <a:srgbClr val="2563EB"/>
+            <a:srgbClr val="4F46E5"/>
           </a:solidFill>
           <a:ln>
             <a:noFill/>
@@ -12927,7 +12855,7 @@
             <a:r>
               <a:rPr sz="1400" b="1">
                 <a:solidFill>
-                  <a:srgbClr val="0B1F3A"/>
+                  <a:srgbClr val="14102B"/>
                 </a:solidFill>
                 <a:latin typeface="Calibri"/>
               </a:rPr>
@@ -13022,7 +12950,7 @@
             <a:avLst/>
           </a:prstGeom>
           <a:solidFill>
-            <a:srgbClr val="F1F5F9"/>
+            <a:srgbClr val="F3F1FB"/>
           </a:solidFill>
           <a:ln>
             <a:noFill/>
@@ -13162,7 +13090,7 @@
             <a:avLst/>
           </a:prstGeom>
           <a:solidFill>
-            <a:srgbClr val="14B8A6"/>
+            <a:srgbClr val="9A3CE0"/>
           </a:solidFill>
           <a:ln>
             <a:noFill/>
@@ -13221,7 +13149,7 @@
             <a:r>
               <a:rPr sz="1100" b="1">
                 <a:solidFill>
-                  <a:srgbClr val="14B8A6"/>
+                  <a:srgbClr val="9A3CE0"/>
                 </a:solidFill>
                 <a:latin typeface="Calibri"/>
               </a:rPr>
@@ -13260,7 +13188,7 @@
             <a:r>
               <a:rPr sz="2900" b="1">
                 <a:solidFill>
-                  <a:srgbClr val="0B1F3A"/>
+                  <a:srgbClr val="14102B"/>
                 </a:solidFill>
                 <a:latin typeface="Calibri"/>
               </a:rPr>
@@ -13323,7 +13251,7 @@
             <a:avLst/>
           </a:prstGeom>
           <a:solidFill>
-            <a:srgbClr val="F1F5F9"/>
+            <a:srgbClr val="F3F1FB"/>
           </a:solidFill>
           <a:ln>
             <a:noFill/>
@@ -13367,7 +13295,7 @@
             <a:avLst/>
           </a:prstGeom>
           <a:solidFill>
-            <a:srgbClr val="14B8A6"/>
+            <a:srgbClr val="9A3CE0"/>
           </a:solidFill>
           <a:ln>
             <a:noFill/>
@@ -13426,7 +13354,7 @@
             <a:r>
               <a:rPr sz="1400" b="1">
                 <a:solidFill>
-                  <a:srgbClr val="0B1F3A"/>
+                  <a:srgbClr val="14102B"/>
                 </a:solidFill>
                 <a:latin typeface="Calibri"/>
               </a:rPr>
@@ -13505,7 +13433,7 @@
             <a:avLst/>
           </a:prstGeom>
           <a:solidFill>
-            <a:srgbClr val="F1F5F9"/>
+            <a:srgbClr val="F3F1FB"/>
           </a:solidFill>
           <a:ln>
             <a:noFill/>
@@ -13549,7 +13477,7 @@
             <a:avLst/>
           </a:prstGeom>
           <a:solidFill>
-            <a:srgbClr val="14B8A6"/>
+            <a:srgbClr val="9A3CE0"/>
           </a:solidFill>
           <a:ln>
             <a:noFill/>
@@ -13608,7 +13536,7 @@
             <a:r>
               <a:rPr sz="1400" b="1">
                 <a:solidFill>
-                  <a:srgbClr val="0B1F3A"/>
+                  <a:srgbClr val="14102B"/>
                 </a:solidFill>
                 <a:latin typeface="Calibri"/>
               </a:rPr>
@@ -13687,7 +13615,7 @@
             <a:avLst/>
           </a:prstGeom>
           <a:solidFill>
-            <a:srgbClr val="F1F5F9"/>
+            <a:srgbClr val="F3F1FB"/>
           </a:solidFill>
           <a:ln>
             <a:noFill/>
@@ -13731,7 +13659,7 @@
             <a:avLst/>
           </a:prstGeom>
           <a:solidFill>
-            <a:srgbClr val="14B8A6"/>
+            <a:srgbClr val="9A3CE0"/>
           </a:solidFill>
           <a:ln>
             <a:noFill/>
@@ -13790,7 +13718,7 @@
             <a:r>
               <a:rPr sz="1400" b="1">
                 <a:solidFill>
-                  <a:srgbClr val="0B1F3A"/>
+                  <a:srgbClr val="14102B"/>
                 </a:solidFill>
                 <a:latin typeface="Calibri"/>
               </a:rPr>
@@ -13884,7 +13812,7 @@
             <a:r>
               <a:rPr sz="1400" b="1">
                 <a:solidFill>
-                  <a:srgbClr val="0B1F3A"/>
+                  <a:srgbClr val="14102B"/>
                 </a:solidFill>
                 <a:latin typeface="Calibri"/>
               </a:rPr>
@@ -13893,7 +13821,7 @@
             <a:r>
               <a:rPr sz="1400" b="1">
                 <a:solidFill>
-                  <a:srgbClr val="14B8A6"/>
+                  <a:srgbClr val="9A3CE0"/>
                 </a:solidFill>
                 <a:latin typeface="Calibri"/>
               </a:rPr>
@@ -13902,7 +13830,7 @@
             <a:r>
               <a:rPr sz="1400" b="1">
                 <a:solidFill>
-                  <a:srgbClr val="0B1F3A"/>
+                  <a:srgbClr val="14102B"/>
                 </a:solidFill>
                 <a:latin typeface="Calibri"/>
               </a:rPr>
@@ -13926,7 +13854,7 @@
             <a:avLst/>
           </a:prstGeom>
           <a:solidFill>
-            <a:srgbClr val="F1F5F9"/>
+            <a:srgbClr val="F3F1FB"/>
           </a:solidFill>
           <a:ln>
             <a:noFill/>
@@ -14066,7 +13994,7 @@
             <a:avLst/>
           </a:prstGeom>
           <a:solidFill>
-            <a:srgbClr val="14B8A6"/>
+            <a:srgbClr val="9A3CE0"/>
           </a:solidFill>
           <a:ln>
             <a:noFill/>
@@ -14125,7 +14053,7 @@
             <a:r>
               <a:rPr sz="1100" b="1">
                 <a:solidFill>
-                  <a:srgbClr val="14B8A6"/>
+                  <a:srgbClr val="9A3CE0"/>
                 </a:solidFill>
                 <a:latin typeface="Calibri"/>
               </a:rPr>
@@ -14164,7 +14092,7 @@
             <a:r>
               <a:rPr sz="2900" b="1">
                 <a:solidFill>
-                  <a:srgbClr val="0B1F3A"/>
+                  <a:srgbClr val="14102B"/>
                 </a:solidFill>
                 <a:latin typeface="Calibri"/>
               </a:rPr>
@@ -14227,7 +14155,7 @@
             <a:avLst/>
           </a:prstGeom>
           <a:solidFill>
-            <a:srgbClr val="F1F5F9"/>
+            <a:srgbClr val="F3F1FB"/>
           </a:solidFill>
           <a:ln>
             <a:noFill/>
@@ -14286,7 +14214,7 @@
             <a:r>
               <a:rPr sz="1250" b="1">
                 <a:solidFill>
-                  <a:srgbClr val="0B1F3A"/>
+                  <a:srgbClr val="14102B"/>
                 </a:solidFill>
                 <a:latin typeface="Calibri"/>
               </a:rPr>
@@ -14341,7 +14269,7 @@
             <a:r>
               <a:rPr sz="1800" b="1">
                 <a:solidFill>
-                  <a:srgbClr val="14B8A6"/>
+                  <a:srgbClr val="9A3CE0"/>
                 </a:solidFill>
                 <a:latin typeface="Calibri"/>
               </a:rPr>
@@ -14365,7 +14293,7 @@
             <a:avLst/>
           </a:prstGeom>
           <a:solidFill>
-            <a:srgbClr val="F1F5F9"/>
+            <a:srgbClr val="F3F1FB"/>
           </a:solidFill>
           <a:ln>
             <a:noFill/>
@@ -14424,7 +14352,7 @@
             <a:r>
               <a:rPr sz="1250" b="1">
                 <a:solidFill>
-                  <a:srgbClr val="0B1F3A"/>
+                  <a:srgbClr val="14102B"/>
                 </a:solidFill>
                 <a:latin typeface="Calibri"/>
               </a:rPr>
@@ -14479,7 +14407,7 @@
             <a:r>
               <a:rPr sz="1800" b="1">
                 <a:solidFill>
-                  <a:srgbClr val="14B8A6"/>
+                  <a:srgbClr val="9A3CE0"/>
                 </a:solidFill>
                 <a:latin typeface="Calibri"/>
               </a:rPr>
@@ -14503,7 +14431,7 @@
             <a:avLst/>
           </a:prstGeom>
           <a:solidFill>
-            <a:srgbClr val="F1F5F9"/>
+            <a:srgbClr val="F3F1FB"/>
           </a:solidFill>
           <a:ln>
             <a:noFill/>
@@ -14562,7 +14490,7 @@
             <a:r>
               <a:rPr sz="1250" b="1">
                 <a:solidFill>
-                  <a:srgbClr val="0B1F3A"/>
+                  <a:srgbClr val="14102B"/>
                 </a:solidFill>
                 <a:latin typeface="Calibri"/>
               </a:rPr>
@@ -14617,7 +14545,7 @@
             <a:r>
               <a:rPr sz="1800" b="1">
                 <a:solidFill>
-                  <a:srgbClr val="14B8A6"/>
+                  <a:srgbClr val="9A3CE0"/>
                 </a:solidFill>
                 <a:latin typeface="Calibri"/>
               </a:rPr>
@@ -14641,7 +14569,7 @@
             <a:avLst/>
           </a:prstGeom>
           <a:solidFill>
-            <a:srgbClr val="F1F5F9"/>
+            <a:srgbClr val="F3F1FB"/>
           </a:solidFill>
           <a:ln>
             <a:noFill/>
@@ -14700,7 +14628,7 @@
             <a:r>
               <a:rPr sz="1250" b="1">
                 <a:solidFill>
-                  <a:srgbClr val="0B1F3A"/>
+                  <a:srgbClr val="14102B"/>
                 </a:solidFill>
                 <a:latin typeface="Calibri"/>
               </a:rPr>
@@ -14755,7 +14683,7 @@
             <a:r>
               <a:rPr sz="1800" b="1">
                 <a:solidFill>
-                  <a:srgbClr val="14B8A6"/>
+                  <a:srgbClr val="9A3CE0"/>
                 </a:solidFill>
                 <a:latin typeface="Calibri"/>
               </a:rPr>
@@ -14779,7 +14707,7 @@
             <a:avLst/>
           </a:prstGeom>
           <a:solidFill>
-            <a:srgbClr val="F1F5F9"/>
+            <a:srgbClr val="F3F1FB"/>
           </a:solidFill>
           <a:ln>
             <a:noFill/>
@@ -14838,7 +14766,7 @@
             <a:r>
               <a:rPr sz="1250" b="1">
                 <a:solidFill>
-                  <a:srgbClr val="0B1F3A"/>
+                  <a:srgbClr val="14102B"/>
                 </a:solidFill>
                 <a:latin typeface="Calibri"/>
               </a:rPr>
@@ -14893,7 +14821,7 @@
             <a:r>
               <a:rPr sz="1800" b="1">
                 <a:solidFill>
-                  <a:srgbClr val="14B8A6"/>
+                  <a:srgbClr val="9A3CE0"/>
                 </a:solidFill>
                 <a:latin typeface="Calibri"/>
               </a:rPr>
@@ -14917,7 +14845,7 @@
             <a:avLst/>
           </a:prstGeom>
           <a:solidFill>
-            <a:srgbClr val="F1F5F9"/>
+            <a:srgbClr val="F3F1FB"/>
           </a:solidFill>
           <a:ln>
             <a:noFill/>
@@ -14976,7 +14904,7 @@
             <a:r>
               <a:rPr sz="1250" b="1">
                 <a:solidFill>
-                  <a:srgbClr val="0B1F3A"/>
+                  <a:srgbClr val="14102B"/>
                 </a:solidFill>
                 <a:latin typeface="Calibri"/>
               </a:rPr>
@@ -15031,7 +14959,7 @@
             <a:r>
               <a:rPr sz="1400" b="1">
                 <a:solidFill>
-                  <a:srgbClr val="14B8A6"/>
+                  <a:srgbClr val="9A3CE0"/>
                 </a:solidFill>
                 <a:latin typeface="Calibri"/>
               </a:rPr>
@@ -15055,7 +14983,7 @@
             <a:avLst/>
           </a:prstGeom>
           <a:solidFill>
-            <a:srgbClr val="F1F5F9"/>
+            <a:srgbClr val="F3F1FB"/>
           </a:solidFill>
           <a:ln>
             <a:noFill/>
@@ -15195,7 +15123,7 @@
             <a:avLst/>
           </a:prstGeom>
           <a:solidFill>
-            <a:srgbClr val="14B8A6"/>
+            <a:srgbClr val="9A3CE0"/>
           </a:solidFill>
           <a:ln>
             <a:noFill/>
@@ -15254,7 +15182,7 @@
             <a:r>
               <a:rPr sz="1100" b="1">
                 <a:solidFill>
-                  <a:srgbClr val="14B8A6"/>
+                  <a:srgbClr val="9A3CE0"/>
                 </a:solidFill>
                 <a:latin typeface="Calibri"/>
               </a:rPr>
@@ -15293,7 +15221,7 @@
             <a:r>
               <a:rPr sz="2900" b="1">
                 <a:solidFill>
-                  <a:srgbClr val="0B1F3A"/>
+                  <a:srgbClr val="14102B"/>
                 </a:solidFill>
                 <a:latin typeface="Calibri"/>
               </a:rPr>
@@ -15356,7 +15284,7 @@
             <a:avLst/>
           </a:prstGeom>
           <a:solidFill>
-            <a:srgbClr val="F1F5F9"/>
+            <a:srgbClr val="F3F1FB"/>
           </a:solidFill>
           <a:ln>
             <a:noFill/>
@@ -15400,7 +15328,7 @@
             <a:avLst/>
           </a:prstGeom>
           <a:solidFill>
-            <a:srgbClr val="14B8A6"/>
+            <a:srgbClr val="9A3CE0"/>
           </a:solidFill>
           <a:ln>
             <a:noFill/>
@@ -15459,7 +15387,7 @@
             <a:r>
               <a:rPr sz="1400" b="1">
                 <a:solidFill>
-                  <a:srgbClr val="0B1F3A"/>
+                  <a:srgbClr val="14102B"/>
                 </a:solidFill>
                 <a:latin typeface="Calibri"/>
               </a:rPr>
@@ -15554,7 +15482,7 @@
             <a:avLst/>
           </a:prstGeom>
           <a:solidFill>
-            <a:srgbClr val="F1F5F9"/>
+            <a:srgbClr val="F3F1FB"/>
           </a:solidFill>
           <a:ln>
             <a:noFill/>
@@ -15598,7 +15526,7 @@
             <a:avLst/>
           </a:prstGeom>
           <a:solidFill>
-            <a:srgbClr val="14B8A6"/>
+            <a:srgbClr val="9A3CE0"/>
           </a:solidFill>
           <a:ln>
             <a:noFill/>
@@ -15657,7 +15585,7 @@
             <a:r>
               <a:rPr sz="1400" b="1">
                 <a:solidFill>
-                  <a:srgbClr val="0B1F3A"/>
+                  <a:srgbClr val="14102B"/>
                 </a:solidFill>
                 <a:latin typeface="Calibri"/>
               </a:rPr>
@@ -15752,7 +15680,7 @@
             <a:avLst/>
           </a:prstGeom>
           <a:solidFill>
-            <a:srgbClr val="F1F5F9"/>
+            <a:srgbClr val="F3F1FB"/>
           </a:solidFill>
           <a:ln>
             <a:noFill/>
@@ -15796,7 +15724,7 @@
             <a:avLst/>
           </a:prstGeom>
           <a:solidFill>
-            <a:srgbClr val="14B8A6"/>
+            <a:srgbClr val="9A3CE0"/>
           </a:solidFill>
           <a:ln>
             <a:noFill/>
@@ -15855,7 +15783,7 @@
             <a:r>
               <a:rPr sz="1400" b="1">
                 <a:solidFill>
-                  <a:srgbClr val="0B1F3A"/>
+                  <a:srgbClr val="14102B"/>
                 </a:solidFill>
                 <a:latin typeface="Calibri"/>
               </a:rPr>
@@ -15950,7 +15878,7 @@
             <a:avLst/>
           </a:prstGeom>
           <a:solidFill>
-            <a:srgbClr val="F1F5F9"/>
+            <a:srgbClr val="F3F1FB"/>
           </a:solidFill>
           <a:ln>
             <a:noFill/>
@@ -16090,7 +16018,7 @@
             <a:avLst/>
           </a:prstGeom>
           <a:solidFill>
-            <a:srgbClr val="14B8A6"/>
+            <a:srgbClr val="9A3CE0"/>
           </a:solidFill>
           <a:ln>
             <a:noFill/>
@@ -16149,7 +16077,7 @@
             <a:r>
               <a:rPr sz="1100" b="1">
                 <a:solidFill>
-                  <a:srgbClr val="14B8A6"/>
+                  <a:srgbClr val="9A3CE0"/>
                 </a:solidFill>
                 <a:latin typeface="Calibri"/>
               </a:rPr>
@@ -16188,11 +16116,11 @@
             <a:r>
               <a:rPr sz="2900" b="1">
                 <a:solidFill>
-                  <a:srgbClr val="0B1F3A"/>
-                </a:solidFill>
-                <a:latin typeface="Calibri"/>
-              </a:rPr>
-              <a:t>Todos los canales en una bandeja —  y sabés de dónde vino cada lead</a:t>
+                  <a:srgbClr val="14102B"/>
+                </a:solidFill>
+                <a:latin typeface="Calibri"/>
+              </a:rPr>
+              <a:t>Todos los canales en una bandeja —  y sabes de dónde vino cada lead</a:t>
             </a:r>
           </a:p>
         </p:txBody>
@@ -16212,7 +16140,7 @@
             <a:avLst/>
           </a:prstGeom>
           <a:solidFill>
-            <a:srgbClr val="F1F5F9"/>
+            <a:srgbClr val="F3F1FB"/>
           </a:solidFill>
           <a:ln>
             <a:noFill/>
@@ -16256,7 +16184,7 @@
             <a:avLst/>
           </a:prstGeom>
           <a:solidFill>
-            <a:srgbClr val="2563EB"/>
+            <a:srgbClr val="4F46E5"/>
           </a:solidFill>
           <a:ln>
             <a:noFill/>
@@ -16315,7 +16243,7 @@
             <a:r>
               <a:rPr sz="1400" b="1">
                 <a:solidFill>
-                  <a:srgbClr val="0B1F3A"/>
+                  <a:srgbClr val="14102B"/>
                 </a:solidFill>
                 <a:latin typeface="Calibri"/>
               </a:rPr>
@@ -16410,7 +16338,7 @@
             <a:avLst/>
           </a:prstGeom>
           <a:solidFill>
-            <a:srgbClr val="F1F5F9"/>
+            <a:srgbClr val="F3F1FB"/>
           </a:solidFill>
           <a:ln>
             <a:noFill/>
@@ -16454,7 +16382,7 @@
             <a:avLst/>
           </a:prstGeom>
           <a:solidFill>
-            <a:srgbClr val="2563EB"/>
+            <a:srgbClr val="4F46E5"/>
           </a:solidFill>
           <a:ln>
             <a:noFill/>
@@ -16513,7 +16441,7 @@
             <a:r>
               <a:rPr sz="1400" b="1">
                 <a:solidFill>
-                  <a:srgbClr val="0B1F3A"/>
+                  <a:srgbClr val="14102B"/>
                 </a:solidFill>
                 <a:latin typeface="Calibri"/>
               </a:rPr>
@@ -16572,7 +16500,7 @@
                 </a:solidFill>
                 <a:latin typeface="Calibri"/>
               </a:rPr>
-              <a:t>•  Sabés qué campaña trae pacientes</a:t>
+              <a:t>•  Sabes qué campaña trae pacientes</a:t>
             </a:r>
           </a:p>
         </p:txBody>
@@ -16592,7 +16520,7 @@
             <a:avLst/>
           </a:prstGeom>
           <a:solidFill>
-            <a:srgbClr val="F1F5F9"/>
+            <a:srgbClr val="F3F1FB"/>
           </a:solidFill>
           <a:ln>
             <a:noFill/>
@@ -16636,7 +16564,7 @@
             <a:avLst/>
           </a:prstGeom>
           <a:solidFill>
-            <a:srgbClr val="2563EB"/>
+            <a:srgbClr val="4F46E5"/>
           </a:solidFill>
           <a:ln>
             <a:noFill/>
@@ -16695,7 +16623,7 @@
             <a:r>
               <a:rPr sz="1400" b="1">
                 <a:solidFill>
-                  <a:srgbClr val="0B1F3A"/>
+                  <a:srgbClr val="14102B"/>
                 </a:solidFill>
                 <a:latin typeface="Calibri"/>
               </a:rPr>
@@ -16790,7 +16718,7 @@
             <a:avLst/>
           </a:prstGeom>
           <a:solidFill>
-            <a:srgbClr val="F1F5F9"/>
+            <a:srgbClr val="F3F1FB"/>
           </a:solidFill>
           <a:ln>
             <a:noFill/>
@@ -16930,7 +16858,7 @@
             <a:avLst/>
           </a:prstGeom>
           <a:solidFill>
-            <a:srgbClr val="14B8A6"/>
+            <a:srgbClr val="9A3CE0"/>
           </a:solidFill>
           <a:ln>
             <a:noFill/>
@@ -16989,7 +16917,7 @@
             <a:r>
               <a:rPr sz="1100" b="1">
                 <a:solidFill>
-                  <a:srgbClr val="14B8A6"/>
+                  <a:srgbClr val="9A3CE0"/>
                 </a:solidFill>
                 <a:latin typeface="Calibri"/>
               </a:rPr>
@@ -17028,7 +16956,7 @@
             <a:r>
               <a:rPr sz="2900" b="1">
                 <a:solidFill>
-                  <a:srgbClr val="0B1F3A"/>
+                  <a:srgbClr val="14102B"/>
                 </a:solidFill>
                 <a:latin typeface="Calibri"/>
               </a:rPr>
@@ -17091,7 +17019,7 @@
             <a:avLst/>
           </a:prstGeom>
           <a:solidFill>
-            <a:srgbClr val="F1F5F9"/>
+            <a:srgbClr val="F3F1FB"/>
           </a:solidFill>
           <a:ln>
             <a:noFill/>
@@ -17150,7 +17078,7 @@
             <a:r>
               <a:rPr sz="1250" b="1">
                 <a:solidFill>
-                  <a:srgbClr val="0B1F3A"/>
+                  <a:srgbClr val="14102B"/>
                 </a:solidFill>
                 <a:latin typeface="Calibri"/>
               </a:rPr>
@@ -17205,7 +17133,7 @@
             <a:r>
               <a:rPr sz="1800" b="1">
                 <a:solidFill>
-                  <a:srgbClr val="14B8A6"/>
+                  <a:srgbClr val="9A3CE0"/>
                 </a:solidFill>
                 <a:latin typeface="Calibri"/>
               </a:rPr>
@@ -17229,7 +17157,7 @@
             <a:avLst/>
           </a:prstGeom>
           <a:solidFill>
-            <a:srgbClr val="F1F5F9"/>
+            <a:srgbClr val="F3F1FB"/>
           </a:solidFill>
           <a:ln>
             <a:noFill/>
@@ -17288,7 +17216,7 @@
             <a:r>
               <a:rPr sz="1250" b="1">
                 <a:solidFill>
-                  <a:srgbClr val="0B1F3A"/>
+                  <a:srgbClr val="14102B"/>
                 </a:solidFill>
                 <a:latin typeface="Calibri"/>
               </a:rPr>
@@ -17343,7 +17271,7 @@
             <a:r>
               <a:rPr sz="1800" b="1">
                 <a:solidFill>
-                  <a:srgbClr val="14B8A6"/>
+                  <a:srgbClr val="9A3CE0"/>
                 </a:solidFill>
                 <a:latin typeface="Calibri"/>
               </a:rPr>
@@ -17367,7 +17295,7 @@
             <a:avLst/>
           </a:prstGeom>
           <a:solidFill>
-            <a:srgbClr val="F1F5F9"/>
+            <a:srgbClr val="F3F1FB"/>
           </a:solidFill>
           <a:ln>
             <a:noFill/>
@@ -17426,7 +17354,7 @@
             <a:r>
               <a:rPr sz="1250" b="1">
                 <a:solidFill>
-                  <a:srgbClr val="0B1F3A"/>
+                  <a:srgbClr val="14102B"/>
                 </a:solidFill>
                 <a:latin typeface="Calibri"/>
               </a:rPr>
@@ -17481,7 +17409,7 @@
             <a:r>
               <a:rPr sz="1800" b="1">
                 <a:solidFill>
-                  <a:srgbClr val="14B8A6"/>
+                  <a:srgbClr val="9A3CE0"/>
                 </a:solidFill>
                 <a:latin typeface="Calibri"/>
               </a:rPr>
@@ -17505,7 +17433,7 @@
             <a:avLst/>
           </a:prstGeom>
           <a:solidFill>
-            <a:srgbClr val="F1F5F9"/>
+            <a:srgbClr val="F3F1FB"/>
           </a:solidFill>
           <a:ln>
             <a:noFill/>
@@ -17564,7 +17492,7 @@
             <a:r>
               <a:rPr sz="1250" b="1">
                 <a:solidFill>
-                  <a:srgbClr val="0B1F3A"/>
+                  <a:srgbClr val="14102B"/>
                 </a:solidFill>
                 <a:latin typeface="Calibri"/>
               </a:rPr>
@@ -17619,7 +17547,7 @@
             <a:r>
               <a:rPr sz="1800" b="1">
                 <a:solidFill>
-                  <a:srgbClr val="14B8A6"/>
+                  <a:srgbClr val="9A3CE0"/>
                 </a:solidFill>
                 <a:latin typeface="Calibri"/>
               </a:rPr>
@@ -17643,7 +17571,7 @@
             <a:avLst/>
           </a:prstGeom>
           <a:solidFill>
-            <a:srgbClr val="F1F5F9"/>
+            <a:srgbClr val="F3F1FB"/>
           </a:solidFill>
           <a:ln>
             <a:noFill/>
@@ -17702,7 +17630,7 @@
             <a:r>
               <a:rPr sz="1250" b="1">
                 <a:solidFill>
-                  <a:srgbClr val="0B1F3A"/>
+                  <a:srgbClr val="14102B"/>
                 </a:solidFill>
                 <a:latin typeface="Calibri"/>
               </a:rPr>
@@ -17757,7 +17685,7 @@
             <a:r>
               <a:rPr sz="1800" b="1">
                 <a:solidFill>
-                  <a:srgbClr val="14B8A6"/>
+                  <a:srgbClr val="9A3CE0"/>
                 </a:solidFill>
                 <a:latin typeface="Calibri"/>
               </a:rPr>
@@ -17781,7 +17709,7 @@
             <a:avLst/>
           </a:prstGeom>
           <a:solidFill>
-            <a:srgbClr val="F1F5F9"/>
+            <a:srgbClr val="F3F1FB"/>
           </a:solidFill>
           <a:ln>
             <a:noFill/>
@@ -17840,7 +17768,7 @@
             <a:r>
               <a:rPr sz="1250" b="1">
                 <a:solidFill>
-                  <a:srgbClr val="0B1F3A"/>
+                  <a:srgbClr val="14102B"/>
                 </a:solidFill>
                 <a:latin typeface="Calibri"/>
               </a:rPr>
@@ -17895,7 +17823,7 @@
             <a:r>
               <a:rPr sz="1800" b="1">
                 <a:solidFill>
-                  <a:srgbClr val="14B8A6"/>
+                  <a:srgbClr val="9A3CE0"/>
                 </a:solidFill>
                 <a:latin typeface="Calibri"/>
               </a:rPr>
@@ -17919,7 +17847,7 @@
             <a:avLst/>
           </a:prstGeom>
           <a:solidFill>
-            <a:srgbClr val="F1F5F9"/>
+            <a:srgbClr val="F3F1FB"/>
           </a:solidFill>
           <a:ln>
             <a:noFill/>
@@ -17978,7 +17906,7 @@
             <a:r>
               <a:rPr sz="1250" b="1">
                 <a:solidFill>
-                  <a:srgbClr val="0B1F3A"/>
+                  <a:srgbClr val="14102B"/>
                 </a:solidFill>
                 <a:latin typeface="Calibri"/>
               </a:rPr>
@@ -18037,7 +17965,7 @@
                 </a:solidFill>
                 <a:latin typeface="Calibri"/>
               </a:rPr>
-              <a:t>Los robots mueven al paciente de etapa automáticamente. Vos ves el tablero y sabés qué falta para cada cierre.</a:t>
+              <a:t>Los robots mueven al paciente de etapa automáticamente. Ves el panel y sabes qué falta para cada cierre.</a:t>
             </a:r>
           </a:p>
         </p:txBody>
@@ -18057,7 +17985,7 @@
             <a:avLst/>
           </a:prstGeom>
           <a:solidFill>
-            <a:srgbClr val="F1F5F9"/>
+            <a:srgbClr val="F3F1FB"/>
           </a:solidFill>
           <a:ln>
             <a:noFill/>
@@ -18197,7 +18125,7 @@
             <a:avLst/>
           </a:prstGeom>
           <a:solidFill>
-            <a:srgbClr val="14B8A6"/>
+            <a:srgbClr val="9A3CE0"/>
           </a:solidFill>
           <a:ln>
             <a:noFill/>
@@ -18256,7 +18184,7 @@
             <a:r>
               <a:rPr sz="1100" b="1">
                 <a:solidFill>
-                  <a:srgbClr val="14B8A6"/>
+                  <a:srgbClr val="9A3CE0"/>
                 </a:solidFill>
                 <a:latin typeface="Calibri"/>
               </a:rPr>
@@ -18295,7 +18223,7 @@
             <a:r>
               <a:rPr sz="2900" b="1">
                 <a:solidFill>
-                  <a:srgbClr val="0B1F3A"/>
+                  <a:srgbClr val="14102B"/>
                 </a:solidFill>
                 <a:latin typeface="Calibri"/>
               </a:rPr>
@@ -18358,7 +18286,7 @@
             <a:avLst/>
           </a:prstGeom>
           <a:solidFill>
-            <a:srgbClr val="F1F5F9"/>
+            <a:srgbClr val="F3F1FB"/>
           </a:solidFill>
           <a:ln>
             <a:noFill/>
@@ -18402,7 +18330,7 @@
             <a:avLst/>
           </a:prstGeom>
           <a:solidFill>
-            <a:srgbClr val="14B8A6"/>
+            <a:srgbClr val="9A3CE0"/>
           </a:solidFill>
           <a:ln>
             <a:noFill/>
@@ -18461,7 +18389,7 @@
             <a:r>
               <a:rPr sz="1400" b="1">
                 <a:solidFill>
-                  <a:srgbClr val="0B1F3A"/>
+                  <a:srgbClr val="14102B"/>
                 </a:solidFill>
                 <a:latin typeface="Calibri"/>
               </a:rPr>
@@ -18540,7 +18468,7 @@
             <a:avLst/>
           </a:prstGeom>
           <a:solidFill>
-            <a:srgbClr val="F1F5F9"/>
+            <a:srgbClr val="F3F1FB"/>
           </a:solidFill>
           <a:ln>
             <a:noFill/>
@@ -18584,7 +18512,7 @@
             <a:avLst/>
           </a:prstGeom>
           <a:solidFill>
-            <a:srgbClr val="14B8A6"/>
+            <a:srgbClr val="9A3CE0"/>
           </a:solidFill>
           <a:ln>
             <a:noFill/>
@@ -18643,7 +18571,7 @@
             <a:r>
               <a:rPr sz="1400" b="1">
                 <a:solidFill>
-                  <a:srgbClr val="0B1F3A"/>
+                  <a:srgbClr val="14102B"/>
                 </a:solidFill>
                 <a:latin typeface="Calibri"/>
               </a:rPr>
@@ -18722,7 +18650,7 @@
             <a:avLst/>
           </a:prstGeom>
           <a:solidFill>
-            <a:srgbClr val="F1F5F9"/>
+            <a:srgbClr val="F3F1FB"/>
           </a:solidFill>
           <a:ln>
             <a:noFill/>
@@ -18766,7 +18694,7 @@
             <a:avLst/>
           </a:prstGeom>
           <a:solidFill>
-            <a:srgbClr val="14B8A6"/>
+            <a:srgbClr val="9A3CE0"/>
           </a:solidFill>
           <a:ln>
             <a:noFill/>
@@ -18825,7 +18753,7 @@
             <a:r>
               <a:rPr sz="1400" b="1">
                 <a:solidFill>
-                  <a:srgbClr val="0B1F3A"/>
+                  <a:srgbClr val="14102B"/>
                 </a:solidFill>
                 <a:latin typeface="Calibri"/>
               </a:rPr>
@@ -18904,7 +18832,7 @@
             <a:avLst/>
           </a:prstGeom>
           <a:solidFill>
-            <a:srgbClr val="F1F5F9"/>
+            <a:srgbClr val="F3F1FB"/>
           </a:solidFill>
           <a:ln>
             <a:noFill/>
@@ -18948,7 +18876,7 @@
             <a:avLst/>
           </a:prstGeom>
           <a:solidFill>
-            <a:srgbClr val="14B8A6"/>
+            <a:srgbClr val="9A3CE0"/>
           </a:solidFill>
           <a:ln>
             <a:noFill/>
@@ -19007,7 +18935,7 @@
             <a:r>
               <a:rPr sz="1400" b="1">
                 <a:solidFill>
-                  <a:srgbClr val="0B1F3A"/>
+                  <a:srgbClr val="14102B"/>
                 </a:solidFill>
                 <a:latin typeface="Calibri"/>
               </a:rPr>
@@ -19102,7 +19030,7 @@
             <a:avLst/>
           </a:prstGeom>
           <a:solidFill>
-            <a:srgbClr val="F1F5F9"/>
+            <a:srgbClr val="F3F1FB"/>
           </a:solidFill>
           <a:ln>
             <a:noFill/>
@@ -19146,7 +19074,7 @@
             <a:avLst/>
           </a:prstGeom>
           <a:solidFill>
-            <a:srgbClr val="14B8A6"/>
+            <a:srgbClr val="9A3CE0"/>
           </a:solidFill>
           <a:ln>
             <a:noFill/>
@@ -19205,7 +19133,7 @@
             <a:r>
               <a:rPr sz="1400" b="1">
                 <a:solidFill>
-                  <a:srgbClr val="0B1F3A"/>
+                  <a:srgbClr val="14102B"/>
                 </a:solidFill>
                 <a:latin typeface="Calibri"/>
               </a:rPr>
@@ -19284,7 +19212,7 @@
             <a:avLst/>
           </a:prstGeom>
           <a:solidFill>
-            <a:srgbClr val="F1F5F9"/>
+            <a:srgbClr val="F3F1FB"/>
           </a:solidFill>
           <a:ln>
             <a:noFill/>
@@ -19328,7 +19256,7 @@
             <a:avLst/>
           </a:prstGeom>
           <a:solidFill>
-            <a:srgbClr val="14B8A6"/>
+            <a:srgbClr val="9A3CE0"/>
           </a:solidFill>
           <a:ln>
             <a:noFill/>
@@ -19387,7 +19315,7 @@
             <a:r>
               <a:rPr sz="1400" b="1">
                 <a:solidFill>
-                  <a:srgbClr val="0B1F3A"/>
+                  <a:srgbClr val="14102B"/>
                 </a:solidFill>
                 <a:latin typeface="Calibri"/>
               </a:rPr>
@@ -19466,7 +19394,7 @@
             <a:avLst/>
           </a:prstGeom>
           <a:solidFill>
-            <a:srgbClr val="F1F5F9"/>
+            <a:srgbClr val="F3F1FB"/>
           </a:solidFill>
           <a:ln>
             <a:noFill/>
@@ -19606,7 +19534,7 @@
             <a:avLst/>
           </a:prstGeom>
           <a:solidFill>
-            <a:srgbClr val="14B8A6"/>
+            <a:srgbClr val="9A3CE0"/>
           </a:solidFill>
           <a:ln>
             <a:noFill/>
@@ -19665,7 +19593,7 @@
             <a:r>
               <a:rPr sz="1100" b="1">
                 <a:solidFill>
-                  <a:srgbClr val="14B8A6"/>
+                  <a:srgbClr val="9A3CE0"/>
                 </a:solidFill>
                 <a:latin typeface="Calibri"/>
               </a:rPr>
@@ -19704,7 +19632,7 @@
             <a:r>
               <a:rPr sz="2900" b="1">
                 <a:solidFill>
-                  <a:srgbClr val="0B1F3A"/>
+                  <a:srgbClr val="14102B"/>
                 </a:solidFill>
                 <a:latin typeface="Calibri"/>
               </a:rPr>
@@ -19767,7 +19695,7 @@
             <a:avLst/>
           </a:prstGeom>
           <a:solidFill>
-            <a:srgbClr val="F1F5F9"/>
+            <a:srgbClr val="F3F1FB"/>
           </a:solidFill>
           <a:ln>
             <a:noFill/>
@@ -19811,7 +19739,7 @@
             <a:avLst/>
           </a:prstGeom>
           <a:solidFill>
-            <a:srgbClr val="14B8A6"/>
+            <a:srgbClr val="9A3CE0"/>
           </a:solidFill>
           <a:ln>
             <a:noFill/>
@@ -19870,7 +19798,7 @@
             <a:r>
               <a:rPr sz="1600" b="1">
                 <a:solidFill>
-                  <a:srgbClr val="0B1F3A"/>
+                  <a:srgbClr val="14102B"/>
                 </a:solidFill>
                 <a:latin typeface="Calibri"/>
               </a:rPr>
@@ -19926,7 +19854,7 @@
             <a:avLst/>
           </a:prstGeom>
           <a:solidFill>
-            <a:srgbClr val="F1F5F9"/>
+            <a:srgbClr val="F3F1FB"/>
           </a:solidFill>
           <a:ln>
             <a:noFill/>
@@ -19970,7 +19898,7 @@
             <a:avLst/>
           </a:prstGeom>
           <a:solidFill>
-            <a:srgbClr val="2563EB"/>
+            <a:srgbClr val="4F46E5"/>
           </a:solidFill>
           <a:ln>
             <a:noFill/>
@@ -20029,7 +19957,7 @@
             <a:r>
               <a:rPr sz="1600" b="1">
                 <a:solidFill>
-                  <a:srgbClr val="0B1F3A"/>
+                  <a:srgbClr val="14102B"/>
                 </a:solidFill>
                 <a:latin typeface="Calibri"/>
               </a:rPr>
@@ -20065,7 +19993,7 @@
                 </a:solidFill>
                 <a:latin typeface="Calibri"/>
               </a:rPr>
-              <a:t>Recuperás al paciente y proteges la marca.</a:t>
+              <a:t>Recuperas al paciente y proteges la marca.</a:t>
             </a:r>
           </a:p>
         </p:txBody>
@@ -20100,7 +20028,7 @@
             <a:r>
               <a:rPr sz="1350" b="1">
                 <a:solidFill>
-                  <a:srgbClr val="14B8A6"/>
+                  <a:srgbClr val="9A3CE0"/>
                 </a:solidFill>
                 <a:latin typeface="Calibri"/>
               </a:rPr>
@@ -20124,7 +20052,7 @@
             <a:avLst/>
           </a:prstGeom>
           <a:solidFill>
-            <a:srgbClr val="F1F5F9"/>
+            <a:srgbClr val="F3F1FB"/>
           </a:solidFill>
           <a:ln>
             <a:noFill/>

</xml_diff>

<commit_message>
Add omnia logo to deck (recreated wordmark) on cover and closing
- Generate brand wordmark (assets/omnia-logo.png) via make_logo.py: "omnia"
  in blue→purple→pink gradient + "in business", as a faithful placeholder
  until the official PNG is provided.
- Place it on a white chip over the gradient cover and closing slides.

Co-Authored-By: Claude Opus 4.8 <noreply@anthropic.com>
Claude-Session: https://claude.ai/code/session_01TgN5d424q32UXmoazQaikt
</commit_message>
<xml_diff>
--- a/presentacion/omnia-sistema-clinicas.pptx
+++ b/presentacion/omnia-sistema-clinicas.pptx
@@ -3158,13 +3158,81 @@
       </p:sp>
       <p:sp>
         <p:nvSpPr>
-          <p:cNvPr id="3" name="TextBox 2"/>
-          <p:cNvSpPr txBox="1"/>
-          <p:nvPr/>
-        </p:nvSpPr>
-        <p:spPr>
-          <a:xfrm>
-            <a:off x="914400" y="1828800"/>
+          <p:cNvPr id="3" name="Rounded Rectangle 2"/>
+          <p:cNvSpPr/>
+          <p:nvPr/>
+        </p:nvSpPr>
+        <p:spPr>
+          <a:xfrm>
+            <a:off x="822960" y="640080"/>
+            <a:ext cx="2697480" cy="1234440"/>
+          </a:xfrm>
+          <a:prstGeom prst="roundRect">
+            <a:avLst/>
+          </a:prstGeom>
+          <a:solidFill>
+            <a:srgbClr val="FFFFFF"/>
+          </a:solidFill>
+          <a:ln>
+            <a:noFill/>
+          </a:ln>
+          <a:effectLst/>
+        </p:spPr>
+        <p:style>
+          <a:lnRef idx="1">
+            <a:schemeClr val="accent1"/>
+          </a:lnRef>
+          <a:fillRef idx="3">
+            <a:schemeClr val="accent1"/>
+          </a:fillRef>
+          <a:effectRef idx="2">
+            <a:schemeClr val="accent1"/>
+          </a:effectRef>
+          <a:fontRef idx="minor">
+            <a:schemeClr val="lt1"/>
+          </a:fontRef>
+        </p:style>
+        <p:txBody>
+          <a:bodyPr rtlCol="0" anchor="ctr"/>
+          <a:lstStyle/>
+          <a:p>
+            <a:pPr algn="ctr"/>
+          </a:p>
+        </p:txBody>
+      </p:sp>
+      <p:pic>
+        <p:nvPicPr>
+          <p:cNvPr id="4" name="Picture 3" descr="omnia-logo.png"/>
+          <p:cNvPicPr>
+            <a:picLocks noChangeAspect="1"/>
+          </p:cNvPicPr>
+          <p:nvPr/>
+        </p:nvPicPr>
+        <p:blipFill>
+          <a:blip r:embed="rId2"/>
+          <a:stretch>
+            <a:fillRect/>
+          </a:stretch>
+        </p:blipFill>
+        <p:spPr>
+          <a:xfrm>
+            <a:off x="1078992" y="896112"/>
+            <a:ext cx="2011298" cy="731520"/>
+          </a:xfrm>
+          <a:prstGeom prst="rect">
+            <a:avLst/>
+          </a:prstGeom>
+        </p:spPr>
+      </p:pic>
+      <p:sp>
+        <p:nvSpPr>
+          <p:cNvPr id="5" name="TextBox 4"/>
+          <p:cNvSpPr txBox="1"/>
+          <p:nvPr/>
+        </p:nvSpPr>
+        <p:spPr>
+          <a:xfrm>
+            <a:off x="914400" y="2514600"/>
             <a:ext cx="10515600" cy="457200"/>
           </a:xfrm>
           <a:prstGeom prst="rect">
@@ -3197,14 +3265,14 @@
       </p:sp>
       <p:sp>
         <p:nvSpPr>
-          <p:cNvPr id="4" name="TextBox 3"/>
-          <p:cNvSpPr txBox="1"/>
-          <p:nvPr/>
-        </p:nvSpPr>
-        <p:spPr>
-          <a:xfrm>
-            <a:off x="914400" y="2194560"/>
-            <a:ext cx="10515600" cy="1097280"/>
+          <p:cNvPr id="6" name="TextBox 5"/>
+          <p:cNvSpPr txBox="1"/>
+          <p:nvPr/>
+        </p:nvSpPr>
+        <p:spPr>
+          <a:xfrm>
+            <a:off x="914400" y="2971800"/>
+            <a:ext cx="10515600" cy="1371600"/>
           </a:xfrm>
           <a:prstGeom prst="rect">
             <a:avLst/>
@@ -3223,26 +3291,26 @@
               </a:spcAft>
             </a:pPr>
             <a:r>
-              <a:rPr sz="5400" b="1">
+              <a:rPr sz="3400" b="1">
                 <a:solidFill>
                   <a:srgbClr val="FFFFFF"/>
                 </a:solidFill>
                 <a:latin typeface="Calibri"/>
               </a:rPr>
-              <a:t>omnia</a:t>
-            </a:r>
-          </a:p>
-        </p:txBody>
-      </p:sp>
-      <p:sp>
-        <p:nvSpPr>
-          <p:cNvPr id="5" name="TextBox 4"/>
-          <p:cNvSpPr txBox="1"/>
-          <p:nvPr/>
-        </p:nvSpPr>
-        <p:spPr>
-          <a:xfrm>
-            <a:off x="914400" y="3246120"/>
+              <a:t>Sistema Ads + CRM para Clínicas</a:t>
+            </a:r>
+          </a:p>
+        </p:txBody>
+      </p:sp>
+      <p:sp>
+        <p:nvSpPr>
+          <p:cNvPr id="7" name="TextBox 6"/>
+          <p:cNvSpPr txBox="1"/>
+          <p:nvPr/>
+        </p:nvSpPr>
+        <p:spPr>
+          <a:xfrm>
+            <a:off x="914400" y="4389120"/>
             <a:ext cx="10515600" cy="457200"/>
           </a:xfrm>
           <a:prstGeom prst="rect">
@@ -3262,85 +3330,7 @@
               </a:spcAft>
             </a:pPr>
             <a:r>
-              <a:rPr sz="1800" b="0">
-                <a:solidFill>
-                  <a:srgbClr val="FFFFFF"/>
-                </a:solidFill>
-                <a:latin typeface="Calibri"/>
-              </a:rPr>
-              <a:t>in business</a:t>
-            </a:r>
-          </a:p>
-        </p:txBody>
-      </p:sp>
-      <p:sp>
-        <p:nvSpPr>
-          <p:cNvPr id="6" name="TextBox 5"/>
-          <p:cNvSpPr txBox="1"/>
-          <p:nvPr/>
-        </p:nvSpPr>
-        <p:spPr>
-          <a:xfrm>
-            <a:off x="914400" y="3749039"/>
-            <a:ext cx="10515600" cy="822960"/>
-          </a:xfrm>
-          <a:prstGeom prst="rect">
-            <a:avLst/>
-          </a:prstGeom>
-          <a:noFill/>
-        </p:spPr>
-        <p:txBody>
-          <a:bodyPr wrap="square" anchor="t">
-            <a:spAutoFit/>
-          </a:bodyPr>
-          <a:lstStyle/>
-          <a:p>
-            <a:pPr algn="l">
-              <a:spcAft>
-                <a:spcPts val="400"/>
-              </a:spcAft>
-            </a:pPr>
-            <a:r>
-              <a:rPr sz="2200" b="0">
-                <a:solidFill>
-                  <a:srgbClr val="FFFFFF"/>
-                </a:solidFill>
-                <a:latin typeface="Calibri"/>
-              </a:rPr>
-              <a:t>Sistema Ads + CRM para Clínicas</a:t>
-            </a:r>
-          </a:p>
-        </p:txBody>
-      </p:sp>
-      <p:sp>
-        <p:nvSpPr>
-          <p:cNvPr id="7" name="TextBox 6"/>
-          <p:cNvSpPr txBox="1"/>
-          <p:nvPr/>
-        </p:nvSpPr>
-        <p:spPr>
-          <a:xfrm>
-            <a:off x="914400" y="4572000"/>
-            <a:ext cx="10515600" cy="457200"/>
-          </a:xfrm>
-          <a:prstGeom prst="rect">
-            <a:avLst/>
-          </a:prstGeom>
-          <a:noFill/>
-        </p:spPr>
-        <p:txBody>
-          <a:bodyPr wrap="square" anchor="t">
-            <a:spAutoFit/>
-          </a:bodyPr>
-          <a:lstStyle/>
-          <a:p>
-            <a:pPr algn="l">
-              <a:spcAft>
-                <a:spcPts val="400"/>
-              </a:spcAft>
-            </a:pPr>
-            <a:r>
-              <a:rPr sz="1500" b="0">
+              <a:rPr sz="1600" b="0">
                 <a:solidFill>
                   <a:srgbClr val="FFFFFF"/>
                 </a:solidFill>
@@ -11532,7 +11522,75 @@
       </p:sp>
       <p:sp>
         <p:nvSpPr>
-          <p:cNvPr id="3" name="TextBox 2"/>
+          <p:cNvPr id="3" name="Rounded Rectangle 2"/>
+          <p:cNvSpPr/>
+          <p:nvPr/>
+        </p:nvSpPr>
+        <p:spPr>
+          <a:xfrm>
+            <a:off x="822960" y="548640"/>
+            <a:ext cx="2286000" cy="1024128"/>
+          </a:xfrm>
+          <a:prstGeom prst="roundRect">
+            <a:avLst/>
+          </a:prstGeom>
+          <a:solidFill>
+            <a:srgbClr val="FFFFFF"/>
+          </a:solidFill>
+          <a:ln>
+            <a:noFill/>
+          </a:ln>
+          <a:effectLst/>
+        </p:spPr>
+        <p:style>
+          <a:lnRef idx="1">
+            <a:schemeClr val="accent1"/>
+          </a:lnRef>
+          <a:fillRef idx="3">
+            <a:schemeClr val="accent1"/>
+          </a:fillRef>
+          <a:effectRef idx="2">
+            <a:schemeClr val="accent1"/>
+          </a:effectRef>
+          <a:fontRef idx="minor">
+            <a:schemeClr val="lt1"/>
+          </a:fontRef>
+        </p:style>
+        <p:txBody>
+          <a:bodyPr rtlCol="0" anchor="ctr"/>
+          <a:lstStyle/>
+          <a:p>
+            <a:pPr algn="ctr"/>
+          </a:p>
+        </p:txBody>
+      </p:sp>
+      <p:pic>
+        <p:nvPicPr>
+          <p:cNvPr id="4" name="Picture 3" descr="omnia-logo.png"/>
+          <p:cNvPicPr>
+            <a:picLocks noChangeAspect="1"/>
+          </p:cNvPicPr>
+          <p:nvPr/>
+        </p:nvPicPr>
+        <p:blipFill>
+          <a:blip r:embed="rId2"/>
+          <a:stretch>
+            <a:fillRect/>
+          </a:stretch>
+        </p:blipFill>
+        <p:spPr>
+          <a:xfrm>
+            <a:off x="1024128" y="758952"/>
+            <a:ext cx="1659321" cy="603504"/>
+          </a:xfrm>
+          <a:prstGeom prst="rect">
+            <a:avLst/>
+          </a:prstGeom>
+        </p:spPr>
+      </p:pic>
+      <p:sp>
+        <p:nvSpPr>
+          <p:cNvPr id="5" name="TextBox 4"/>
           <p:cNvSpPr txBox="1"/>
           <p:nvPr/>
         </p:nvSpPr>
@@ -11571,7 +11629,7 @@
       </p:sp>
       <p:sp>
         <p:nvSpPr>
-          <p:cNvPr id="4" name="TextBox 3"/>
+          <p:cNvPr id="6" name="TextBox 5"/>
           <p:cNvSpPr txBox="1"/>
           <p:nvPr/>
         </p:nvSpPr>
@@ -11626,7 +11684,7 @@
       </p:sp>
       <p:sp>
         <p:nvSpPr>
-          <p:cNvPr id="5" name="TextBox 4"/>
+          <p:cNvPr id="7" name="TextBox 6"/>
           <p:cNvSpPr txBox="1"/>
           <p:nvPr/>
         </p:nvSpPr>
@@ -11697,7 +11755,7 @@
       </p:sp>
       <p:sp>
         <p:nvSpPr>
-          <p:cNvPr id="6" name="TextBox 5"/>
+          <p:cNvPr id="8" name="TextBox 7"/>
           <p:cNvSpPr txBox="1"/>
           <p:nvPr/>
         </p:nvSpPr>

</xml_diff>

<commit_message>
Deck v9: AI tokens — volume or unlimited (127€/mes) option
Tokens de IA row now shows both models: por volumen (€28–€74) or plan
ilimitado 127 €/mes, with a note that unlimited suits clinics with high
lead traffic.

Co-Authored-By: Claude Opus 4.8 <noreply@anthropic.com>
Claude-Session: https://claude.ai/code/session_01TgN5d424q32UXmoazQaikt
</commit_message>
<xml_diff>
--- a/presentacion/omnia-sistema-clinicas.pptx
+++ b/presentacion/omnia-sistema-clinicas.pptx
@@ -10870,7 +10870,7 @@
                 </a:solidFill>
                 <a:latin typeface="Calibri"/>
               </a:rPr>
-              <a:t>Por volumen de mensajes</a:t>
+              <a:t>Por volumen  ·  o ilimitado *</a:t>
             </a:r>
           </a:p>
         </p:txBody>
@@ -10909,7 +10909,7 @@
                 </a:solidFill>
                 <a:latin typeface="Calibri"/>
               </a:rPr>
-              <a:t>€28 – €74</a:t>
+              <a:t>€28–€74  ·  €127/mes *</a:t>
             </a:r>
           </a:p>
         </p:txBody>
@@ -11100,7 +11100,7 @@
         <p:spPr>
           <a:xfrm>
             <a:off x="502920" y="4910328"/>
-            <a:ext cx="11155680" cy="603504"/>
+            <a:ext cx="11155680" cy="896112"/>
           </a:xfrm>
           <a:prstGeom prst="roundRect">
             <a:avLst/>
@@ -11143,8 +11143,8 @@
         </p:nvSpPr>
         <p:spPr>
           <a:xfrm>
-            <a:off x="713232" y="4965192"/>
-            <a:ext cx="10698480" cy="502920"/>
+            <a:off x="713232" y="4992624"/>
+            <a:ext cx="10698480" cy="749808"/>
           </a:xfrm>
           <a:prstGeom prst="rect">
             <a:avLst/>
@@ -11159,7 +11159,7 @@
           <a:p>
             <a:pPr algn="l">
               <a:spcAft>
-                <a:spcPts val="0"/>
+                <a:spcPts val="300"/>
               </a:spcAft>
             </a:pPr>
             <a:r>
@@ -11178,7 +11178,23 @@
                 </a:solidFill>
                 <a:latin typeface="Calibri"/>
               </a:rPr>
-              <a:t>Son pagos directos a los proveedores según el volumen real; en el discovery técnico afinamos las cifras según los canales que se activen.  *Cifras en € (IVA no incluido).</a:t>
+              <a:t>Son pagos directos a los proveedores según el volumen real; en el discovery afinamos las cifras.</a:t>
+            </a:r>
+          </a:p>
+          <a:p>
+            <a:pPr algn="l">
+              <a:spcAft>
+                <a:spcPts val="300"/>
+              </a:spcAft>
+            </a:pPr>
+            <a:r>
+              <a:rPr sz="1000" b="0">
+                <a:solidFill>
+                  <a:srgbClr val="64748B"/>
+                </a:solidFill>
+                <a:latin typeface="Calibri"/>
+              </a:rPr>
+              <a:t>* Tokens de IA: por volumen (€28–€74) o plan ILIMITADO 127 €/mes —recomendado para clínicas con alto tráfico de leads.   Cifras en € (IVA no incluido).</a:t>
             </a:r>
           </a:p>
         </p:txBody>

</xml_diff>